<commit_message>
updates for rebuttal letter
</commit_message>
<xml_diff>
--- a/img/task.pptx
+++ b/img/task.pptx
@@ -6,7 +6,9 @@
   </p:sldMasterIdLst>
   <p:sldIdLst>
     <p:sldId id="257" r:id="rId2"/>
-    <p:sldId id="256" r:id="rId3"/>
+    <p:sldId id="259" r:id="rId3"/>
+    <p:sldId id="258" r:id="rId4"/>
+    <p:sldId id="256" r:id="rId5"/>
   </p:sldIdLst>
   <p:sldSz cx="16200438" cy="4319588"/>
   <p:notesSz cx="6858000" cy="9144000"/>
@@ -116,7 +118,7 @@
 <file path=ppt/revisionInfo.xml><?xml version="1.0" encoding="utf-8"?>
 <p1510:revInfo xmlns:a="http://schemas.openxmlformats.org/drawingml/2006/main" xmlns:r="http://schemas.openxmlformats.org/officeDocument/2006/relationships" xmlns:p1510="http://schemas.microsoft.com/office/powerpoint/2015/10/main">
   <p1510:revLst>
-    <p1510:client id="{B6D57924-B848-2742-8D38-F6230294B7DC}" v="29" dt="2025-08-16T07:14:44.337"/>
+    <p1510:client id="{93D1AB52-404D-6F4A-8978-031F45E46BAB}" v="20" dt="2026-03-30T14:11:40.548"/>
   </p1510:revLst>
 </p1510:revInfo>
 </file>
@@ -126,654 +128,382 @@
   <pc:docChgLst>
     <pc:chgData name="Björn Meder HMU Potsdam" userId="d258dbf6-ab6a-4282-851d-9abdcd54331d" providerId="ADAL" clId="{4DFD6B1A-A511-587B-86A6-0ACC1CABEBE3}"/>
     <pc:docChg chg="undo custSel addSld modSld sldOrd">
-      <pc:chgData name="Björn Meder HMU Potsdam" userId="d258dbf6-ab6a-4282-851d-9abdcd54331d" providerId="ADAL" clId="{4DFD6B1A-A511-587B-86A6-0ACC1CABEBE3}" dt="2025-08-16T07:15:11.444" v="216" actId="20578"/>
+      <pc:chgData name="Björn Meder HMU Potsdam" userId="d258dbf6-ab6a-4282-851d-9abdcd54331d" providerId="ADAL" clId="{4DFD6B1A-A511-587B-86A6-0ACC1CABEBE3}" dt="2026-03-30T14:11:40.548" v="435"/>
       <pc:docMkLst>
         <pc:docMk/>
       </pc:docMkLst>
-      <pc:sldChg chg="addSp delSp modSp add mod ord">
-        <pc:chgData name="Björn Meder HMU Potsdam" userId="d258dbf6-ab6a-4282-851d-9abdcd54331d" providerId="ADAL" clId="{4DFD6B1A-A511-587B-86A6-0ACC1CABEBE3}" dt="2025-08-16T07:15:11.444" v="216" actId="20578"/>
+      <pc:sldChg chg="addSp mod">
+        <pc:chgData name="Björn Meder HMU Potsdam" userId="d258dbf6-ab6a-4282-851d-9abdcd54331d" providerId="ADAL" clId="{4DFD6B1A-A511-587B-86A6-0ACC1CABEBE3}" dt="2026-03-30T14:04:02.513" v="217" actId="22"/>
+        <pc:sldMkLst>
+          <pc:docMk/>
+          <pc:sldMk cId="1845256045" sldId="256"/>
+        </pc:sldMkLst>
+        <pc:spChg chg="add">
+          <ac:chgData name="Björn Meder HMU Potsdam" userId="d258dbf6-ab6a-4282-851d-9abdcd54331d" providerId="ADAL" clId="{4DFD6B1A-A511-587B-86A6-0ACC1CABEBE3}" dt="2026-03-30T14:04:02.513" v="217" actId="22"/>
+          <ac:spMkLst>
+            <pc:docMk/>
+            <pc:sldMk cId="1845256045" sldId="256"/>
+            <ac:spMk id="3" creationId="{DFD685BF-4FD3-9357-7EEE-941C1AD4203B}"/>
+          </ac:spMkLst>
+        </pc:spChg>
+      </pc:sldChg>
+      <pc:sldChg chg="addSp delSp modSp mod">
+        <pc:chgData name="Björn Meder HMU Potsdam" userId="d258dbf6-ab6a-4282-851d-9abdcd54331d" providerId="ADAL" clId="{4DFD6B1A-A511-587B-86A6-0ACC1CABEBE3}" dt="2026-03-30T14:11:40.548" v="435"/>
         <pc:sldMkLst>
           <pc:docMk/>
           <pc:sldMk cId="34156375" sldId="257"/>
         </pc:sldMkLst>
         <pc:spChg chg="add mod">
-          <ac:chgData name="Björn Meder HMU Potsdam" userId="d258dbf6-ab6a-4282-851d-9abdcd54331d" providerId="ADAL" clId="{4DFD6B1A-A511-587B-86A6-0ACC1CABEBE3}" dt="2025-08-16T07:06:49.193" v="75" actId="1037"/>
+          <ac:chgData name="Björn Meder HMU Potsdam" userId="d258dbf6-ab6a-4282-851d-9abdcd54331d" providerId="ADAL" clId="{4DFD6B1A-A511-587B-86A6-0ACC1CABEBE3}" dt="2026-03-30T14:06:38.414" v="291"/>
           <ac:spMkLst>
             <pc:docMk/>
             <pc:sldMk cId="34156375" sldId="257"/>
-            <ac:spMk id="38" creationId="{448CD114-3C19-C02E-BA6B-DD5CD0D288FC}"/>
+            <ac:spMk id="2" creationId="{B10940F8-704A-4754-AF59-520F1805EA83}"/>
           </ac:spMkLst>
         </pc:spChg>
         <pc:spChg chg="add mod">
-          <ac:chgData name="Björn Meder HMU Potsdam" userId="d258dbf6-ab6a-4282-851d-9abdcd54331d" providerId="ADAL" clId="{4DFD6B1A-A511-587B-86A6-0ACC1CABEBE3}" dt="2025-08-16T07:12:54.556" v="202" actId="1036"/>
+          <ac:chgData name="Björn Meder HMU Potsdam" userId="d258dbf6-ab6a-4282-851d-9abdcd54331d" providerId="ADAL" clId="{4DFD6B1A-A511-587B-86A6-0ACC1CABEBE3}" dt="2026-03-30T14:06:38.414" v="291"/>
           <ac:spMkLst>
             <pc:docMk/>
             <pc:sldMk cId="34156375" sldId="257"/>
-            <ac:spMk id="39" creationId="{70AEBB63-8371-464C-88DF-09CD8F6461BB}"/>
+            <ac:spMk id="3" creationId="{625D3306-7D34-E403-EFA6-1FB7DB752B8E}"/>
           </ac:spMkLst>
         </pc:spChg>
         <pc:spChg chg="add mod">
-          <ac:chgData name="Björn Meder HMU Potsdam" userId="d258dbf6-ab6a-4282-851d-9abdcd54331d" providerId="ADAL" clId="{4DFD6B1A-A511-587B-86A6-0ACC1CABEBE3}" dt="2025-08-16T07:12:54.556" v="202" actId="1036"/>
+          <ac:chgData name="Björn Meder HMU Potsdam" userId="d258dbf6-ab6a-4282-851d-9abdcd54331d" providerId="ADAL" clId="{4DFD6B1A-A511-587B-86A6-0ACC1CABEBE3}" dt="2026-03-30T14:06:38.414" v="291"/>
           <ac:spMkLst>
             <pc:docMk/>
             <pc:sldMk cId="34156375" sldId="257"/>
-            <ac:spMk id="40" creationId="{A9ADF8AA-678C-83A0-EAC3-BD2B4D45577A}"/>
+            <ac:spMk id="4" creationId="{31AC0FE6-48D8-5954-A310-8726D0B3EA05}"/>
           </ac:spMkLst>
         </pc:spChg>
         <pc:spChg chg="add mod">
-          <ac:chgData name="Björn Meder HMU Potsdam" userId="d258dbf6-ab6a-4282-851d-9abdcd54331d" providerId="ADAL" clId="{4DFD6B1A-A511-587B-86A6-0ACC1CABEBE3}" dt="2025-08-16T07:12:50.373" v="200" actId="554"/>
+          <ac:chgData name="Björn Meder HMU Potsdam" userId="d258dbf6-ab6a-4282-851d-9abdcd54331d" providerId="ADAL" clId="{4DFD6B1A-A511-587B-86A6-0ACC1CABEBE3}" dt="2026-03-30T14:06:38.414" v="291"/>
           <ac:spMkLst>
             <pc:docMk/>
             <pc:sldMk cId="34156375" sldId="257"/>
-            <ac:spMk id="41" creationId="{61D13226-896A-A190-5957-A0CBFA31C357}"/>
+            <ac:spMk id="5" creationId="{241EDC92-CAFC-6B38-71D4-950F04E1B074}"/>
           </ac:spMkLst>
         </pc:spChg>
         <pc:spChg chg="add mod">
-          <ac:chgData name="Björn Meder HMU Potsdam" userId="d258dbf6-ab6a-4282-851d-9abdcd54331d" providerId="ADAL" clId="{4DFD6B1A-A511-587B-86A6-0ACC1CABEBE3}" dt="2025-08-16T07:12:50.373" v="200" actId="554"/>
+          <ac:chgData name="Björn Meder HMU Potsdam" userId="d258dbf6-ab6a-4282-851d-9abdcd54331d" providerId="ADAL" clId="{4DFD6B1A-A511-587B-86A6-0ACC1CABEBE3}" dt="2026-03-30T14:06:38.414" v="291"/>
           <ac:spMkLst>
             <pc:docMk/>
             <pc:sldMk cId="34156375" sldId="257"/>
-            <ac:spMk id="42" creationId="{760CF696-3888-E86C-81FD-F695DFE89A32}"/>
+            <ac:spMk id="6" creationId="{B9E906C4-CDFA-510D-72FF-DFEA4808DACA}"/>
           </ac:spMkLst>
         </pc:spChg>
         <pc:spChg chg="add mod">
-          <ac:chgData name="Björn Meder HMU Potsdam" userId="d258dbf6-ab6a-4282-851d-9abdcd54331d" providerId="ADAL" clId="{4DFD6B1A-A511-587B-86A6-0ACC1CABEBE3}" dt="2025-08-16T07:12:47.099" v="199" actId="554"/>
+          <ac:chgData name="Björn Meder HMU Potsdam" userId="d258dbf6-ab6a-4282-851d-9abdcd54331d" providerId="ADAL" clId="{4DFD6B1A-A511-587B-86A6-0ACC1CABEBE3}" dt="2026-03-30T14:06:38.414" v="291"/>
           <ac:spMkLst>
             <pc:docMk/>
             <pc:sldMk cId="34156375" sldId="257"/>
-            <ac:spMk id="43" creationId="{DDA2092D-2AD1-1ABE-62A0-837A0E74BDFA}"/>
+            <ac:spMk id="7" creationId="{B7ECF44F-561B-9BC9-A9C1-CF10498DAF3D}"/>
           </ac:spMkLst>
         </pc:spChg>
         <pc:spChg chg="add mod">
-          <ac:chgData name="Björn Meder HMU Potsdam" userId="d258dbf6-ab6a-4282-851d-9abdcd54331d" providerId="ADAL" clId="{4DFD6B1A-A511-587B-86A6-0ACC1CABEBE3}" dt="2025-08-16T07:12:47.099" v="199" actId="554"/>
+          <ac:chgData name="Björn Meder HMU Potsdam" userId="d258dbf6-ab6a-4282-851d-9abdcd54331d" providerId="ADAL" clId="{4DFD6B1A-A511-587B-86A6-0ACC1CABEBE3}" dt="2026-03-30T14:06:38.414" v="291"/>
           <ac:spMkLst>
             <pc:docMk/>
             <pc:sldMk cId="34156375" sldId="257"/>
-            <ac:spMk id="44" creationId="{F323E07B-5A06-F267-8220-0390F1D57091}"/>
+            <ac:spMk id="8" creationId="{145AF773-10F1-FCA9-29B9-9A276A8166E3}"/>
           </ac:spMkLst>
         </pc:spChg>
         <pc:spChg chg="add mod">
-          <ac:chgData name="Björn Meder HMU Potsdam" userId="d258dbf6-ab6a-4282-851d-9abdcd54331d" providerId="ADAL" clId="{4DFD6B1A-A511-587B-86A6-0ACC1CABEBE3}" dt="2025-08-16T07:12:40.493" v="198" actId="1036"/>
+          <ac:chgData name="Björn Meder HMU Potsdam" userId="d258dbf6-ab6a-4282-851d-9abdcd54331d" providerId="ADAL" clId="{4DFD6B1A-A511-587B-86A6-0ACC1CABEBE3}" dt="2026-03-30T14:06:38.414" v="291"/>
           <ac:spMkLst>
             <pc:docMk/>
             <pc:sldMk cId="34156375" sldId="257"/>
-            <ac:spMk id="45" creationId="{98F2BC21-1865-99FF-0648-5627C4C27389}"/>
+            <ac:spMk id="9" creationId="{E39565E1-178D-C5BC-88BA-40A981E4AD0C}"/>
           </ac:spMkLst>
         </pc:spChg>
         <pc:spChg chg="add mod">
-          <ac:chgData name="Björn Meder HMU Potsdam" userId="d258dbf6-ab6a-4282-851d-9abdcd54331d" providerId="ADAL" clId="{4DFD6B1A-A511-587B-86A6-0ACC1CABEBE3}" dt="2025-08-16T07:12:40.493" v="198" actId="1036"/>
+          <ac:chgData name="Björn Meder HMU Potsdam" userId="d258dbf6-ab6a-4282-851d-9abdcd54331d" providerId="ADAL" clId="{4DFD6B1A-A511-587B-86A6-0ACC1CABEBE3}" dt="2026-03-30T14:06:50.152" v="293"/>
           <ac:spMkLst>
             <pc:docMk/>
             <pc:sldMk cId="34156375" sldId="257"/>
-            <ac:spMk id="46" creationId="{9F58EAA9-DAFB-098A-5368-C11F71E605C2}"/>
+            <ac:spMk id="10" creationId="{7A0F9339-2E17-CA94-8BAC-4C8559FD84DD}"/>
           </ac:spMkLst>
         </pc:spChg>
         <pc:spChg chg="add mod">
-          <ac:chgData name="Björn Meder HMU Potsdam" userId="d258dbf6-ab6a-4282-851d-9abdcd54331d" providerId="ADAL" clId="{4DFD6B1A-A511-587B-86A6-0ACC1CABEBE3}" dt="2025-08-16T07:12:40.493" v="198" actId="1036"/>
+          <ac:chgData name="Björn Meder HMU Potsdam" userId="d258dbf6-ab6a-4282-851d-9abdcd54331d" providerId="ADAL" clId="{4DFD6B1A-A511-587B-86A6-0ACC1CABEBE3}" dt="2026-03-30T14:06:50.152" v="293"/>
           <ac:spMkLst>
             <pc:docMk/>
             <pc:sldMk cId="34156375" sldId="257"/>
-            <ac:spMk id="47" creationId="{7C3862DE-1F5F-3CB4-07A4-A2A0AC47CD6A}"/>
+            <ac:spMk id="11" creationId="{E4260463-B06A-C9DA-E409-ECFFAACD844D}"/>
           </ac:spMkLst>
         </pc:spChg>
         <pc:spChg chg="add mod">
-          <ac:chgData name="Björn Meder HMU Potsdam" userId="d258dbf6-ab6a-4282-851d-9abdcd54331d" providerId="ADAL" clId="{4DFD6B1A-A511-587B-86A6-0ACC1CABEBE3}" dt="2025-08-16T07:12:40.493" v="198" actId="1036"/>
+          <ac:chgData name="Björn Meder HMU Potsdam" userId="d258dbf6-ab6a-4282-851d-9abdcd54331d" providerId="ADAL" clId="{4DFD6B1A-A511-587B-86A6-0ACC1CABEBE3}" dt="2026-03-30T14:06:50.152" v="293"/>
           <ac:spMkLst>
             <pc:docMk/>
             <pc:sldMk cId="34156375" sldId="257"/>
-            <ac:spMk id="48" creationId="{CF59F1C9-120F-B885-8620-D6B2621134D8}"/>
+            <ac:spMk id="12" creationId="{41B0EEBE-A745-2353-1F94-18EAFABDE46A}"/>
           </ac:spMkLst>
         </pc:spChg>
         <pc:spChg chg="add mod">
-          <ac:chgData name="Björn Meder HMU Potsdam" userId="d258dbf6-ab6a-4282-851d-9abdcd54331d" providerId="ADAL" clId="{4DFD6B1A-A511-587B-86A6-0ACC1CABEBE3}" dt="2025-08-16T07:14:05.420" v="211" actId="554"/>
+          <ac:chgData name="Björn Meder HMU Potsdam" userId="d258dbf6-ab6a-4282-851d-9abdcd54331d" providerId="ADAL" clId="{4DFD6B1A-A511-587B-86A6-0ACC1CABEBE3}" dt="2026-03-30T14:06:50.152" v="293"/>
           <ac:spMkLst>
             <pc:docMk/>
             <pc:sldMk cId="34156375" sldId="257"/>
-            <ac:spMk id="49" creationId="{9B8966E5-28BF-258F-CA2E-93BA17BD83D8}"/>
+            <ac:spMk id="13" creationId="{EF77A9EF-A089-7C53-B283-06987BA26505}"/>
           </ac:spMkLst>
         </pc:spChg>
         <pc:spChg chg="add mod">
-          <ac:chgData name="Björn Meder HMU Potsdam" userId="d258dbf6-ab6a-4282-851d-9abdcd54331d" providerId="ADAL" clId="{4DFD6B1A-A511-587B-86A6-0ACC1CABEBE3}" dt="2025-08-16T07:14:05.420" v="211" actId="554"/>
+          <ac:chgData name="Björn Meder HMU Potsdam" userId="d258dbf6-ab6a-4282-851d-9abdcd54331d" providerId="ADAL" clId="{4DFD6B1A-A511-587B-86A6-0ACC1CABEBE3}" dt="2026-03-30T14:06:50.152" v="293"/>
           <ac:spMkLst>
             <pc:docMk/>
             <pc:sldMk cId="34156375" sldId="257"/>
-            <ac:spMk id="50" creationId="{76AA6E67-C047-6B9E-034C-90BA401825AA}"/>
+            <ac:spMk id="14" creationId="{5A3E81BD-7E1E-D8A6-9477-78E3AECDEC97}"/>
           </ac:spMkLst>
         </pc:spChg>
         <pc:spChg chg="add mod">
-          <ac:chgData name="Björn Meder HMU Potsdam" userId="d258dbf6-ab6a-4282-851d-9abdcd54331d" providerId="ADAL" clId="{4DFD6B1A-A511-587B-86A6-0ACC1CABEBE3}" dt="2025-08-16T07:14:05.420" v="211" actId="554"/>
+          <ac:chgData name="Björn Meder HMU Potsdam" userId="d258dbf6-ab6a-4282-851d-9abdcd54331d" providerId="ADAL" clId="{4DFD6B1A-A511-587B-86A6-0ACC1CABEBE3}" dt="2026-03-30T14:06:50.152" v="293"/>
           <ac:spMkLst>
             <pc:docMk/>
             <pc:sldMk cId="34156375" sldId="257"/>
-            <ac:spMk id="51" creationId="{B14A9CC0-2D13-27CF-CD9C-437FE6EBD294}"/>
+            <ac:spMk id="15" creationId="{06CFABE1-B30D-63A4-31EE-FE0B9E0A9347}"/>
           </ac:spMkLst>
         </pc:spChg>
-        <pc:spChg chg="add del mod">
-          <ac:chgData name="Björn Meder HMU Potsdam" userId="d258dbf6-ab6a-4282-851d-9abdcd54331d" providerId="ADAL" clId="{4DFD6B1A-A511-587B-86A6-0ACC1CABEBE3}" dt="2025-08-16T07:12:22.808" v="194" actId="478"/>
+        <pc:spChg chg="add mod">
+          <ac:chgData name="Björn Meder HMU Potsdam" userId="d258dbf6-ab6a-4282-851d-9abdcd54331d" providerId="ADAL" clId="{4DFD6B1A-A511-587B-86A6-0ACC1CABEBE3}" dt="2026-03-30T14:06:50.152" v="293"/>
           <ac:spMkLst>
             <pc:docMk/>
             <pc:sldMk cId="34156375" sldId="257"/>
-            <ac:spMk id="52" creationId="{83BCC762-8285-486F-F443-042FD02328D2}"/>
+            <ac:spMk id="16" creationId="{0A32D9A7-0E48-0F2D-D066-3DCE013B28C5}"/>
+          </ac:spMkLst>
+        </pc:spChg>
+        <pc:spChg chg="add mod">
+          <ac:chgData name="Björn Meder HMU Potsdam" userId="d258dbf6-ab6a-4282-851d-9abdcd54331d" providerId="ADAL" clId="{4DFD6B1A-A511-587B-86A6-0ACC1CABEBE3}" dt="2026-03-30T14:06:50.152" v="293"/>
+          <ac:spMkLst>
+            <pc:docMk/>
+            <pc:sldMk cId="34156375" sldId="257"/>
+            <ac:spMk id="17" creationId="{67862164-BD51-DCAA-B114-30766194BA57}"/>
+          </ac:spMkLst>
+        </pc:spChg>
+        <pc:spChg chg="add mod">
+          <ac:chgData name="Björn Meder HMU Potsdam" userId="d258dbf6-ab6a-4282-851d-9abdcd54331d" providerId="ADAL" clId="{4DFD6B1A-A511-587B-86A6-0ACC1CABEBE3}" dt="2026-03-30T14:11:40.548" v="435"/>
+          <ac:spMkLst>
+            <pc:docMk/>
+            <pc:sldMk cId="34156375" sldId="257"/>
+            <ac:spMk id="18" creationId="{E2983378-1CB0-6284-CA59-CD0AE190374C}"/>
           </ac:spMkLst>
         </pc:spChg>
         <pc:spChg chg="mod">
-          <ac:chgData name="Björn Meder HMU Potsdam" userId="d258dbf6-ab6a-4282-851d-9abdcd54331d" providerId="ADAL" clId="{4DFD6B1A-A511-587B-86A6-0ACC1CABEBE3}" dt="2025-08-16T07:13:47.028" v="208" actId="1076"/>
-          <ac:spMkLst>
-            <pc:docMk/>
-            <pc:sldMk cId="34156375" sldId="257"/>
-            <ac:spMk id="80" creationId="{66D5D2D8-0186-ECD1-9EC5-73B8BEE98C7E}"/>
-          </ac:spMkLst>
-        </pc:spChg>
-        <pc:spChg chg="mod">
-          <ac:chgData name="Björn Meder HMU Potsdam" userId="d258dbf6-ab6a-4282-851d-9abdcd54331d" providerId="ADAL" clId="{4DFD6B1A-A511-587B-86A6-0ACC1CABEBE3}" dt="2025-08-16T07:05:10.755" v="50" actId="1038"/>
+          <ac:chgData name="Björn Meder HMU Potsdam" userId="d258dbf6-ab6a-4282-851d-9abdcd54331d" providerId="ADAL" clId="{4DFD6B1A-A511-587B-86A6-0ACC1CABEBE3}" dt="2026-03-30T14:05:08.545" v="253" actId="1038"/>
           <ac:spMkLst>
             <pc:docMk/>
             <pc:sldMk cId="34156375" sldId="257"/>
             <ac:spMk id="81" creationId="{C125EBF5-6832-456B-2CDF-E8692B33E80F}"/>
           </ac:spMkLst>
         </pc:spChg>
-        <pc:grpChg chg="add del mod">
-          <ac:chgData name="Björn Meder HMU Potsdam" userId="d258dbf6-ab6a-4282-851d-9abdcd54331d" providerId="ADAL" clId="{4DFD6B1A-A511-587B-86A6-0ACC1CABEBE3}" dt="2025-08-16T07:14:29.486" v="212" actId="165"/>
+        <pc:spChg chg="del">
+          <ac:chgData name="Björn Meder HMU Potsdam" userId="d258dbf6-ab6a-4282-851d-9abdcd54331d" providerId="ADAL" clId="{4DFD6B1A-A511-587B-86A6-0ACC1CABEBE3}" dt="2026-03-30T14:06:48.603" v="292" actId="478"/>
+          <ac:spMkLst>
+            <pc:docMk/>
+            <pc:sldMk cId="34156375" sldId="257"/>
+            <ac:spMk id="85" creationId="{C1960B97-28BF-1A04-BA65-95D4D2C8CD53}"/>
+          </ac:spMkLst>
+        </pc:spChg>
+        <pc:spChg chg="del">
+          <ac:chgData name="Björn Meder HMU Potsdam" userId="d258dbf6-ab6a-4282-851d-9abdcd54331d" providerId="ADAL" clId="{4DFD6B1A-A511-587B-86A6-0ACC1CABEBE3}" dt="2026-03-30T14:06:48.603" v="292" actId="478"/>
+          <ac:spMkLst>
+            <pc:docMk/>
+            <pc:sldMk cId="34156375" sldId="257"/>
+            <ac:spMk id="86" creationId="{C227A0CD-4A06-DF50-F244-0A6B2ED3E7CF}"/>
+          </ac:spMkLst>
+        </pc:spChg>
+        <pc:spChg chg="del">
+          <ac:chgData name="Björn Meder HMU Potsdam" userId="d258dbf6-ab6a-4282-851d-9abdcd54331d" providerId="ADAL" clId="{4DFD6B1A-A511-587B-86A6-0ACC1CABEBE3}" dt="2026-03-30T14:06:48.603" v="292" actId="478"/>
+          <ac:spMkLst>
+            <pc:docMk/>
+            <pc:sldMk cId="34156375" sldId="257"/>
+            <ac:spMk id="87" creationId="{776649FF-65A7-9588-1976-192CDE45CB20}"/>
+          </ac:spMkLst>
+        </pc:spChg>
+        <pc:spChg chg="del">
+          <ac:chgData name="Björn Meder HMU Potsdam" userId="d258dbf6-ab6a-4282-851d-9abdcd54331d" providerId="ADAL" clId="{4DFD6B1A-A511-587B-86A6-0ACC1CABEBE3}" dt="2026-03-30T14:06:48.603" v="292" actId="478"/>
+          <ac:spMkLst>
+            <pc:docMk/>
+            <pc:sldMk cId="34156375" sldId="257"/>
+            <ac:spMk id="88" creationId="{713ED1F4-2010-32D6-E938-E0D71D3F830B}"/>
+          </ac:spMkLst>
+        </pc:spChg>
+        <pc:spChg chg="del">
+          <ac:chgData name="Björn Meder HMU Potsdam" userId="d258dbf6-ab6a-4282-851d-9abdcd54331d" providerId="ADAL" clId="{4DFD6B1A-A511-587B-86A6-0ACC1CABEBE3}" dt="2026-03-30T14:06:48.603" v="292" actId="478"/>
+          <ac:spMkLst>
+            <pc:docMk/>
+            <pc:sldMk cId="34156375" sldId="257"/>
+            <ac:spMk id="89" creationId="{9F3DC06C-FAF3-E4D7-537E-1506A017F0A0}"/>
+          </ac:spMkLst>
+        </pc:spChg>
+        <pc:spChg chg="del">
+          <ac:chgData name="Björn Meder HMU Potsdam" userId="d258dbf6-ab6a-4282-851d-9abdcd54331d" providerId="ADAL" clId="{4DFD6B1A-A511-587B-86A6-0ACC1CABEBE3}" dt="2026-03-30T14:06:48.603" v="292" actId="478"/>
+          <ac:spMkLst>
+            <pc:docMk/>
+            <pc:sldMk cId="34156375" sldId="257"/>
+            <ac:spMk id="90" creationId="{F483518A-A1EE-FE16-E97F-DED529FA1394}"/>
+          </ac:spMkLst>
+        </pc:spChg>
+        <pc:spChg chg="del">
+          <ac:chgData name="Björn Meder HMU Potsdam" userId="d258dbf6-ab6a-4282-851d-9abdcd54331d" providerId="ADAL" clId="{4DFD6B1A-A511-587B-86A6-0ACC1CABEBE3}" dt="2026-03-30T14:06:48.603" v="292" actId="478"/>
+          <ac:spMkLst>
+            <pc:docMk/>
+            <pc:sldMk cId="34156375" sldId="257"/>
+            <ac:spMk id="91" creationId="{1176E01C-3CDC-DB8D-AB3D-8BF5904D1941}"/>
+          </ac:spMkLst>
+        </pc:spChg>
+        <pc:grpChg chg="mod">
+          <ac:chgData name="Björn Meder HMU Potsdam" userId="d258dbf6-ab6a-4282-851d-9abdcd54331d" providerId="ADAL" clId="{4DFD6B1A-A511-587B-86A6-0ACC1CABEBE3}" dt="2026-03-30T14:07:10.688" v="295" actId="166"/>
           <ac:grpSpMkLst>
             <pc:docMk/>
             <pc:sldMk cId="34156375" sldId="257"/>
-            <ac:grpSpMk id="28" creationId="{30B61C34-48F1-BA45-0C5D-BEAE6DF3C699}"/>
+            <ac:grpSpMk id="97" creationId="{4F165C9E-8617-AFD8-4A21-3F9FBC2CCE8D}"/>
           </ac:grpSpMkLst>
         </pc:grpChg>
-        <pc:grpChg chg="del">
-          <ac:chgData name="Björn Meder HMU Potsdam" userId="d258dbf6-ab6a-4282-851d-9abdcd54331d" providerId="ADAL" clId="{4DFD6B1A-A511-587B-86A6-0ACC1CABEBE3}" dt="2025-08-16T07:01:38.643" v="2" actId="165"/>
-          <ac:grpSpMkLst>
-            <pc:docMk/>
-            <pc:sldMk cId="34156375" sldId="257"/>
-            <ac:grpSpMk id="72" creationId="{D168537E-8382-C385-5E43-2D6B609951EF}"/>
-          </ac:grpSpMkLst>
-        </pc:grpChg>
-        <pc:grpChg chg="mod">
-          <ac:chgData name="Björn Meder HMU Potsdam" userId="d258dbf6-ab6a-4282-851d-9abdcd54331d" providerId="ADAL" clId="{4DFD6B1A-A511-587B-86A6-0ACC1CABEBE3}" dt="2025-08-16T07:10:25.549" v="158" actId="1076"/>
-          <ac:grpSpMkLst>
-            <pc:docMk/>
-            <pc:sldMk cId="34156375" sldId="257"/>
-            <ac:grpSpMk id="77" creationId="{36459198-76B8-D3CA-9FCE-F5629DE94F10}"/>
-          </ac:grpSpMkLst>
-        </pc:grpChg>
-        <pc:picChg chg="add mod">
-          <ac:chgData name="Björn Meder HMU Potsdam" userId="d258dbf6-ab6a-4282-851d-9abdcd54331d" providerId="ADAL" clId="{4DFD6B1A-A511-587B-86A6-0ACC1CABEBE3}" dt="2025-08-16T07:02:22.350" v="11"/>
+        <pc:picChg chg="mod">
+          <ac:chgData name="Björn Meder HMU Potsdam" userId="d258dbf6-ab6a-4282-851d-9abdcd54331d" providerId="ADAL" clId="{4DFD6B1A-A511-587B-86A6-0ACC1CABEBE3}" dt="2026-03-30T14:06:55.391" v="294" actId="166"/>
           <ac:picMkLst>
             <pc:docMk/>
             <pc:sldMk cId="34156375" sldId="257"/>
-            <ac:picMk id="3" creationId="{87262A04-D6B2-B62C-4AB9-EF3381096A5F}"/>
+            <ac:picMk id="99" creationId="{F18CF5DF-C8D5-E8C0-47A2-7B403E6A78F4}"/>
+          </ac:picMkLst>
+        </pc:picChg>
+      </pc:sldChg>
+      <pc:sldChg chg="add">
+        <pc:chgData name="Björn Meder HMU Potsdam" userId="d258dbf6-ab6a-4282-851d-9abdcd54331d" providerId="ADAL" clId="{4DFD6B1A-A511-587B-86A6-0ACC1CABEBE3}" dt="2026-03-30T14:04:52.505" v="218"/>
+        <pc:sldMkLst>
+          <pc:docMk/>
+          <pc:sldMk cId="3288632656" sldId="258"/>
+        </pc:sldMkLst>
+      </pc:sldChg>
+      <pc:sldChg chg="addSp delSp modSp new mod">
+        <pc:chgData name="Björn Meder HMU Potsdam" userId="d258dbf6-ab6a-4282-851d-9abdcd54331d" providerId="ADAL" clId="{4DFD6B1A-A511-587B-86A6-0ACC1CABEBE3}" dt="2026-03-30T14:11:32.467" v="434" actId="6549"/>
+        <pc:sldMkLst>
+          <pc:docMk/>
+          <pc:sldMk cId="598453788" sldId="259"/>
+        </pc:sldMkLst>
+        <pc:spChg chg="del">
+          <ac:chgData name="Björn Meder HMU Potsdam" userId="d258dbf6-ab6a-4282-851d-9abdcd54331d" providerId="ADAL" clId="{4DFD6B1A-A511-587B-86A6-0ACC1CABEBE3}" dt="2026-03-30T14:05:44.140" v="255" actId="478"/>
+          <ac:spMkLst>
+            <pc:docMk/>
+            <pc:sldMk cId="598453788" sldId="259"/>
+            <ac:spMk id="2" creationId="{72725CEB-2441-9F82-B595-C73416BDBC9E}"/>
+          </ac:spMkLst>
+        </pc:spChg>
+        <pc:spChg chg="del">
+          <ac:chgData name="Björn Meder HMU Potsdam" userId="d258dbf6-ab6a-4282-851d-9abdcd54331d" providerId="ADAL" clId="{4DFD6B1A-A511-587B-86A6-0ACC1CABEBE3}" dt="2026-03-30T14:05:44.140" v="255" actId="478"/>
+          <ac:spMkLst>
+            <pc:docMk/>
+            <pc:sldMk cId="598453788" sldId="259"/>
+            <ac:spMk id="3" creationId="{D7CC643A-9EB6-81F2-47DB-D5CE632D804E}"/>
+          </ac:spMkLst>
+        </pc:spChg>
+        <pc:spChg chg="add del mod">
+          <ac:chgData name="Björn Meder HMU Potsdam" userId="d258dbf6-ab6a-4282-851d-9abdcd54331d" providerId="ADAL" clId="{4DFD6B1A-A511-587B-86A6-0ACC1CABEBE3}" dt="2026-03-30T14:07:23.882" v="296" actId="478"/>
+          <ac:spMkLst>
+            <pc:docMk/>
+            <pc:sldMk cId="598453788" sldId="259"/>
+            <ac:spMk id="4" creationId="{ACB1B840-F2BF-8935-6F87-5F25E0E6493A}"/>
+          </ac:spMkLst>
+        </pc:spChg>
+        <pc:spChg chg="add del mod">
+          <ac:chgData name="Björn Meder HMU Potsdam" userId="d258dbf6-ab6a-4282-851d-9abdcd54331d" providerId="ADAL" clId="{4DFD6B1A-A511-587B-86A6-0ACC1CABEBE3}" dt="2026-03-30T14:07:23.882" v="296" actId="478"/>
+          <ac:spMkLst>
+            <pc:docMk/>
+            <pc:sldMk cId="598453788" sldId="259"/>
+            <ac:spMk id="5" creationId="{85F0CFA3-6B79-0E68-CB78-302BA3641B0A}"/>
+          </ac:spMkLst>
+        </pc:spChg>
+        <pc:spChg chg="add del mod">
+          <ac:chgData name="Björn Meder HMU Potsdam" userId="d258dbf6-ab6a-4282-851d-9abdcd54331d" providerId="ADAL" clId="{4DFD6B1A-A511-587B-86A6-0ACC1CABEBE3}" dt="2026-03-30T14:07:23.882" v="296" actId="478"/>
+          <ac:spMkLst>
+            <pc:docMk/>
+            <pc:sldMk cId="598453788" sldId="259"/>
+            <ac:spMk id="6" creationId="{B1CA4E9E-D169-D00D-456C-B46591D41DA9}"/>
+          </ac:spMkLst>
+        </pc:spChg>
+        <pc:spChg chg="add del mod">
+          <ac:chgData name="Björn Meder HMU Potsdam" userId="d258dbf6-ab6a-4282-851d-9abdcd54331d" providerId="ADAL" clId="{4DFD6B1A-A511-587B-86A6-0ACC1CABEBE3}" dt="2026-03-30T14:07:23.882" v="296" actId="478"/>
+          <ac:spMkLst>
+            <pc:docMk/>
+            <pc:sldMk cId="598453788" sldId="259"/>
+            <ac:spMk id="7" creationId="{D1715367-DE42-7185-8EAB-E822FCC87F01}"/>
+          </ac:spMkLst>
+        </pc:spChg>
+        <pc:spChg chg="add del mod">
+          <ac:chgData name="Björn Meder HMU Potsdam" userId="d258dbf6-ab6a-4282-851d-9abdcd54331d" providerId="ADAL" clId="{4DFD6B1A-A511-587B-86A6-0ACC1CABEBE3}" dt="2026-03-30T14:07:23.882" v="296" actId="478"/>
+          <ac:spMkLst>
+            <pc:docMk/>
+            <pc:sldMk cId="598453788" sldId="259"/>
+            <ac:spMk id="8" creationId="{9B52F4E3-0BB7-F339-8A33-4A270E4A2BF7}"/>
+          </ac:spMkLst>
+        </pc:spChg>
+        <pc:spChg chg="add del mod">
+          <ac:chgData name="Björn Meder HMU Potsdam" userId="d258dbf6-ab6a-4282-851d-9abdcd54331d" providerId="ADAL" clId="{4DFD6B1A-A511-587B-86A6-0ACC1CABEBE3}" dt="2026-03-30T14:07:23.882" v="296" actId="478"/>
+          <ac:spMkLst>
+            <pc:docMk/>
+            <pc:sldMk cId="598453788" sldId="259"/>
+            <ac:spMk id="9" creationId="{38EB6D09-EC8D-5652-ED00-323D1D79C034}"/>
+          </ac:spMkLst>
+        </pc:spChg>
+        <pc:spChg chg="add del mod">
+          <ac:chgData name="Björn Meder HMU Potsdam" userId="d258dbf6-ab6a-4282-851d-9abdcd54331d" providerId="ADAL" clId="{4DFD6B1A-A511-587B-86A6-0ACC1CABEBE3}" dt="2026-03-30T14:07:23.882" v="296" actId="478"/>
+          <ac:spMkLst>
+            <pc:docMk/>
+            <pc:sldMk cId="598453788" sldId="259"/>
+            <ac:spMk id="10" creationId="{F110A297-171B-861F-8491-0D3458D26823}"/>
+          </ac:spMkLst>
+        </pc:spChg>
+        <pc:spChg chg="add del mod">
+          <ac:chgData name="Björn Meder HMU Potsdam" userId="d258dbf6-ab6a-4282-851d-9abdcd54331d" providerId="ADAL" clId="{4DFD6B1A-A511-587B-86A6-0ACC1CABEBE3}" dt="2026-03-30T14:07:23.882" v="296" actId="478"/>
+          <ac:spMkLst>
+            <pc:docMk/>
+            <pc:sldMk cId="598453788" sldId="259"/>
+            <ac:spMk id="11" creationId="{6DFCE2DE-E4EA-C8A8-A5FF-02273AF53D90}"/>
+          </ac:spMkLst>
+        </pc:spChg>
+        <pc:spChg chg="add del mod">
+          <ac:chgData name="Björn Meder HMU Potsdam" userId="d258dbf6-ab6a-4282-851d-9abdcd54331d" providerId="ADAL" clId="{4DFD6B1A-A511-587B-86A6-0ACC1CABEBE3}" dt="2026-03-30T14:11:13.205" v="414" actId="478"/>
+          <ac:spMkLst>
+            <pc:docMk/>
+            <pc:sldMk cId="598453788" sldId="259"/>
+            <ac:spMk id="14" creationId="{ADF61865-1DB9-FAAE-13DC-2E335602F1D7}"/>
+          </ac:spMkLst>
+        </pc:spChg>
+        <pc:spChg chg="add mod">
+          <ac:chgData name="Björn Meder HMU Potsdam" userId="d258dbf6-ab6a-4282-851d-9abdcd54331d" providerId="ADAL" clId="{4DFD6B1A-A511-587B-86A6-0ACC1CABEBE3}" dt="2026-03-30T14:11:32.467" v="434" actId="6549"/>
+          <ac:spMkLst>
+            <pc:docMk/>
+            <pc:sldMk cId="598453788" sldId="259"/>
+            <ac:spMk id="15" creationId="{7312DAE1-2B18-54AB-3FF3-CCF983A71FFE}"/>
+          </ac:spMkLst>
+        </pc:spChg>
+        <pc:spChg chg="add mod">
+          <ac:chgData name="Björn Meder HMU Potsdam" userId="d258dbf6-ab6a-4282-851d-9abdcd54331d" providerId="ADAL" clId="{4DFD6B1A-A511-587B-86A6-0ACC1CABEBE3}" dt="2026-03-30T14:09:45.323" v="363"/>
+          <ac:spMkLst>
+            <pc:docMk/>
+            <pc:sldMk cId="598453788" sldId="259"/>
+            <ac:spMk id="16" creationId="{FDCB6DEB-DEE2-1DA2-B3F3-414F1CDFADF4}"/>
+          </ac:spMkLst>
+        </pc:spChg>
+        <pc:picChg chg="add del mod">
+          <ac:chgData name="Björn Meder HMU Potsdam" userId="d258dbf6-ab6a-4282-851d-9abdcd54331d" providerId="ADAL" clId="{4DFD6B1A-A511-587B-86A6-0ACC1CABEBE3}" dt="2026-03-30T14:07:32.045" v="300" actId="478"/>
+          <ac:picMkLst>
+            <pc:docMk/>
+            <pc:sldMk cId="598453788" sldId="259"/>
+            <ac:picMk id="12" creationId="{32E63996-0631-4EE4-91FC-7F7E2B3C49BF}"/>
           </ac:picMkLst>
         </pc:picChg>
         <pc:picChg chg="add mod">
-          <ac:chgData name="Björn Meder HMU Potsdam" userId="d258dbf6-ab6a-4282-851d-9abdcd54331d" providerId="ADAL" clId="{4DFD6B1A-A511-587B-86A6-0ACC1CABEBE3}" dt="2025-08-16T07:02:22.350" v="11"/>
+          <ac:chgData name="Björn Meder HMU Potsdam" userId="d258dbf6-ab6a-4282-851d-9abdcd54331d" providerId="ADAL" clId="{4DFD6B1A-A511-587B-86A6-0ACC1CABEBE3}" dt="2026-03-30T14:07:32.799" v="301"/>
           <ac:picMkLst>
             <pc:docMk/>
-            <pc:sldMk cId="34156375" sldId="257"/>
-            <ac:picMk id="5" creationId="{25651A63-BD5B-5180-4D6C-4EA673E007A3}"/>
-          </ac:picMkLst>
-        </pc:picChg>
-        <pc:picChg chg="add mod">
-          <ac:chgData name="Björn Meder HMU Potsdam" userId="d258dbf6-ab6a-4282-851d-9abdcd54331d" providerId="ADAL" clId="{4DFD6B1A-A511-587B-86A6-0ACC1CABEBE3}" dt="2025-08-16T07:02:22.350" v="11"/>
-          <ac:picMkLst>
-            <pc:docMk/>
-            <pc:sldMk cId="34156375" sldId="257"/>
-            <ac:picMk id="7" creationId="{84557F7C-25ED-3BC0-924E-223E2103ECA2}"/>
-          </ac:picMkLst>
-        </pc:picChg>
-        <pc:picChg chg="add mod">
-          <ac:chgData name="Björn Meder HMU Potsdam" userId="d258dbf6-ab6a-4282-851d-9abdcd54331d" providerId="ADAL" clId="{4DFD6B1A-A511-587B-86A6-0ACC1CABEBE3}" dt="2025-08-16T07:02:22.350" v="11"/>
-          <ac:picMkLst>
-            <pc:docMk/>
-            <pc:sldMk cId="34156375" sldId="257"/>
-            <ac:picMk id="9" creationId="{60F49C8D-94D5-8E24-471F-1B1F4E4EFA6E}"/>
-          </ac:picMkLst>
-        </pc:picChg>
-        <pc:picChg chg="add mod">
-          <ac:chgData name="Björn Meder HMU Potsdam" userId="d258dbf6-ab6a-4282-851d-9abdcd54331d" providerId="ADAL" clId="{4DFD6B1A-A511-587B-86A6-0ACC1CABEBE3}" dt="2025-08-16T07:02:22.350" v="11"/>
-          <ac:picMkLst>
-            <pc:docMk/>
-            <pc:sldMk cId="34156375" sldId="257"/>
-            <ac:picMk id="11" creationId="{D9501E04-E906-806B-912F-F7F535D78242}"/>
-          </ac:picMkLst>
-        </pc:picChg>
-        <pc:picChg chg="add mod">
-          <ac:chgData name="Björn Meder HMU Potsdam" userId="d258dbf6-ab6a-4282-851d-9abdcd54331d" providerId="ADAL" clId="{4DFD6B1A-A511-587B-86A6-0ACC1CABEBE3}" dt="2025-08-16T07:02:22.350" v="11"/>
-          <ac:picMkLst>
-            <pc:docMk/>
-            <pc:sldMk cId="34156375" sldId="257"/>
-            <ac:picMk id="13" creationId="{EA91C52E-F644-4778-E980-60E549173D18}"/>
-          </ac:picMkLst>
-        </pc:picChg>
-        <pc:picChg chg="add mod">
-          <ac:chgData name="Björn Meder HMU Potsdam" userId="d258dbf6-ab6a-4282-851d-9abdcd54331d" providerId="ADAL" clId="{4DFD6B1A-A511-587B-86A6-0ACC1CABEBE3}" dt="2025-08-16T07:02:22.350" v="11"/>
-          <ac:picMkLst>
-            <pc:docMk/>
-            <pc:sldMk cId="34156375" sldId="257"/>
-            <ac:picMk id="15" creationId="{0B0EF168-731B-B569-A6B7-AD2D631876C4}"/>
-          </ac:picMkLst>
-        </pc:picChg>
-        <pc:picChg chg="add mod">
-          <ac:chgData name="Björn Meder HMU Potsdam" userId="d258dbf6-ab6a-4282-851d-9abdcd54331d" providerId="ADAL" clId="{4DFD6B1A-A511-587B-86A6-0ACC1CABEBE3}" dt="2025-08-16T07:02:22.350" v="11"/>
-          <ac:picMkLst>
-            <pc:docMk/>
-            <pc:sldMk cId="34156375" sldId="257"/>
-            <ac:picMk id="17" creationId="{CD740380-890B-97D6-C814-E3D409E951CB}"/>
-          </ac:picMkLst>
-        </pc:picChg>
-        <pc:picChg chg="add mod">
-          <ac:chgData name="Björn Meder HMU Potsdam" userId="d258dbf6-ab6a-4282-851d-9abdcd54331d" providerId="ADAL" clId="{4DFD6B1A-A511-587B-86A6-0ACC1CABEBE3}" dt="2025-08-16T07:02:22.350" v="11"/>
-          <ac:picMkLst>
-            <pc:docMk/>
-            <pc:sldMk cId="34156375" sldId="257"/>
-            <ac:picMk id="19" creationId="{0EAB9893-86D6-10A2-1EC9-BFCF30CD28C1}"/>
-          </ac:picMkLst>
-        </pc:picChg>
-        <pc:picChg chg="add mod">
-          <ac:chgData name="Björn Meder HMU Potsdam" userId="d258dbf6-ab6a-4282-851d-9abdcd54331d" providerId="ADAL" clId="{4DFD6B1A-A511-587B-86A6-0ACC1CABEBE3}" dt="2025-08-16T07:02:33.109" v="13" actId="14100"/>
-          <ac:picMkLst>
-            <pc:docMk/>
-            <pc:sldMk cId="34156375" sldId="257"/>
-            <ac:picMk id="23" creationId="{D17B3F28-26F2-87A9-3224-CB6A21435721}"/>
-          </ac:picMkLst>
-        </pc:picChg>
-        <pc:picChg chg="add del mod">
-          <ac:chgData name="Björn Meder HMU Potsdam" userId="d258dbf6-ab6a-4282-851d-9abdcd54331d" providerId="ADAL" clId="{4DFD6B1A-A511-587B-86A6-0ACC1CABEBE3}" dt="2025-08-16T07:03:48.357" v="16" actId="478"/>
-          <ac:picMkLst>
-            <pc:docMk/>
-            <pc:sldMk cId="34156375" sldId="257"/>
-            <ac:picMk id="24" creationId="{DF7A8E7B-00F9-B07F-A9C9-A788166FD8CA}"/>
-          </ac:picMkLst>
-        </pc:picChg>
-        <pc:picChg chg="add del mod">
-          <ac:chgData name="Björn Meder HMU Potsdam" userId="d258dbf6-ab6a-4282-851d-9abdcd54331d" providerId="ADAL" clId="{4DFD6B1A-A511-587B-86A6-0ACC1CABEBE3}" dt="2025-08-16T07:03:48.357" v="16" actId="478"/>
-          <ac:picMkLst>
-            <pc:docMk/>
-            <pc:sldMk cId="34156375" sldId="257"/>
-            <ac:picMk id="25" creationId="{50E33874-2044-A564-A34A-45D691935634}"/>
-          </ac:picMkLst>
-        </pc:picChg>
-        <pc:picChg chg="add del mod">
-          <ac:chgData name="Björn Meder HMU Potsdam" userId="d258dbf6-ab6a-4282-851d-9abdcd54331d" providerId="ADAL" clId="{4DFD6B1A-A511-587B-86A6-0ACC1CABEBE3}" dt="2025-08-16T07:03:48.357" v="16" actId="478"/>
-          <ac:picMkLst>
-            <pc:docMk/>
-            <pc:sldMk cId="34156375" sldId="257"/>
-            <ac:picMk id="26" creationId="{9A9B8CF7-FED5-935A-7BB8-C06564C8A660}"/>
-          </ac:picMkLst>
-        </pc:picChg>
-        <pc:picChg chg="add del mod">
-          <ac:chgData name="Björn Meder HMU Potsdam" userId="d258dbf6-ab6a-4282-851d-9abdcd54331d" providerId="ADAL" clId="{4DFD6B1A-A511-587B-86A6-0ACC1CABEBE3}" dt="2025-08-16T07:03:48.357" v="16" actId="478"/>
-          <ac:picMkLst>
-            <pc:docMk/>
-            <pc:sldMk cId="34156375" sldId="257"/>
-            <ac:picMk id="27" creationId="{551515E1-907B-CF47-F766-5A57D944916D}"/>
-          </ac:picMkLst>
-        </pc:picChg>
-        <pc:picChg chg="mod topLvl">
-          <ac:chgData name="Björn Meder HMU Potsdam" userId="d258dbf6-ab6a-4282-851d-9abdcd54331d" providerId="ADAL" clId="{4DFD6B1A-A511-587B-86A6-0ACC1CABEBE3}" dt="2025-08-16T07:14:44.337" v="215" actId="465"/>
-          <ac:picMkLst>
-            <pc:docMk/>
-            <pc:sldMk cId="34156375" sldId="257"/>
-            <ac:picMk id="29" creationId="{52DFD066-56C8-F401-9824-E63A66FD8DE3}"/>
-          </ac:picMkLst>
-        </pc:picChg>
-        <pc:picChg chg="mod topLvl">
-          <ac:chgData name="Björn Meder HMU Potsdam" userId="d258dbf6-ab6a-4282-851d-9abdcd54331d" providerId="ADAL" clId="{4DFD6B1A-A511-587B-86A6-0ACC1CABEBE3}" dt="2025-08-16T07:14:40.669" v="214" actId="465"/>
-          <ac:picMkLst>
-            <pc:docMk/>
-            <pc:sldMk cId="34156375" sldId="257"/>
-            <ac:picMk id="30" creationId="{E05433B0-B7BA-7A98-207D-239BBB94A262}"/>
-          </ac:picMkLst>
-        </pc:picChg>
-        <pc:picChg chg="mod topLvl">
-          <ac:chgData name="Björn Meder HMU Potsdam" userId="d258dbf6-ab6a-4282-851d-9abdcd54331d" providerId="ADAL" clId="{4DFD6B1A-A511-587B-86A6-0ACC1CABEBE3}" dt="2025-08-16T07:14:37.907" v="213" actId="465"/>
-          <ac:picMkLst>
-            <pc:docMk/>
-            <pc:sldMk cId="34156375" sldId="257"/>
-            <ac:picMk id="31" creationId="{9BCA3DFD-A3F1-CF71-7602-76C4E6EA2C3E}"/>
-          </ac:picMkLst>
-        </pc:picChg>
-        <pc:picChg chg="mod topLvl">
-          <ac:chgData name="Björn Meder HMU Potsdam" userId="d258dbf6-ab6a-4282-851d-9abdcd54331d" providerId="ADAL" clId="{4DFD6B1A-A511-587B-86A6-0ACC1CABEBE3}" dt="2025-08-16T07:14:44.337" v="215" actId="465"/>
-          <ac:picMkLst>
-            <pc:docMk/>
-            <pc:sldMk cId="34156375" sldId="257"/>
-            <ac:picMk id="32" creationId="{83AFEAE7-44F2-8648-F279-9487F0178620}"/>
-          </ac:picMkLst>
-        </pc:picChg>
-        <pc:picChg chg="mod topLvl">
-          <ac:chgData name="Björn Meder HMU Potsdam" userId="d258dbf6-ab6a-4282-851d-9abdcd54331d" providerId="ADAL" clId="{4DFD6B1A-A511-587B-86A6-0ACC1CABEBE3}" dt="2025-08-16T07:14:44.337" v="215" actId="465"/>
-          <ac:picMkLst>
-            <pc:docMk/>
-            <pc:sldMk cId="34156375" sldId="257"/>
-            <ac:picMk id="33" creationId="{0546CB74-262E-BA4F-B904-F814BF6D7321}"/>
-          </ac:picMkLst>
-        </pc:picChg>
-        <pc:picChg chg="mod topLvl">
-          <ac:chgData name="Björn Meder HMU Potsdam" userId="d258dbf6-ab6a-4282-851d-9abdcd54331d" providerId="ADAL" clId="{4DFD6B1A-A511-587B-86A6-0ACC1CABEBE3}" dt="2025-08-16T07:14:40.669" v="214" actId="465"/>
-          <ac:picMkLst>
-            <pc:docMk/>
-            <pc:sldMk cId="34156375" sldId="257"/>
-            <ac:picMk id="34" creationId="{386DA79D-F596-D613-92F7-3C0158E99893}"/>
-          </ac:picMkLst>
-        </pc:picChg>
-        <pc:picChg chg="mod topLvl">
-          <ac:chgData name="Björn Meder HMU Potsdam" userId="d258dbf6-ab6a-4282-851d-9abdcd54331d" providerId="ADAL" clId="{4DFD6B1A-A511-587B-86A6-0ACC1CABEBE3}" dt="2025-08-16T07:14:40.669" v="214" actId="465"/>
-          <ac:picMkLst>
-            <pc:docMk/>
-            <pc:sldMk cId="34156375" sldId="257"/>
-            <ac:picMk id="35" creationId="{2E10C79D-1D6D-4A73-621F-8BA18273367D}"/>
-          </ac:picMkLst>
-        </pc:picChg>
-        <pc:picChg chg="mod topLvl">
-          <ac:chgData name="Björn Meder HMU Potsdam" userId="d258dbf6-ab6a-4282-851d-9abdcd54331d" providerId="ADAL" clId="{4DFD6B1A-A511-587B-86A6-0ACC1CABEBE3}" dt="2025-08-16T07:14:37.907" v="213" actId="465"/>
-          <ac:picMkLst>
-            <pc:docMk/>
-            <pc:sldMk cId="34156375" sldId="257"/>
-            <ac:picMk id="36" creationId="{E0B13C66-5342-D09E-7AAC-82520DC8C39D}"/>
-          </ac:picMkLst>
-        </pc:picChg>
-        <pc:picChg chg="mod topLvl">
-          <ac:chgData name="Björn Meder HMU Potsdam" userId="d258dbf6-ab6a-4282-851d-9abdcd54331d" providerId="ADAL" clId="{4DFD6B1A-A511-587B-86A6-0ACC1CABEBE3}" dt="2025-08-16T07:14:37.907" v="213" actId="465"/>
-          <ac:picMkLst>
-            <pc:docMk/>
-            <pc:sldMk cId="34156375" sldId="257"/>
-            <ac:picMk id="37" creationId="{AAB0F67F-0AF4-2945-014F-CD1A32645447}"/>
-          </ac:picMkLst>
-        </pc:picChg>
-        <pc:picChg chg="del mod topLvl">
-          <ac:chgData name="Björn Meder HMU Potsdam" userId="d258dbf6-ab6a-4282-851d-9abdcd54331d" providerId="ADAL" clId="{4DFD6B1A-A511-587B-86A6-0ACC1CABEBE3}" dt="2025-08-16T07:02:00.400" v="10" actId="478"/>
-          <ac:picMkLst>
-            <pc:docMk/>
-            <pc:sldMk cId="34156375" sldId="257"/>
-            <ac:picMk id="73" creationId="{72F34CD0-FCE4-F720-D4B1-92E171AE7CB7}"/>
-          </ac:picMkLst>
-        </pc:picChg>
-        <pc:picChg chg="del mod topLvl">
-          <ac:chgData name="Björn Meder HMU Potsdam" userId="d258dbf6-ab6a-4282-851d-9abdcd54331d" providerId="ADAL" clId="{4DFD6B1A-A511-587B-86A6-0ACC1CABEBE3}" dt="2025-08-16T07:02:00.400" v="10" actId="478"/>
-          <ac:picMkLst>
-            <pc:docMk/>
-            <pc:sldMk cId="34156375" sldId="257"/>
-            <ac:picMk id="74" creationId="{AB9CBE55-907A-5A47-5A69-A79F5093FBDB}"/>
-          </ac:picMkLst>
-        </pc:picChg>
-        <pc:picChg chg="del mod topLvl">
-          <ac:chgData name="Björn Meder HMU Potsdam" userId="d258dbf6-ab6a-4282-851d-9abdcd54331d" providerId="ADAL" clId="{4DFD6B1A-A511-587B-86A6-0ACC1CABEBE3}" dt="2025-08-16T07:02:00.400" v="10" actId="478"/>
-          <ac:picMkLst>
-            <pc:docMk/>
-            <pc:sldMk cId="34156375" sldId="257"/>
-            <ac:picMk id="75" creationId="{8D96A265-73C6-3DB5-0088-530A2E3851D2}"/>
-          </ac:picMkLst>
-        </pc:picChg>
-        <pc:picChg chg="del">
-          <ac:chgData name="Björn Meder HMU Potsdam" userId="d258dbf6-ab6a-4282-851d-9abdcd54331d" providerId="ADAL" clId="{4DFD6B1A-A511-587B-86A6-0ACC1CABEBE3}" dt="2025-08-16T07:01:36.082" v="1" actId="478"/>
-          <ac:picMkLst>
-            <pc:docMk/>
-            <pc:sldMk cId="34156375" sldId="257"/>
-            <ac:picMk id="76" creationId="{1FEA5B02-A90B-9816-552C-7B381CCE0C53}"/>
+            <pc:sldMk cId="598453788" sldId="259"/>
+            <ac:picMk id="13" creationId="{25A8D0D4-0BB2-8654-66F7-0757C94C65A9}"/>
           </ac:picMkLst>
         </pc:picChg>
       </pc:sldChg>
-    </pc:docChg>
-  </pc:docChgLst>
-  <pc:docChgLst>
-    <pc:chgData name="Björn Meder HMU Potsdam" userId="d258dbf6-ab6a-4282-851d-9abdcd54331d" providerId="ADAL" clId="{B6D57924-B848-2742-8D38-F6230294B7DC}"/>
-    <pc:docChg chg="custSel addSld delSld modSld modMainMaster">
-      <pc:chgData name="Björn Meder HMU Potsdam" userId="d258dbf6-ab6a-4282-851d-9abdcd54331d" providerId="ADAL" clId="{B6D57924-B848-2742-8D38-F6230294B7DC}" dt="2025-07-31T17:45:04.732" v="54" actId="2696"/>
-      <pc:docMkLst>
-        <pc:docMk/>
-      </pc:docMkLst>
-      <pc:sldChg chg="addSp delSp modSp mod">
-        <pc:chgData name="Björn Meder HMU Potsdam" userId="d258dbf6-ab6a-4282-851d-9abdcd54331d" providerId="ADAL" clId="{B6D57924-B848-2742-8D38-F6230294B7DC}" dt="2025-07-31T12:15:23.197" v="47" actId="1038"/>
-        <pc:sldMkLst>
-          <pc:docMk/>
-          <pc:sldMk cId="1845256045" sldId="256"/>
-        </pc:sldMkLst>
-        <pc:spChg chg="mod">
-          <ac:chgData name="Björn Meder HMU Potsdam" userId="d258dbf6-ab6a-4282-851d-9abdcd54331d" providerId="ADAL" clId="{B6D57924-B848-2742-8D38-F6230294B7DC}" dt="2025-07-31T12:15:09.225" v="13" actId="1036"/>
-          <ac:spMkLst>
-            <pc:docMk/>
-            <pc:sldMk cId="1845256045" sldId="256"/>
-            <ac:spMk id="80" creationId="{E71E4D08-87DF-61BD-C1FF-2F48DF5FBA20}"/>
-          </ac:spMkLst>
-        </pc:spChg>
-        <pc:spChg chg="mod">
-          <ac:chgData name="Björn Meder HMU Potsdam" userId="d258dbf6-ab6a-4282-851d-9abdcd54331d" providerId="ADAL" clId="{B6D57924-B848-2742-8D38-F6230294B7DC}" dt="2025-07-31T12:15:23.197" v="47" actId="1038"/>
-          <ac:spMkLst>
-            <pc:docMk/>
-            <pc:sldMk cId="1845256045" sldId="256"/>
-            <ac:spMk id="81" creationId="{3B97A300-5E81-4CF9-CCD4-584F03355EDB}"/>
-          </ac:spMkLst>
-        </pc:spChg>
-        <pc:spChg chg="add mod">
-          <ac:chgData name="Björn Meder HMU Potsdam" userId="d258dbf6-ab6a-4282-851d-9abdcd54331d" providerId="ADAL" clId="{B6D57924-B848-2742-8D38-F6230294B7DC}" dt="2025-07-31T12:15:18.386" v="31" actId="1037"/>
-          <ac:spMkLst>
-            <pc:docMk/>
-            <pc:sldMk cId="1845256045" sldId="256"/>
-            <ac:spMk id="82" creationId="{371E1DE2-74FF-C979-AD89-03EF229E06B5}"/>
-          </ac:spMkLst>
-        </pc:spChg>
-        <pc:spChg chg="add mod">
-          <ac:chgData name="Björn Meder HMU Potsdam" userId="d258dbf6-ab6a-4282-851d-9abdcd54331d" providerId="ADAL" clId="{B6D57924-B848-2742-8D38-F6230294B7DC}" dt="2025-07-31T12:15:01.020" v="11" actId="1035"/>
-          <ac:spMkLst>
-            <pc:docMk/>
-            <pc:sldMk cId="1845256045" sldId="256"/>
-            <ac:spMk id="85" creationId="{853AB7EB-6194-7658-67E5-1A34E32737F8}"/>
-          </ac:spMkLst>
-        </pc:spChg>
-        <pc:spChg chg="add mod">
-          <ac:chgData name="Björn Meder HMU Potsdam" userId="d258dbf6-ab6a-4282-851d-9abdcd54331d" providerId="ADAL" clId="{B6D57924-B848-2742-8D38-F6230294B7DC}" dt="2025-07-31T12:15:01.020" v="11" actId="1035"/>
-          <ac:spMkLst>
-            <pc:docMk/>
-            <pc:sldMk cId="1845256045" sldId="256"/>
-            <ac:spMk id="86" creationId="{98D8540B-28A8-C964-0916-98ADBC06B2E0}"/>
-          </ac:spMkLst>
-        </pc:spChg>
-        <pc:spChg chg="mod">
-          <ac:chgData name="Björn Meder HMU Potsdam" userId="d258dbf6-ab6a-4282-851d-9abdcd54331d" providerId="ADAL" clId="{B6D57924-B848-2742-8D38-F6230294B7DC}" dt="2025-07-31T12:15:01.020" v="11" actId="1035"/>
-          <ac:spMkLst>
-            <pc:docMk/>
-            <pc:sldMk cId="1845256045" sldId="256"/>
-            <ac:spMk id="87" creationId="{DB945779-C1E9-8AC7-D3F0-FB76AB437AA0}"/>
-          </ac:spMkLst>
-        </pc:spChg>
-        <pc:spChg chg="add mod">
-          <ac:chgData name="Björn Meder HMU Potsdam" userId="d258dbf6-ab6a-4282-851d-9abdcd54331d" providerId="ADAL" clId="{B6D57924-B848-2742-8D38-F6230294B7DC}" dt="2025-07-31T12:15:01.020" v="11" actId="1035"/>
-          <ac:spMkLst>
-            <pc:docMk/>
-            <pc:sldMk cId="1845256045" sldId="256"/>
-            <ac:spMk id="88" creationId="{8B661F2B-11F7-51BE-AAC8-BBC669B48D45}"/>
-          </ac:spMkLst>
-        </pc:spChg>
-        <pc:spChg chg="add mod">
-          <ac:chgData name="Björn Meder HMU Potsdam" userId="d258dbf6-ab6a-4282-851d-9abdcd54331d" providerId="ADAL" clId="{B6D57924-B848-2742-8D38-F6230294B7DC}" dt="2025-07-31T12:15:01.020" v="11" actId="1035"/>
-          <ac:spMkLst>
-            <pc:docMk/>
-            <pc:sldMk cId="1845256045" sldId="256"/>
-            <ac:spMk id="89" creationId="{E179F596-7D73-38BB-DAF4-17F6B8510B7F}"/>
-          </ac:spMkLst>
-        </pc:spChg>
-        <pc:spChg chg="add mod">
-          <ac:chgData name="Björn Meder HMU Potsdam" userId="d258dbf6-ab6a-4282-851d-9abdcd54331d" providerId="ADAL" clId="{B6D57924-B848-2742-8D38-F6230294B7DC}" dt="2025-07-31T12:14:57.816" v="9"/>
-          <ac:spMkLst>
-            <pc:docMk/>
-            <pc:sldMk cId="1845256045" sldId="256"/>
-            <ac:spMk id="90" creationId="{D5F5B5AA-6D10-2387-9C82-493513E83EED}"/>
-          </ac:spMkLst>
-        </pc:spChg>
-        <pc:spChg chg="add mod">
-          <ac:chgData name="Björn Meder HMU Potsdam" userId="d258dbf6-ab6a-4282-851d-9abdcd54331d" providerId="ADAL" clId="{B6D57924-B848-2742-8D38-F6230294B7DC}" dt="2025-07-31T12:15:01.020" v="11" actId="1035"/>
-          <ac:spMkLst>
-            <pc:docMk/>
-            <pc:sldMk cId="1845256045" sldId="256"/>
-            <ac:spMk id="92" creationId="{CC7728F4-E58A-CD50-621E-09FFC051CADB}"/>
-          </ac:spMkLst>
-        </pc:spChg>
-        <pc:spChg chg="add mod">
-          <ac:chgData name="Björn Meder HMU Potsdam" userId="d258dbf6-ab6a-4282-851d-9abdcd54331d" providerId="ADAL" clId="{B6D57924-B848-2742-8D38-F6230294B7DC}" dt="2025-07-31T12:14:57.816" v="9"/>
-          <ac:spMkLst>
-            <pc:docMk/>
-            <pc:sldMk cId="1845256045" sldId="256"/>
-            <ac:spMk id="95" creationId="{1A1CA980-DEBE-7ED3-FCBB-F27C08FFC466}"/>
-          </ac:spMkLst>
-        </pc:spChg>
-        <pc:spChg chg="mod">
-          <ac:chgData name="Björn Meder HMU Potsdam" userId="d258dbf6-ab6a-4282-851d-9abdcd54331d" providerId="ADAL" clId="{B6D57924-B848-2742-8D38-F6230294B7DC}" dt="2025-07-31T12:15:01.020" v="11" actId="1035"/>
-          <ac:spMkLst>
-            <pc:docMk/>
-            <pc:sldMk cId="1845256045" sldId="256"/>
-            <ac:spMk id="96" creationId="{BC70F5D4-92D3-9A8C-3B4A-63DA43F4707A}"/>
-          </ac:spMkLst>
-        </pc:spChg>
-        <pc:spChg chg="mod">
-          <ac:chgData name="Björn Meder HMU Potsdam" userId="d258dbf6-ab6a-4282-851d-9abdcd54331d" providerId="ADAL" clId="{B6D57924-B848-2742-8D38-F6230294B7DC}" dt="2025-07-31T12:14:57.816" v="9"/>
-          <ac:spMkLst>
-            <pc:docMk/>
-            <pc:sldMk cId="1845256045" sldId="256"/>
-            <ac:spMk id="98" creationId="{5A057943-34A0-3508-F911-C78D2758DCDF}"/>
-          </ac:spMkLst>
-        </pc:spChg>
-        <pc:spChg chg="add mod">
-          <ac:chgData name="Björn Meder HMU Potsdam" userId="d258dbf6-ab6a-4282-851d-9abdcd54331d" providerId="ADAL" clId="{B6D57924-B848-2742-8D38-F6230294B7DC}" dt="2025-07-31T12:14:57.816" v="9"/>
-          <ac:spMkLst>
-            <pc:docMk/>
-            <pc:sldMk cId="1845256045" sldId="256"/>
-            <ac:spMk id="100" creationId="{69C215B1-3CF1-6167-D884-7C75549F646D}"/>
-          </ac:spMkLst>
-        </pc:spChg>
-      </pc:sldChg>
-      <pc:sldChg chg="addSp delSp modSp new del mod">
-        <pc:chgData name="Björn Meder HMU Potsdam" userId="d258dbf6-ab6a-4282-851d-9abdcd54331d" providerId="ADAL" clId="{B6D57924-B848-2742-8D38-F6230294B7DC}" dt="2025-07-31T17:45:04.732" v="54" actId="2696"/>
-        <pc:sldMkLst>
-          <pc:docMk/>
-          <pc:sldMk cId="1595734359" sldId="257"/>
-        </pc:sldMkLst>
-      </pc:sldChg>
-      <pc:sldMasterChg chg="modSp modSldLayout">
-        <pc:chgData name="Björn Meder HMU Potsdam" userId="d258dbf6-ab6a-4282-851d-9abdcd54331d" providerId="ADAL" clId="{B6D57924-B848-2742-8D38-F6230294B7DC}" dt="2025-07-31T12:14:45.714" v="5"/>
-        <pc:sldMasterMkLst>
-          <pc:docMk/>
-          <pc:sldMasterMk cId="2618204342" sldId="2147483696"/>
-        </pc:sldMasterMkLst>
-        <pc:sldLayoutChg chg="modSp">
-          <pc:chgData name="Björn Meder HMU Potsdam" userId="d258dbf6-ab6a-4282-851d-9abdcd54331d" providerId="ADAL" clId="{B6D57924-B848-2742-8D38-F6230294B7DC}" dt="2025-07-31T12:14:45.714" v="5"/>
-          <pc:sldLayoutMkLst>
-            <pc:docMk/>
-            <pc:sldMasterMk cId="2618204342" sldId="2147483696"/>
-            <pc:sldLayoutMk cId="4028182537" sldId="2147483697"/>
-          </pc:sldLayoutMkLst>
-        </pc:sldLayoutChg>
-        <pc:sldLayoutChg chg="modSp">
-          <pc:chgData name="Björn Meder HMU Potsdam" userId="d258dbf6-ab6a-4282-851d-9abdcd54331d" providerId="ADAL" clId="{B6D57924-B848-2742-8D38-F6230294B7DC}" dt="2025-07-31T12:14:45.714" v="5"/>
-          <pc:sldLayoutMkLst>
-            <pc:docMk/>
-            <pc:sldMasterMk cId="2618204342" sldId="2147483696"/>
-            <pc:sldLayoutMk cId="94315151" sldId="2147483699"/>
-          </pc:sldLayoutMkLst>
-        </pc:sldLayoutChg>
-        <pc:sldLayoutChg chg="modSp">
-          <pc:chgData name="Björn Meder HMU Potsdam" userId="d258dbf6-ab6a-4282-851d-9abdcd54331d" providerId="ADAL" clId="{B6D57924-B848-2742-8D38-F6230294B7DC}" dt="2025-07-31T12:14:45.714" v="5"/>
-          <pc:sldLayoutMkLst>
-            <pc:docMk/>
-            <pc:sldMasterMk cId="2618204342" sldId="2147483696"/>
-            <pc:sldLayoutMk cId="603476742" sldId="2147483700"/>
-          </pc:sldLayoutMkLst>
-        </pc:sldLayoutChg>
-        <pc:sldLayoutChg chg="modSp">
-          <pc:chgData name="Björn Meder HMU Potsdam" userId="d258dbf6-ab6a-4282-851d-9abdcd54331d" providerId="ADAL" clId="{B6D57924-B848-2742-8D38-F6230294B7DC}" dt="2025-07-31T12:14:45.714" v="5"/>
-          <pc:sldLayoutMkLst>
-            <pc:docMk/>
-            <pc:sldMasterMk cId="2618204342" sldId="2147483696"/>
-            <pc:sldLayoutMk cId="745039881" sldId="2147483701"/>
-          </pc:sldLayoutMkLst>
-        </pc:sldLayoutChg>
-        <pc:sldLayoutChg chg="modSp">
-          <pc:chgData name="Björn Meder HMU Potsdam" userId="d258dbf6-ab6a-4282-851d-9abdcd54331d" providerId="ADAL" clId="{B6D57924-B848-2742-8D38-F6230294B7DC}" dt="2025-07-31T12:14:45.714" v="5"/>
-          <pc:sldLayoutMkLst>
-            <pc:docMk/>
-            <pc:sldMasterMk cId="2618204342" sldId="2147483696"/>
-            <pc:sldLayoutMk cId="1001682325" sldId="2147483704"/>
-          </pc:sldLayoutMkLst>
-        </pc:sldLayoutChg>
-        <pc:sldLayoutChg chg="modSp">
-          <pc:chgData name="Björn Meder HMU Potsdam" userId="d258dbf6-ab6a-4282-851d-9abdcd54331d" providerId="ADAL" clId="{B6D57924-B848-2742-8D38-F6230294B7DC}" dt="2025-07-31T12:14:45.714" v="5"/>
-          <pc:sldLayoutMkLst>
-            <pc:docMk/>
-            <pc:sldMasterMk cId="2618204342" sldId="2147483696"/>
-            <pc:sldLayoutMk cId="2365256577" sldId="2147483705"/>
-          </pc:sldLayoutMkLst>
-        </pc:sldLayoutChg>
-        <pc:sldLayoutChg chg="modSp">
-          <pc:chgData name="Björn Meder HMU Potsdam" userId="d258dbf6-ab6a-4282-851d-9abdcd54331d" providerId="ADAL" clId="{B6D57924-B848-2742-8D38-F6230294B7DC}" dt="2025-07-31T12:14:45.714" v="5"/>
-          <pc:sldLayoutMkLst>
-            <pc:docMk/>
-            <pc:sldMasterMk cId="2618204342" sldId="2147483696"/>
-            <pc:sldLayoutMk cId="3918179759" sldId="2147483707"/>
-          </pc:sldLayoutMkLst>
-        </pc:sldLayoutChg>
-      </pc:sldMasterChg>
-      <pc:sldMasterChg chg="modSp modSldLayout">
-        <pc:chgData name="Björn Meder HMU Potsdam" userId="d258dbf6-ab6a-4282-851d-9abdcd54331d" providerId="ADAL" clId="{B6D57924-B848-2742-8D38-F6230294B7DC}" dt="2025-07-31T12:14:56.840" v="8"/>
-        <pc:sldMasterMkLst>
-          <pc:docMk/>
-          <pc:sldMasterMk cId="4117015308" sldId="2147483708"/>
-        </pc:sldMasterMkLst>
-        <pc:sldLayoutChg chg="modSp">
-          <pc:chgData name="Björn Meder HMU Potsdam" userId="d258dbf6-ab6a-4282-851d-9abdcd54331d" providerId="ADAL" clId="{B6D57924-B848-2742-8D38-F6230294B7DC}" dt="2025-07-31T12:14:56.840" v="8"/>
-          <pc:sldLayoutMkLst>
-            <pc:docMk/>
-            <pc:sldMasterMk cId="4117015308" sldId="2147483708"/>
-            <pc:sldLayoutMk cId="1280892548" sldId="2147483709"/>
-          </pc:sldLayoutMkLst>
-        </pc:sldLayoutChg>
-        <pc:sldLayoutChg chg="modSp">
-          <pc:chgData name="Björn Meder HMU Potsdam" userId="d258dbf6-ab6a-4282-851d-9abdcd54331d" providerId="ADAL" clId="{B6D57924-B848-2742-8D38-F6230294B7DC}" dt="2025-07-31T12:14:56.840" v="8"/>
-          <pc:sldLayoutMkLst>
-            <pc:docMk/>
-            <pc:sldMasterMk cId="4117015308" sldId="2147483708"/>
-            <pc:sldLayoutMk cId="1884543042" sldId="2147483711"/>
-          </pc:sldLayoutMkLst>
-        </pc:sldLayoutChg>
-        <pc:sldLayoutChg chg="modSp">
-          <pc:chgData name="Björn Meder HMU Potsdam" userId="d258dbf6-ab6a-4282-851d-9abdcd54331d" providerId="ADAL" clId="{B6D57924-B848-2742-8D38-F6230294B7DC}" dt="2025-07-31T12:14:56.840" v="8"/>
-          <pc:sldLayoutMkLst>
-            <pc:docMk/>
-            <pc:sldMasterMk cId="4117015308" sldId="2147483708"/>
-            <pc:sldLayoutMk cId="2899403362" sldId="2147483712"/>
-          </pc:sldLayoutMkLst>
-        </pc:sldLayoutChg>
-        <pc:sldLayoutChg chg="modSp">
-          <pc:chgData name="Björn Meder HMU Potsdam" userId="d258dbf6-ab6a-4282-851d-9abdcd54331d" providerId="ADAL" clId="{B6D57924-B848-2742-8D38-F6230294B7DC}" dt="2025-07-31T12:14:56.840" v="8"/>
-          <pc:sldLayoutMkLst>
-            <pc:docMk/>
-            <pc:sldMasterMk cId="4117015308" sldId="2147483708"/>
-            <pc:sldLayoutMk cId="3191287041" sldId="2147483713"/>
-          </pc:sldLayoutMkLst>
-        </pc:sldLayoutChg>
-        <pc:sldLayoutChg chg="modSp">
-          <pc:chgData name="Björn Meder HMU Potsdam" userId="d258dbf6-ab6a-4282-851d-9abdcd54331d" providerId="ADAL" clId="{B6D57924-B848-2742-8D38-F6230294B7DC}" dt="2025-07-31T12:14:56.840" v="8"/>
-          <pc:sldLayoutMkLst>
-            <pc:docMk/>
-            <pc:sldMasterMk cId="4117015308" sldId="2147483708"/>
-            <pc:sldLayoutMk cId="2492687080" sldId="2147483716"/>
-          </pc:sldLayoutMkLst>
-        </pc:sldLayoutChg>
-        <pc:sldLayoutChg chg="modSp">
-          <pc:chgData name="Björn Meder HMU Potsdam" userId="d258dbf6-ab6a-4282-851d-9abdcd54331d" providerId="ADAL" clId="{B6D57924-B848-2742-8D38-F6230294B7DC}" dt="2025-07-31T12:14:56.840" v="8"/>
-          <pc:sldLayoutMkLst>
-            <pc:docMk/>
-            <pc:sldMasterMk cId="4117015308" sldId="2147483708"/>
-            <pc:sldLayoutMk cId="319162707" sldId="2147483717"/>
-          </pc:sldLayoutMkLst>
-        </pc:sldLayoutChg>
-        <pc:sldLayoutChg chg="modSp">
-          <pc:chgData name="Björn Meder HMU Potsdam" userId="d258dbf6-ab6a-4282-851d-9abdcd54331d" providerId="ADAL" clId="{B6D57924-B848-2742-8D38-F6230294B7DC}" dt="2025-07-31T12:14:56.840" v="8"/>
-          <pc:sldLayoutMkLst>
-            <pc:docMk/>
-            <pc:sldMasterMk cId="4117015308" sldId="2147483708"/>
-            <pc:sldLayoutMk cId="3894819517" sldId="2147483719"/>
-          </pc:sldLayoutMkLst>
-        </pc:sldLayoutChg>
-      </pc:sldMasterChg>
     </pc:docChg>
   </pc:docChgLst>
 </pc:chgInfo>
@@ -910,7 +640,7 @@
           <a:p>
             <a:fld id="{0A85FBF7-6189-C04A-8896-44241FF05286}" type="datetimeFigureOut">
               <a:rPr lang="en-US" smtClean="0"/>
-              <a:t>8/16/25</a:t>
+              <a:t>3/30/26</a:t>
             </a:fld>
             <a:endParaRPr lang="en-US"/>
           </a:p>
@@ -1080,7 +810,7 @@
           <a:p>
             <a:fld id="{0A85FBF7-6189-C04A-8896-44241FF05286}" type="datetimeFigureOut">
               <a:rPr lang="en-US" smtClean="0"/>
-              <a:t>8/16/25</a:t>
+              <a:t>3/30/26</a:t>
             </a:fld>
             <a:endParaRPr lang="en-US"/>
           </a:p>
@@ -1260,7 +990,7 @@
           <a:p>
             <a:fld id="{0A85FBF7-6189-C04A-8896-44241FF05286}" type="datetimeFigureOut">
               <a:rPr lang="en-US" smtClean="0"/>
-              <a:t>8/16/25</a:t>
+              <a:t>3/30/26</a:t>
             </a:fld>
             <a:endParaRPr lang="en-US"/>
           </a:p>
@@ -1430,7 +1160,7 @@
           <a:p>
             <a:fld id="{0A85FBF7-6189-C04A-8896-44241FF05286}" type="datetimeFigureOut">
               <a:rPr lang="en-US" smtClean="0"/>
-              <a:t>8/16/25</a:t>
+              <a:t>3/30/26</a:t>
             </a:fld>
             <a:endParaRPr lang="en-US"/>
           </a:p>
@@ -1676,7 +1406,7 @@
           <a:p>
             <a:fld id="{0A85FBF7-6189-C04A-8896-44241FF05286}" type="datetimeFigureOut">
               <a:rPr lang="en-US" smtClean="0"/>
-              <a:t>8/16/25</a:t>
+              <a:t>3/30/26</a:t>
             </a:fld>
             <a:endParaRPr lang="en-US"/>
           </a:p>
@@ -1908,7 +1638,7 @@
           <a:p>
             <a:fld id="{0A85FBF7-6189-C04A-8896-44241FF05286}" type="datetimeFigureOut">
               <a:rPr lang="en-US" smtClean="0"/>
-              <a:t>8/16/25</a:t>
+              <a:t>3/30/26</a:t>
             </a:fld>
             <a:endParaRPr lang="en-US"/>
           </a:p>
@@ -2275,7 +2005,7 @@
           <a:p>
             <a:fld id="{0A85FBF7-6189-C04A-8896-44241FF05286}" type="datetimeFigureOut">
               <a:rPr lang="en-US" smtClean="0"/>
-              <a:t>8/16/25</a:t>
+              <a:t>3/30/26</a:t>
             </a:fld>
             <a:endParaRPr lang="en-US"/>
           </a:p>
@@ -2393,7 +2123,7 @@
           <a:p>
             <a:fld id="{0A85FBF7-6189-C04A-8896-44241FF05286}" type="datetimeFigureOut">
               <a:rPr lang="en-US" smtClean="0"/>
-              <a:t>8/16/25</a:t>
+              <a:t>3/30/26</a:t>
             </a:fld>
             <a:endParaRPr lang="en-US"/>
           </a:p>
@@ -2488,7 +2218,7 @@
           <a:p>
             <a:fld id="{0A85FBF7-6189-C04A-8896-44241FF05286}" type="datetimeFigureOut">
               <a:rPr lang="en-US" smtClean="0"/>
-              <a:t>8/16/25</a:t>
+              <a:t>3/30/26</a:t>
             </a:fld>
             <a:endParaRPr lang="en-US"/>
           </a:p>
@@ -2765,7 +2495,7 @@
           <a:p>
             <a:fld id="{0A85FBF7-6189-C04A-8896-44241FF05286}" type="datetimeFigureOut">
               <a:rPr lang="en-US" smtClean="0"/>
-              <a:t>8/16/25</a:t>
+              <a:t>3/30/26</a:t>
             </a:fld>
             <a:endParaRPr lang="en-US"/>
           </a:p>
@@ -3022,7 +2752,7 @@
           <a:p>
             <a:fld id="{0A85FBF7-6189-C04A-8896-44241FF05286}" type="datetimeFigureOut">
               <a:rPr lang="en-US" smtClean="0"/>
-              <a:t>8/16/25</a:t>
+              <a:t>3/30/26</a:t>
             </a:fld>
             <a:endParaRPr lang="en-US"/>
           </a:p>
@@ -3235,7 +2965,7 @@
           <a:p>
             <a:fld id="{0A85FBF7-6189-C04A-8896-44241FF05286}" type="datetimeFigureOut">
               <a:rPr lang="en-US" smtClean="0"/>
-              <a:t>8/16/25</a:t>
+              <a:t>3/30/26</a:t>
             </a:fld>
             <a:endParaRPr lang="en-US"/>
           </a:p>
@@ -3789,8 +3519,8 @@
         </p:nvSpPr>
         <p:spPr>
           <a:xfrm>
-            <a:off x="13182730" y="-8041"/>
-            <a:ext cx="2131096" cy="492443"/>
+            <a:off x="12443145" y="-8041"/>
+            <a:ext cx="3432735" cy="492443"/>
           </a:xfrm>
           <a:prstGeom prst="rect">
             <a:avLst/>
@@ -3810,7 +3540,7 @@
                 <a:ea typeface="Helvetica Neue Light" panose="02000403000000020004" pitchFamily="2" charset="0"/>
                 <a:cs typeface="Helvetica Neue" panose="02000503000000020004" pitchFamily="2" charset="0"/>
               </a:rPr>
-              <a:t>Environments</a:t>
+              <a:t>Example environments</a:t>
             </a:r>
           </a:p>
         </p:txBody>
@@ -3944,10 +3674,1067 @@
       </p:pic>
       <p:sp>
         <p:nvSpPr>
-          <p:cNvPr id="85" name="Rectangle 84">
-            <a:extLst>
-              <a:ext uri="{FF2B5EF4-FFF2-40B4-BE49-F238E27FC236}">
-                <a16:creationId xmlns:a16="http://schemas.microsoft.com/office/drawing/2014/main" id="{C1960B97-28BF-1A04-BA65-95D4D2C8CD53}"/>
+          <p:cNvPr id="92" name="TextBox 91">
+            <a:extLst>
+              <a:ext uri="{FF2B5EF4-FFF2-40B4-BE49-F238E27FC236}">
+                <a16:creationId xmlns:a16="http://schemas.microsoft.com/office/drawing/2014/main" id="{3E24AE1A-6FD8-435F-CF2F-E0D1552D29A1}"/>
+              </a:ext>
+            </a:extLst>
+          </p:cNvPr>
+          <p:cNvSpPr txBox="1"/>
+          <p:nvPr/>
+        </p:nvSpPr>
+        <p:spPr>
+          <a:xfrm>
+            <a:off x="6423782" y="713773"/>
+            <a:ext cx="891206" cy="646331"/>
+          </a:xfrm>
+          <a:prstGeom prst="rect">
+            <a:avLst/>
+          </a:prstGeom>
+          <a:noFill/>
+        </p:spPr>
+        <p:txBody>
+          <a:bodyPr wrap="none" rtlCol="0">
+            <a:spAutoFit/>
+          </a:bodyPr>
+          <a:lstStyle/>
+          <a:p>
+            <a:pPr algn="l"/>
+            <a:r>
+              <a:rPr lang="en-US" dirty="0">
+                <a:latin typeface="Helvetica Neue Light" panose="02000403000000020004" pitchFamily="2" charset="0"/>
+                <a:ea typeface="Helvetica Neue Light" panose="02000403000000020004" pitchFamily="2" charset="0"/>
+                <a:cs typeface="Helvetica Neue" panose="02000503000000020004" pitchFamily="2" charset="0"/>
+              </a:rPr>
+              <a:t>Tutorial</a:t>
+            </a:r>
+          </a:p>
+          <a:p>
+            <a:pPr algn="l"/>
+            <a:r>
+              <a:rPr lang="en-US" dirty="0">
+                <a:latin typeface="Helvetica Neue Light" panose="02000403000000020004" pitchFamily="2" charset="0"/>
+                <a:ea typeface="Helvetica Neue Light" panose="02000403000000020004" pitchFamily="2" charset="0"/>
+                <a:cs typeface="Helvetica Neue" panose="02000503000000020004" pitchFamily="2" charset="0"/>
+              </a:rPr>
+              <a:t>round</a:t>
+            </a:r>
+          </a:p>
+        </p:txBody>
+      </p:sp>
+      <p:sp>
+        <p:nvSpPr>
+          <p:cNvPr id="93" name="TextBox 92">
+            <a:extLst>
+              <a:ext uri="{FF2B5EF4-FFF2-40B4-BE49-F238E27FC236}">
+                <a16:creationId xmlns:a16="http://schemas.microsoft.com/office/drawing/2014/main" id="{B5BB5E33-EBC4-BE83-BA81-9BF77F7756F4}"/>
+              </a:ext>
+            </a:extLst>
+          </p:cNvPr>
+          <p:cNvSpPr txBox="1"/>
+          <p:nvPr/>
+        </p:nvSpPr>
+        <p:spPr>
+          <a:xfrm>
+            <a:off x="6423782" y="1772136"/>
+            <a:ext cx="1147464" cy="646331"/>
+          </a:xfrm>
+          <a:prstGeom prst="rect">
+            <a:avLst/>
+          </a:prstGeom>
+          <a:noFill/>
+        </p:spPr>
+        <p:txBody>
+          <a:bodyPr wrap="square" rtlCol="0">
+            <a:spAutoFit/>
+          </a:bodyPr>
+          <a:lstStyle/>
+          <a:p>
+            <a:pPr algn="l"/>
+            <a:r>
+              <a:rPr lang="en-US" dirty="0">
+                <a:latin typeface="Helvetica Neue Light" panose="02000403000000020004" pitchFamily="2" charset="0"/>
+                <a:ea typeface="Helvetica Neue Light" panose="02000403000000020004" pitchFamily="2" charset="0"/>
+                <a:cs typeface="Helvetica Neue" panose="02000503000000020004" pitchFamily="2" charset="0"/>
+              </a:rPr>
+              <a:t>8 rounds of search</a:t>
+            </a:r>
+          </a:p>
+        </p:txBody>
+      </p:sp>
+      <p:cxnSp>
+        <p:nvCxnSpPr>
+          <p:cNvPr id="94" name="Straight Arrow Connector 93">
+            <a:extLst>
+              <a:ext uri="{FF2B5EF4-FFF2-40B4-BE49-F238E27FC236}">
+                <a16:creationId xmlns:a16="http://schemas.microsoft.com/office/drawing/2014/main" id="{EE583D75-5A3F-4F00-170A-0D1CE9FC0573}"/>
+              </a:ext>
+            </a:extLst>
+          </p:cNvPr>
+          <p:cNvCxnSpPr>
+            <a:cxnSpLocks/>
+          </p:cNvCxnSpPr>
+          <p:nvPr/>
+        </p:nvCxnSpPr>
+        <p:spPr>
+          <a:xfrm>
+            <a:off x="9557902" y="628800"/>
+            <a:ext cx="2416777" cy="2777280"/>
+          </a:xfrm>
+          <a:prstGeom prst="straightConnector1">
+            <a:avLst/>
+          </a:prstGeom>
+          <a:ln w="34925">
+            <a:solidFill>
+              <a:schemeClr val="tx1"/>
+            </a:solidFill>
+            <a:tailEnd type="triangle" w="lg" len="lg"/>
+          </a:ln>
+        </p:spPr>
+        <p:style>
+          <a:lnRef idx="2">
+            <a:schemeClr val="accent1"/>
+          </a:lnRef>
+          <a:fillRef idx="0">
+            <a:schemeClr val="accent1"/>
+          </a:fillRef>
+          <a:effectRef idx="1">
+            <a:schemeClr val="accent1"/>
+          </a:effectRef>
+          <a:fontRef idx="minor">
+            <a:schemeClr val="tx1"/>
+          </a:fontRef>
+        </p:style>
+      </p:cxnSp>
+      <p:sp>
+        <p:nvSpPr>
+          <p:cNvPr id="95" name="TextBox 94">
+            <a:extLst>
+              <a:ext uri="{FF2B5EF4-FFF2-40B4-BE49-F238E27FC236}">
+                <a16:creationId xmlns:a16="http://schemas.microsoft.com/office/drawing/2014/main" id="{B352BF44-E0FB-FFA5-6917-E9F3F12458A8}"/>
+              </a:ext>
+            </a:extLst>
+          </p:cNvPr>
+          <p:cNvSpPr txBox="1"/>
+          <p:nvPr/>
+        </p:nvSpPr>
+        <p:spPr>
+          <a:xfrm rot="2940000">
+            <a:off x="10253457" y="1580231"/>
+            <a:ext cx="1310029" cy="400110"/>
+          </a:xfrm>
+          <a:prstGeom prst="rect">
+            <a:avLst/>
+          </a:prstGeom>
+          <a:noFill/>
+        </p:spPr>
+        <p:txBody>
+          <a:bodyPr wrap="square" rtlCol="0">
+            <a:spAutoFit/>
+          </a:bodyPr>
+          <a:lstStyle/>
+          <a:p>
+            <a:pPr algn="ctr"/>
+            <a:r>
+              <a:rPr lang="en-US" sz="2000" dirty="0">
+                <a:latin typeface="Helvetica Neue Light" panose="02000403000000020004" pitchFamily="2" charset="0"/>
+                <a:ea typeface="Helvetica Neue Light" panose="02000403000000020004" pitchFamily="2" charset="0"/>
+                <a:cs typeface="Helvetica Neue" panose="02000503000000020004" pitchFamily="2" charset="0"/>
+              </a:rPr>
+              <a:t>Time</a:t>
+            </a:r>
+          </a:p>
+        </p:txBody>
+      </p:sp>
+      <p:sp>
+        <p:nvSpPr>
+          <p:cNvPr id="96" name="TextBox 95">
+            <a:extLst>
+              <a:ext uri="{FF2B5EF4-FFF2-40B4-BE49-F238E27FC236}">
+                <a16:creationId xmlns:a16="http://schemas.microsoft.com/office/drawing/2014/main" id="{4D8DB33C-C41A-C9AF-DCD5-0B38DE49F470}"/>
+              </a:ext>
+            </a:extLst>
+          </p:cNvPr>
+          <p:cNvSpPr txBox="1"/>
+          <p:nvPr/>
+        </p:nvSpPr>
+        <p:spPr>
+          <a:xfrm>
+            <a:off x="6423782" y="2600339"/>
+            <a:ext cx="1764776" cy="646331"/>
+          </a:xfrm>
+          <a:prstGeom prst="rect">
+            <a:avLst/>
+          </a:prstGeom>
+          <a:noFill/>
+        </p:spPr>
+        <p:txBody>
+          <a:bodyPr wrap="square" rtlCol="0">
+            <a:spAutoFit/>
+          </a:bodyPr>
+          <a:lstStyle/>
+          <a:p>
+            <a:pPr algn="l"/>
+            <a:r>
+              <a:rPr lang="en-US" dirty="0">
+                <a:latin typeface="Helvetica Neue Light" panose="02000403000000020004" pitchFamily="2" charset="0"/>
+                <a:ea typeface="Helvetica Neue Light" panose="02000403000000020004" pitchFamily="2" charset="0"/>
+                <a:cs typeface="Helvetica Neue" panose="02000503000000020004" pitchFamily="2" charset="0"/>
+              </a:rPr>
+              <a:t>25 clicks in each round</a:t>
+            </a:r>
+          </a:p>
+        </p:txBody>
+      </p:sp>
+      <p:sp>
+        <p:nvSpPr>
+          <p:cNvPr id="100" name="TextBox 99">
+            <a:extLst>
+              <a:ext uri="{FF2B5EF4-FFF2-40B4-BE49-F238E27FC236}">
+                <a16:creationId xmlns:a16="http://schemas.microsoft.com/office/drawing/2014/main" id="{99FB87C8-70F5-A168-2F03-1FB715C6666F}"/>
+              </a:ext>
+            </a:extLst>
+          </p:cNvPr>
+          <p:cNvSpPr txBox="1"/>
+          <p:nvPr/>
+        </p:nvSpPr>
+        <p:spPr>
+          <a:xfrm>
+            <a:off x="6423782" y="3351654"/>
+            <a:ext cx="1995684" cy="923330"/>
+          </a:xfrm>
+          <a:prstGeom prst="rect">
+            <a:avLst/>
+          </a:prstGeom>
+          <a:noFill/>
+        </p:spPr>
+        <p:txBody>
+          <a:bodyPr wrap="square" rtlCol="0">
+            <a:spAutoFit/>
+          </a:bodyPr>
+          <a:lstStyle/>
+          <a:p>
+            <a:pPr algn="l"/>
+            <a:r>
+              <a:rPr lang="en-US" dirty="0">
+                <a:latin typeface="Helvetica Neue Light" panose="02000403000000020004" pitchFamily="2" charset="0"/>
+                <a:ea typeface="Helvetica Neue Light" panose="02000403000000020004" pitchFamily="2" charset="0"/>
+                <a:cs typeface="Helvetica Neue" panose="02000503000000020004" pitchFamily="2" charset="0"/>
+              </a:rPr>
+              <a:t>”Bonus round” with reward predictions</a:t>
+            </a:r>
+          </a:p>
+        </p:txBody>
+      </p:sp>
+      <p:pic>
+        <p:nvPicPr>
+          <p:cNvPr id="29" name="Picture 28">
+            <a:extLst>
+              <a:ext uri="{FF2B5EF4-FFF2-40B4-BE49-F238E27FC236}">
+                <a16:creationId xmlns:a16="http://schemas.microsoft.com/office/drawing/2014/main" id="{52DFD066-56C8-F401-9824-E63A66FD8DE3}"/>
+              </a:ext>
+            </a:extLst>
+          </p:cNvPr>
+          <p:cNvPicPr>
+            <a:picLocks noChangeAspect="1"/>
+          </p:cNvPicPr>
+          <p:nvPr/>
+        </p:nvPicPr>
+        <p:blipFill>
+          <a:blip r:embed="rId4"/>
+          <a:stretch>
+            <a:fillRect/>
+          </a:stretch>
+        </p:blipFill>
+        <p:spPr>
+          <a:xfrm>
+            <a:off x="14894836" y="3204369"/>
+            <a:ext cx="1036408" cy="1036407"/>
+          </a:xfrm>
+          <a:prstGeom prst="rect">
+            <a:avLst/>
+          </a:prstGeom>
+        </p:spPr>
+      </p:pic>
+      <p:pic>
+        <p:nvPicPr>
+          <p:cNvPr id="30" name="Picture 29">
+            <a:extLst>
+              <a:ext uri="{FF2B5EF4-FFF2-40B4-BE49-F238E27FC236}">
+                <a16:creationId xmlns:a16="http://schemas.microsoft.com/office/drawing/2014/main" id="{E05433B0-B7BA-7A98-207D-239BBB94A262}"/>
+              </a:ext>
+            </a:extLst>
+          </p:cNvPr>
+          <p:cNvPicPr>
+            <a:picLocks noChangeAspect="1"/>
+          </p:cNvPicPr>
+          <p:nvPr/>
+        </p:nvPicPr>
+        <p:blipFill>
+          <a:blip r:embed="rId5"/>
+          <a:stretch>
+            <a:fillRect/>
+          </a:stretch>
+        </p:blipFill>
+        <p:spPr>
+          <a:xfrm>
+            <a:off x="13643256" y="3204369"/>
+            <a:ext cx="1036408" cy="1036407"/>
+          </a:xfrm>
+          <a:prstGeom prst="rect">
+            <a:avLst/>
+          </a:prstGeom>
+        </p:spPr>
+      </p:pic>
+      <p:pic>
+        <p:nvPicPr>
+          <p:cNvPr id="31" name="Picture 30">
+            <a:extLst>
+              <a:ext uri="{FF2B5EF4-FFF2-40B4-BE49-F238E27FC236}">
+                <a16:creationId xmlns:a16="http://schemas.microsoft.com/office/drawing/2014/main" id="{9BCA3DFD-A3F1-CF71-7602-76C4E6EA2C3E}"/>
+              </a:ext>
+            </a:extLst>
+          </p:cNvPr>
+          <p:cNvPicPr>
+            <a:picLocks noChangeAspect="1"/>
+          </p:cNvPicPr>
+          <p:nvPr/>
+        </p:nvPicPr>
+        <p:blipFill>
+          <a:blip r:embed="rId6"/>
+          <a:stretch>
+            <a:fillRect/>
+          </a:stretch>
+        </p:blipFill>
+        <p:spPr>
+          <a:xfrm>
+            <a:off x="12391676" y="3204369"/>
+            <a:ext cx="1036408" cy="1036407"/>
+          </a:xfrm>
+          <a:prstGeom prst="rect">
+            <a:avLst/>
+          </a:prstGeom>
+        </p:spPr>
+      </p:pic>
+      <p:pic>
+        <p:nvPicPr>
+          <p:cNvPr id="32" name="Picture 31">
+            <a:extLst>
+              <a:ext uri="{FF2B5EF4-FFF2-40B4-BE49-F238E27FC236}">
+                <a16:creationId xmlns:a16="http://schemas.microsoft.com/office/drawing/2014/main" id="{83AFEAE7-44F2-8648-F279-9487F0178620}"/>
+              </a:ext>
+            </a:extLst>
+          </p:cNvPr>
+          <p:cNvPicPr>
+            <a:picLocks noChangeAspect="1"/>
+          </p:cNvPicPr>
+          <p:nvPr/>
+        </p:nvPicPr>
+        <p:blipFill>
+          <a:blip r:embed="rId7"/>
+          <a:stretch>
+            <a:fillRect/>
+          </a:stretch>
+        </p:blipFill>
+        <p:spPr>
+          <a:xfrm>
+            <a:off x="14894836" y="640776"/>
+            <a:ext cx="1036408" cy="1036407"/>
+          </a:xfrm>
+          <a:prstGeom prst="rect">
+            <a:avLst/>
+          </a:prstGeom>
+        </p:spPr>
+      </p:pic>
+      <p:pic>
+        <p:nvPicPr>
+          <p:cNvPr id="33" name="Picture 32">
+            <a:extLst>
+              <a:ext uri="{FF2B5EF4-FFF2-40B4-BE49-F238E27FC236}">
+                <a16:creationId xmlns:a16="http://schemas.microsoft.com/office/drawing/2014/main" id="{0546CB74-262E-BA4F-B904-F814BF6D7321}"/>
+              </a:ext>
+            </a:extLst>
+          </p:cNvPr>
+          <p:cNvPicPr>
+            <a:picLocks noChangeAspect="1"/>
+          </p:cNvPicPr>
+          <p:nvPr/>
+        </p:nvPicPr>
+        <p:blipFill>
+          <a:blip r:embed="rId8"/>
+          <a:stretch>
+            <a:fillRect/>
+          </a:stretch>
+        </p:blipFill>
+        <p:spPr>
+          <a:xfrm>
+            <a:off x="14894836" y="1922572"/>
+            <a:ext cx="1036408" cy="1036407"/>
+          </a:xfrm>
+          <a:prstGeom prst="rect">
+            <a:avLst/>
+          </a:prstGeom>
+        </p:spPr>
+      </p:pic>
+      <p:pic>
+        <p:nvPicPr>
+          <p:cNvPr id="34" name="Picture 33">
+            <a:extLst>
+              <a:ext uri="{FF2B5EF4-FFF2-40B4-BE49-F238E27FC236}">
+                <a16:creationId xmlns:a16="http://schemas.microsoft.com/office/drawing/2014/main" id="{386DA79D-F596-D613-92F7-3C0158E99893}"/>
+              </a:ext>
+            </a:extLst>
+          </p:cNvPr>
+          <p:cNvPicPr>
+            <a:picLocks noChangeAspect="1"/>
+          </p:cNvPicPr>
+          <p:nvPr/>
+        </p:nvPicPr>
+        <p:blipFill>
+          <a:blip r:embed="rId9"/>
+          <a:stretch>
+            <a:fillRect/>
+          </a:stretch>
+        </p:blipFill>
+        <p:spPr>
+          <a:xfrm>
+            <a:off x="13643256" y="1922572"/>
+            <a:ext cx="1036408" cy="1036407"/>
+          </a:xfrm>
+          <a:prstGeom prst="rect">
+            <a:avLst/>
+          </a:prstGeom>
+        </p:spPr>
+      </p:pic>
+      <p:pic>
+        <p:nvPicPr>
+          <p:cNvPr id="35" name="Picture 34">
+            <a:extLst>
+              <a:ext uri="{FF2B5EF4-FFF2-40B4-BE49-F238E27FC236}">
+                <a16:creationId xmlns:a16="http://schemas.microsoft.com/office/drawing/2014/main" id="{2E10C79D-1D6D-4A73-621F-8BA18273367D}"/>
+              </a:ext>
+            </a:extLst>
+          </p:cNvPr>
+          <p:cNvPicPr>
+            <a:picLocks noChangeAspect="1"/>
+          </p:cNvPicPr>
+          <p:nvPr/>
+        </p:nvPicPr>
+        <p:blipFill>
+          <a:blip r:embed="rId10"/>
+          <a:stretch>
+            <a:fillRect/>
+          </a:stretch>
+        </p:blipFill>
+        <p:spPr>
+          <a:xfrm>
+            <a:off x="13643256" y="640776"/>
+            <a:ext cx="1036408" cy="1036407"/>
+          </a:xfrm>
+          <a:prstGeom prst="rect">
+            <a:avLst/>
+          </a:prstGeom>
+        </p:spPr>
+      </p:pic>
+      <p:pic>
+        <p:nvPicPr>
+          <p:cNvPr id="36" name="Picture 35">
+            <a:extLst>
+              <a:ext uri="{FF2B5EF4-FFF2-40B4-BE49-F238E27FC236}">
+                <a16:creationId xmlns:a16="http://schemas.microsoft.com/office/drawing/2014/main" id="{E0B13C66-5342-D09E-7AAC-82520DC8C39D}"/>
+              </a:ext>
+            </a:extLst>
+          </p:cNvPr>
+          <p:cNvPicPr>
+            <a:picLocks noChangeAspect="1"/>
+          </p:cNvPicPr>
+          <p:nvPr/>
+        </p:nvPicPr>
+        <p:blipFill>
+          <a:blip r:embed="rId11"/>
+          <a:stretch>
+            <a:fillRect/>
+          </a:stretch>
+        </p:blipFill>
+        <p:spPr>
+          <a:xfrm>
+            <a:off x="12391676" y="1922572"/>
+            <a:ext cx="1036408" cy="1036407"/>
+          </a:xfrm>
+          <a:prstGeom prst="rect">
+            <a:avLst/>
+          </a:prstGeom>
+        </p:spPr>
+      </p:pic>
+      <p:pic>
+        <p:nvPicPr>
+          <p:cNvPr id="37" name="Picture 36">
+            <a:extLst>
+              <a:ext uri="{FF2B5EF4-FFF2-40B4-BE49-F238E27FC236}">
+                <a16:creationId xmlns:a16="http://schemas.microsoft.com/office/drawing/2014/main" id="{AAB0F67F-0AF4-2945-014F-CD1A32645447}"/>
+              </a:ext>
+            </a:extLst>
+          </p:cNvPr>
+          <p:cNvPicPr>
+            <a:picLocks noChangeAspect="1"/>
+          </p:cNvPicPr>
+          <p:nvPr/>
+        </p:nvPicPr>
+        <p:blipFill>
+          <a:blip r:embed="rId12"/>
+          <a:stretch>
+            <a:fillRect/>
+          </a:stretch>
+        </p:blipFill>
+        <p:spPr>
+          <a:xfrm>
+            <a:off x="12391676" y="640776"/>
+            <a:ext cx="1036408" cy="1036407"/>
+          </a:xfrm>
+          <a:prstGeom prst="rect">
+            <a:avLst/>
+          </a:prstGeom>
+        </p:spPr>
+      </p:pic>
+      <p:sp>
+        <p:nvSpPr>
+          <p:cNvPr id="38" name="TextBox 37">
+            <a:extLst>
+              <a:ext uri="{FF2B5EF4-FFF2-40B4-BE49-F238E27FC236}">
+                <a16:creationId xmlns:a16="http://schemas.microsoft.com/office/drawing/2014/main" id="{448CD114-3C19-C02E-BA6B-DD5CD0D288FC}"/>
+              </a:ext>
+            </a:extLst>
+          </p:cNvPr>
+          <p:cNvSpPr txBox="1"/>
+          <p:nvPr/>
+        </p:nvSpPr>
+        <p:spPr>
+          <a:xfrm>
+            <a:off x="2761202" y="1012162"/>
+            <a:ext cx="216000" cy="216000"/>
+          </a:xfrm>
+          <a:prstGeom prst="rect">
+            <a:avLst/>
+          </a:prstGeom>
+          <a:solidFill>
+            <a:srgbClr val="FDD7A1"/>
+          </a:solidFill>
+        </p:spPr>
+        <p:txBody>
+          <a:bodyPr wrap="none" rtlCol="0" anchor="ctr">
+            <a:spAutoFit/>
+          </a:bodyPr>
+          <a:lstStyle/>
+          <a:p>
+            <a:pPr algn="ctr"/>
+            <a:r>
+              <a:rPr lang="en-US" sz="1200" dirty="0"/>
+              <a:t>12</a:t>
+            </a:r>
+          </a:p>
+        </p:txBody>
+      </p:sp>
+      <p:sp>
+        <p:nvSpPr>
+          <p:cNvPr id="39" name="TextBox 38">
+            <a:extLst>
+              <a:ext uri="{FF2B5EF4-FFF2-40B4-BE49-F238E27FC236}">
+                <a16:creationId xmlns:a16="http://schemas.microsoft.com/office/drawing/2014/main" id="{70AEBB63-8371-464C-88DF-09CD8F6461BB}"/>
+              </a:ext>
+            </a:extLst>
+          </p:cNvPr>
+          <p:cNvSpPr txBox="1"/>
+          <p:nvPr/>
+        </p:nvSpPr>
+        <p:spPr>
+          <a:xfrm>
+            <a:off x="2772354" y="1523602"/>
+            <a:ext cx="216000" cy="216000"/>
+          </a:xfrm>
+          <a:prstGeom prst="rect">
+            <a:avLst/>
+          </a:prstGeom>
+          <a:solidFill>
+            <a:srgbClr val="FEE2BC"/>
+          </a:solidFill>
+        </p:spPr>
+        <p:txBody>
+          <a:bodyPr wrap="none" rtlCol="0" anchor="ctr">
+            <a:spAutoFit/>
+          </a:bodyPr>
+          <a:lstStyle/>
+          <a:p>
+            <a:pPr algn="ctr"/>
+            <a:r>
+              <a:rPr lang="en-US" sz="1200" dirty="0"/>
+              <a:t>8</a:t>
+            </a:r>
+          </a:p>
+        </p:txBody>
+      </p:sp>
+      <p:sp>
+        <p:nvSpPr>
+          <p:cNvPr id="40" name="TextBox 39">
+            <a:extLst>
+              <a:ext uri="{FF2B5EF4-FFF2-40B4-BE49-F238E27FC236}">
+                <a16:creationId xmlns:a16="http://schemas.microsoft.com/office/drawing/2014/main" id="{A9ADF8AA-678C-83A0-EAC3-BD2B4D45577A}"/>
+              </a:ext>
+            </a:extLst>
+          </p:cNvPr>
+          <p:cNvSpPr txBox="1"/>
+          <p:nvPr/>
+        </p:nvSpPr>
+        <p:spPr>
+          <a:xfrm>
+            <a:off x="2269254" y="1523602"/>
+            <a:ext cx="216000" cy="180000"/>
+          </a:xfrm>
+          <a:prstGeom prst="rect">
+            <a:avLst/>
+          </a:prstGeom>
+          <a:solidFill>
+            <a:srgbClr val="FEE9C9"/>
+          </a:solidFill>
+        </p:spPr>
+        <p:txBody>
+          <a:bodyPr wrap="none" rtlCol="0" anchor="ctr">
+            <a:spAutoFit/>
+          </a:bodyPr>
+          <a:lstStyle/>
+          <a:p>
+            <a:pPr algn="ctr"/>
+            <a:r>
+              <a:rPr lang="en-US" sz="1200" dirty="0"/>
+              <a:t>6</a:t>
+            </a:r>
+          </a:p>
+        </p:txBody>
+      </p:sp>
+      <p:sp>
+        <p:nvSpPr>
+          <p:cNvPr id="41" name="TextBox 40">
+            <a:extLst>
+              <a:ext uri="{FF2B5EF4-FFF2-40B4-BE49-F238E27FC236}">
+                <a16:creationId xmlns:a16="http://schemas.microsoft.com/office/drawing/2014/main" id="{61D13226-896A-A190-5957-A0CBFA31C357}"/>
+              </a:ext>
+            </a:extLst>
+          </p:cNvPr>
+          <p:cNvSpPr txBox="1"/>
+          <p:nvPr/>
+        </p:nvSpPr>
+        <p:spPr>
+          <a:xfrm>
+            <a:off x="2534050" y="1785862"/>
+            <a:ext cx="216000" cy="180000"/>
+          </a:xfrm>
+          <a:prstGeom prst="rect">
+            <a:avLst/>
+          </a:prstGeom>
+          <a:solidFill>
+            <a:srgbClr val="FEE0B6"/>
+          </a:solidFill>
+        </p:spPr>
+        <p:txBody>
+          <a:bodyPr wrap="none" rtlCol="0" anchor="ctr">
+            <a:noAutofit/>
+          </a:bodyPr>
+          <a:lstStyle/>
+          <a:p>
+            <a:pPr algn="ctr"/>
+            <a:r>
+              <a:rPr lang="en-US" sz="1200" dirty="0"/>
+              <a:t>9</a:t>
+            </a:r>
+          </a:p>
+        </p:txBody>
+      </p:sp>
+      <p:sp>
+        <p:nvSpPr>
+          <p:cNvPr id="42" name="TextBox 41">
+            <a:extLst>
+              <a:ext uri="{FF2B5EF4-FFF2-40B4-BE49-F238E27FC236}">
+                <a16:creationId xmlns:a16="http://schemas.microsoft.com/office/drawing/2014/main" id="{760CF696-3888-E86C-81FD-F695DFE89A32}"/>
+              </a:ext>
+            </a:extLst>
+          </p:cNvPr>
+          <p:cNvSpPr txBox="1"/>
+          <p:nvPr/>
+        </p:nvSpPr>
+        <p:spPr>
+          <a:xfrm>
+            <a:off x="1774256" y="1785862"/>
+            <a:ext cx="216000" cy="180000"/>
+          </a:xfrm>
+          <a:prstGeom prst="rect">
+            <a:avLst/>
+          </a:prstGeom>
+          <a:solidFill>
+            <a:srgbClr val="FDD7A1"/>
+          </a:solidFill>
+        </p:spPr>
+        <p:txBody>
+          <a:bodyPr wrap="none" rtlCol="0" anchor="ctr">
+            <a:noAutofit/>
+          </a:bodyPr>
+          <a:lstStyle/>
+          <a:p>
+            <a:pPr algn="ctr"/>
+            <a:r>
+              <a:rPr lang="en-US" sz="1200" dirty="0"/>
+              <a:t>12</a:t>
+            </a:r>
+          </a:p>
+        </p:txBody>
+      </p:sp>
+      <p:sp>
+        <p:nvSpPr>
+          <p:cNvPr id="43" name="TextBox 42">
+            <a:extLst>
+              <a:ext uri="{FF2B5EF4-FFF2-40B4-BE49-F238E27FC236}">
+                <a16:creationId xmlns:a16="http://schemas.microsoft.com/office/drawing/2014/main" id="{DDA2092D-2AD1-1ABE-62A0-837A0E74BDFA}"/>
+              </a:ext>
+            </a:extLst>
+          </p:cNvPr>
+          <p:cNvSpPr txBox="1"/>
+          <p:nvPr/>
+        </p:nvSpPr>
+        <p:spPr>
+          <a:xfrm>
+            <a:off x="1779783" y="2282785"/>
+            <a:ext cx="216000" cy="180000"/>
+          </a:xfrm>
+          <a:prstGeom prst="rect">
+            <a:avLst/>
+          </a:prstGeom>
+          <a:solidFill>
+            <a:srgbClr val="EC5F43"/>
+          </a:solidFill>
+        </p:spPr>
+        <p:txBody>
+          <a:bodyPr wrap="none" rtlCol="0" anchor="ctr">
+            <a:noAutofit/>
+          </a:bodyPr>
+          <a:lstStyle/>
+          <a:p>
+            <a:pPr algn="ctr"/>
+            <a:r>
+              <a:rPr lang="en-US" sz="1200" dirty="0"/>
+              <a:t>32</a:t>
+            </a:r>
+          </a:p>
+        </p:txBody>
+      </p:sp>
+      <p:sp>
+        <p:nvSpPr>
+          <p:cNvPr id="44" name="TextBox 43">
+            <a:extLst>
+              <a:ext uri="{FF2B5EF4-FFF2-40B4-BE49-F238E27FC236}">
+                <a16:creationId xmlns:a16="http://schemas.microsoft.com/office/drawing/2014/main" id="{F323E07B-5A06-F267-8220-0390F1D57091}"/>
+              </a:ext>
+            </a:extLst>
+          </p:cNvPr>
+          <p:cNvSpPr txBox="1"/>
+          <p:nvPr/>
+        </p:nvSpPr>
+        <p:spPr>
+          <a:xfrm>
+            <a:off x="2764774" y="2282785"/>
+            <a:ext cx="216000" cy="180000"/>
+          </a:xfrm>
+          <a:prstGeom prst="rect">
+            <a:avLst/>
+          </a:prstGeom>
+          <a:solidFill>
+            <a:srgbClr val="FC9460"/>
+          </a:solidFill>
+        </p:spPr>
+        <p:txBody>
+          <a:bodyPr wrap="none" rtlCol="0" anchor="ctr">
+            <a:noAutofit/>
+          </a:bodyPr>
+          <a:lstStyle/>
+          <a:p>
+            <a:pPr algn="ctr"/>
+            <a:r>
+              <a:rPr lang="en-US" sz="1200" dirty="0"/>
+              <a:t>24</a:t>
+            </a:r>
+          </a:p>
+        </p:txBody>
+      </p:sp>
+      <p:sp>
+        <p:nvSpPr>
+          <p:cNvPr id="45" name="TextBox 44">
+            <a:extLst>
+              <a:ext uri="{FF2B5EF4-FFF2-40B4-BE49-F238E27FC236}">
+                <a16:creationId xmlns:a16="http://schemas.microsoft.com/office/drawing/2014/main" id="{98F2BC21-1865-99FF-0648-5627C4C27389}"/>
+              </a:ext>
+            </a:extLst>
+          </p:cNvPr>
+          <p:cNvSpPr txBox="1"/>
+          <p:nvPr/>
+        </p:nvSpPr>
+        <p:spPr>
+          <a:xfrm>
+            <a:off x="1537502" y="2537016"/>
+            <a:ext cx="216000" cy="180000"/>
+          </a:xfrm>
+          <a:prstGeom prst="rect">
+            <a:avLst/>
+          </a:prstGeom>
+          <a:solidFill>
+            <a:srgbClr val="C91D13"/>
+          </a:solidFill>
+        </p:spPr>
+        <p:txBody>
+          <a:bodyPr wrap="none" rtlCol="0" anchor="ctr">
+            <a:noAutofit/>
+          </a:bodyPr>
+          <a:lstStyle/>
+          <a:p>
+            <a:pPr algn="ctr"/>
+            <a:r>
+              <a:rPr lang="en-US" sz="1200" dirty="0"/>
+              <a:t>40</a:t>
+            </a:r>
+          </a:p>
+        </p:txBody>
+      </p:sp>
+      <p:sp>
+        <p:nvSpPr>
+          <p:cNvPr id="46" name="TextBox 45">
+            <a:extLst>
+              <a:ext uri="{FF2B5EF4-FFF2-40B4-BE49-F238E27FC236}">
+                <a16:creationId xmlns:a16="http://schemas.microsoft.com/office/drawing/2014/main" id="{9F58EAA9-DAFB-098A-5368-C11F71E605C2}"/>
+              </a:ext>
+            </a:extLst>
+          </p:cNvPr>
+          <p:cNvSpPr txBox="1"/>
+          <p:nvPr/>
+        </p:nvSpPr>
+        <p:spPr>
+          <a:xfrm>
+            <a:off x="1776673" y="2537016"/>
+            <a:ext cx="216000" cy="180000"/>
+          </a:xfrm>
+          <a:prstGeom prst="rect">
+            <a:avLst/>
+          </a:prstGeom>
+          <a:solidFill>
+            <a:srgbClr val="BD0E08"/>
+          </a:solidFill>
+        </p:spPr>
+        <p:txBody>
+          <a:bodyPr wrap="none" rtlCol="0" anchor="ctr">
+            <a:noAutofit/>
+          </a:bodyPr>
+          <a:lstStyle/>
+          <a:p>
+            <a:pPr algn="ctr"/>
+            <a:r>
+              <a:rPr lang="en-US" sz="1200" dirty="0"/>
+              <a:t>42</a:t>
+            </a:r>
+          </a:p>
+        </p:txBody>
+      </p:sp>
+      <p:sp>
+        <p:nvSpPr>
+          <p:cNvPr id="47" name="TextBox 46">
+            <a:extLst>
+              <a:ext uri="{FF2B5EF4-FFF2-40B4-BE49-F238E27FC236}">
+                <a16:creationId xmlns:a16="http://schemas.microsoft.com/office/drawing/2014/main" id="{7C3862DE-1F5F-3CB4-07A4-A2A0AC47CD6A}"/>
+              </a:ext>
+            </a:extLst>
+          </p:cNvPr>
+          <p:cNvSpPr txBox="1"/>
+          <p:nvPr/>
+        </p:nvSpPr>
+        <p:spPr>
+          <a:xfrm>
+            <a:off x="2277197" y="2537016"/>
+            <a:ext cx="216000" cy="180000"/>
+          </a:xfrm>
+          <a:prstGeom prst="rect">
+            <a:avLst/>
+          </a:prstGeom>
+          <a:solidFill>
+            <a:srgbClr val="E2442F"/>
+          </a:solidFill>
+        </p:spPr>
+        <p:txBody>
+          <a:bodyPr wrap="none" rtlCol="0" anchor="ctr">
+            <a:noAutofit/>
+          </a:bodyPr>
+          <a:lstStyle/>
+          <a:p>
+            <a:pPr algn="ctr"/>
+            <a:r>
+              <a:rPr lang="en-US" sz="1200" dirty="0"/>
+              <a:t>35</a:t>
+            </a:r>
+          </a:p>
+        </p:txBody>
+      </p:sp>
+      <p:sp>
+        <p:nvSpPr>
+          <p:cNvPr id="48" name="TextBox 47">
+            <a:extLst>
+              <a:ext uri="{FF2B5EF4-FFF2-40B4-BE49-F238E27FC236}">
+                <a16:creationId xmlns:a16="http://schemas.microsoft.com/office/drawing/2014/main" id="{CF59F1C9-120F-B885-8620-D6B2621134D8}"/>
+              </a:ext>
+            </a:extLst>
+          </p:cNvPr>
+          <p:cNvSpPr txBox="1"/>
+          <p:nvPr/>
+        </p:nvSpPr>
+        <p:spPr>
+          <a:xfrm>
+            <a:off x="2772354" y="2537016"/>
+            <a:ext cx="216000" cy="180000"/>
+          </a:xfrm>
+          <a:prstGeom prst="rect">
+            <a:avLst/>
+          </a:prstGeom>
+          <a:solidFill>
+            <a:srgbClr val="F5724E"/>
+          </a:solidFill>
+        </p:spPr>
+        <p:txBody>
+          <a:bodyPr wrap="none" rtlCol="0" anchor="ctr">
+            <a:noAutofit/>
+          </a:bodyPr>
+          <a:lstStyle/>
+          <a:p>
+            <a:pPr algn="ctr"/>
+            <a:r>
+              <a:rPr lang="en-US" sz="1200" dirty="0"/>
+              <a:t>29</a:t>
+            </a:r>
+          </a:p>
+        </p:txBody>
+      </p:sp>
+      <p:sp>
+        <p:nvSpPr>
+          <p:cNvPr id="49" name="TextBox 48">
+            <a:extLst>
+              <a:ext uri="{FF2B5EF4-FFF2-40B4-BE49-F238E27FC236}">
+                <a16:creationId xmlns:a16="http://schemas.microsoft.com/office/drawing/2014/main" id="{9B8966E5-28BF-258F-CA2E-93BA17BD83D8}"/>
+              </a:ext>
+            </a:extLst>
+          </p:cNvPr>
+          <p:cNvSpPr txBox="1"/>
+          <p:nvPr/>
+        </p:nvSpPr>
+        <p:spPr>
+          <a:xfrm>
+            <a:off x="1545121" y="2797410"/>
+            <a:ext cx="216000" cy="180000"/>
+          </a:xfrm>
+          <a:prstGeom prst="rect">
+            <a:avLst/>
+          </a:prstGeom>
+          <a:solidFill>
+            <a:srgbClr val="BD0E08"/>
+          </a:solidFill>
+        </p:spPr>
+        <p:txBody>
+          <a:bodyPr wrap="none" rtlCol="0" anchor="ctr">
+            <a:noAutofit/>
+          </a:bodyPr>
+          <a:lstStyle/>
+          <a:p>
+            <a:pPr algn="ctr"/>
+            <a:r>
+              <a:rPr lang="en-US" sz="1200" dirty="0"/>
+              <a:t>42</a:t>
+            </a:r>
+          </a:p>
+        </p:txBody>
+      </p:sp>
+      <p:sp>
+        <p:nvSpPr>
+          <p:cNvPr id="50" name="TextBox 49">
+            <a:extLst>
+              <a:ext uri="{FF2B5EF4-FFF2-40B4-BE49-F238E27FC236}">
+                <a16:creationId xmlns:a16="http://schemas.microsoft.com/office/drawing/2014/main" id="{76AA6E67-C047-6B9E-034C-90BA401825AA}"/>
+              </a:ext>
+            </a:extLst>
+          </p:cNvPr>
+          <p:cNvSpPr txBox="1"/>
+          <p:nvPr/>
+        </p:nvSpPr>
+        <p:spPr>
+          <a:xfrm>
+            <a:off x="1785488" y="2797410"/>
+            <a:ext cx="216000" cy="180000"/>
+          </a:xfrm>
+          <a:prstGeom prst="rect">
+            <a:avLst/>
+          </a:prstGeom>
+          <a:solidFill>
+            <a:srgbClr val="AC0000"/>
+          </a:solidFill>
+        </p:spPr>
+        <p:txBody>
+          <a:bodyPr wrap="none" rtlCol="0" anchor="ctr">
+            <a:noAutofit/>
+          </a:bodyPr>
+          <a:lstStyle/>
+          <a:p>
+            <a:pPr algn="ctr"/>
+            <a:r>
+              <a:rPr lang="en-US" sz="1200" dirty="0"/>
+              <a:t>45</a:t>
+            </a:r>
+          </a:p>
+        </p:txBody>
+      </p:sp>
+      <p:sp>
+        <p:nvSpPr>
+          <p:cNvPr id="51" name="TextBox 50">
+            <a:extLst>
+              <a:ext uri="{FF2B5EF4-FFF2-40B4-BE49-F238E27FC236}">
+                <a16:creationId xmlns:a16="http://schemas.microsoft.com/office/drawing/2014/main" id="{B14A9CC0-2D13-27CF-CD9C-437FE6EBD294}"/>
+              </a:ext>
+            </a:extLst>
+          </p:cNvPr>
+          <p:cNvSpPr txBox="1"/>
+          <p:nvPr/>
+        </p:nvSpPr>
+        <p:spPr>
+          <a:xfrm>
+            <a:off x="2037427" y="2797410"/>
+            <a:ext cx="216000" cy="180000"/>
+          </a:xfrm>
+          <a:prstGeom prst="rect">
+            <a:avLst/>
+          </a:prstGeom>
+          <a:solidFill>
+            <a:srgbClr val="B20100"/>
+          </a:solidFill>
+        </p:spPr>
+        <p:txBody>
+          <a:bodyPr wrap="none" rtlCol="0" anchor="ctr">
+            <a:noAutofit/>
+          </a:bodyPr>
+          <a:lstStyle/>
+          <a:p>
+            <a:pPr algn="ctr"/>
+            <a:r>
+              <a:rPr lang="en-US" sz="1200" dirty="0"/>
+              <a:t>44</a:t>
+            </a:r>
+          </a:p>
+        </p:txBody>
+      </p:sp>
+      <p:sp>
+        <p:nvSpPr>
+          <p:cNvPr id="10" name="Rectangle 9">
+            <a:extLst>
+              <a:ext uri="{FF2B5EF4-FFF2-40B4-BE49-F238E27FC236}">
+                <a16:creationId xmlns:a16="http://schemas.microsoft.com/office/drawing/2014/main" id="{7A0F9339-2E17-CA94-8BAC-4C8559FD84DD}"/>
               </a:ext>
             </a:extLst>
           </p:cNvPr>
@@ -3995,10 +4782,10 @@
       </p:sp>
       <p:sp>
         <p:nvSpPr>
-          <p:cNvPr id="86" name="Rectangle 85">
-            <a:extLst>
-              <a:ext uri="{FF2B5EF4-FFF2-40B4-BE49-F238E27FC236}">
-                <a16:creationId xmlns:a16="http://schemas.microsoft.com/office/drawing/2014/main" id="{C227A0CD-4A06-DF50-F244-0A6B2ED3E7CF}"/>
+          <p:cNvPr id="11" name="Rectangle 10">
+            <a:extLst>
+              <a:ext uri="{FF2B5EF4-FFF2-40B4-BE49-F238E27FC236}">
+                <a16:creationId xmlns:a16="http://schemas.microsoft.com/office/drawing/2014/main" id="{E4260463-B06A-C9DA-E409-ECFFAACD844D}"/>
               </a:ext>
             </a:extLst>
           </p:cNvPr>
@@ -4009,7 +4796,7 @@
         </p:nvSpPr>
         <p:spPr>
           <a:xfrm>
-            <a:off x="8202941" y="1296288"/>
+            <a:off x="8183731" y="1271315"/>
             <a:ext cx="1224000" cy="1224000"/>
           </a:xfrm>
           <a:prstGeom prst="rect">
@@ -4046,10 +4833,10 @@
       </p:sp>
       <p:sp>
         <p:nvSpPr>
-          <p:cNvPr id="87" name="Rectangle 86">
-            <a:extLst>
-              <a:ext uri="{FF2B5EF4-FFF2-40B4-BE49-F238E27FC236}">
-                <a16:creationId xmlns:a16="http://schemas.microsoft.com/office/drawing/2014/main" id="{776649FF-65A7-9588-1976-192CDE45CB20}"/>
+          <p:cNvPr id="12" name="Rectangle 11">
+            <a:extLst>
+              <a:ext uri="{FF2B5EF4-FFF2-40B4-BE49-F238E27FC236}">
+                <a16:creationId xmlns:a16="http://schemas.microsoft.com/office/drawing/2014/main" id="{41B0EEBE-A745-2353-1F94-18EAFABDE46A}"/>
               </a:ext>
             </a:extLst>
           </p:cNvPr>
@@ -4060,7 +4847,7 @@
         </p:nvSpPr>
         <p:spPr>
           <a:xfrm>
-            <a:off x="8476436" y="1573410"/>
+            <a:off x="8438016" y="1523464"/>
             <a:ext cx="1224000" cy="1224000"/>
           </a:xfrm>
           <a:prstGeom prst="rect">
@@ -4097,10 +4884,10 @@
       </p:sp>
       <p:sp>
         <p:nvSpPr>
-          <p:cNvPr id="88" name="Rectangle 87">
-            <a:extLst>
-              <a:ext uri="{FF2B5EF4-FFF2-40B4-BE49-F238E27FC236}">
-                <a16:creationId xmlns:a16="http://schemas.microsoft.com/office/drawing/2014/main" id="{713ED1F4-2010-32D6-E938-E0D71D3F830B}"/>
+          <p:cNvPr id="13" name="Rectangle 12">
+            <a:extLst>
+              <a:ext uri="{FF2B5EF4-FFF2-40B4-BE49-F238E27FC236}">
+                <a16:creationId xmlns:a16="http://schemas.microsoft.com/office/drawing/2014/main" id="{EF77A9EF-A089-7C53-B283-06987BA26505}"/>
               </a:ext>
             </a:extLst>
           </p:cNvPr>
@@ -4111,7 +4898,7 @@
         </p:nvSpPr>
         <p:spPr>
           <a:xfrm>
-            <a:off x="8749931" y="1850532"/>
+            <a:off x="8692301" y="1775613"/>
             <a:ext cx="1224000" cy="1224000"/>
           </a:xfrm>
           <a:prstGeom prst="rect">
@@ -4148,10 +4935,10 @@
       </p:sp>
       <p:sp>
         <p:nvSpPr>
-          <p:cNvPr id="89" name="Rectangle 88">
-            <a:extLst>
-              <a:ext uri="{FF2B5EF4-FFF2-40B4-BE49-F238E27FC236}">
-                <a16:creationId xmlns:a16="http://schemas.microsoft.com/office/drawing/2014/main" id="{9F3DC06C-FAF3-E4D7-537E-1506A017F0A0}"/>
+          <p:cNvPr id="14" name="Rectangle 13">
+            <a:extLst>
+              <a:ext uri="{FF2B5EF4-FFF2-40B4-BE49-F238E27FC236}">
+                <a16:creationId xmlns:a16="http://schemas.microsoft.com/office/drawing/2014/main" id="{5A3E81BD-7E1E-D8A6-9477-78E3AECDEC97}"/>
               </a:ext>
             </a:extLst>
           </p:cNvPr>
@@ -4162,7 +4949,7 @@
         </p:nvSpPr>
         <p:spPr>
           <a:xfrm>
-            <a:off x="9023426" y="2127654"/>
+            <a:off x="8946586" y="2027762"/>
             <a:ext cx="1224000" cy="1224000"/>
           </a:xfrm>
           <a:prstGeom prst="rect">
@@ -4199,10 +4986,10 @@
       </p:sp>
       <p:sp>
         <p:nvSpPr>
-          <p:cNvPr id="90" name="Rectangle 89">
-            <a:extLst>
-              <a:ext uri="{FF2B5EF4-FFF2-40B4-BE49-F238E27FC236}">
-                <a16:creationId xmlns:a16="http://schemas.microsoft.com/office/drawing/2014/main" id="{F483518A-A1EE-FE16-E97F-DED529FA1394}"/>
+          <p:cNvPr id="15" name="Rectangle 14">
+            <a:extLst>
+              <a:ext uri="{FF2B5EF4-FFF2-40B4-BE49-F238E27FC236}">
+                <a16:creationId xmlns:a16="http://schemas.microsoft.com/office/drawing/2014/main" id="{06CFABE1-B30D-63A4-31EE-FE0B9E0A9347}"/>
               </a:ext>
             </a:extLst>
           </p:cNvPr>
@@ -4213,7 +5000,7 @@
         </p:nvSpPr>
         <p:spPr>
           <a:xfrm>
-            <a:off x="9296921" y="2404776"/>
+            <a:off x="9200871" y="2279911"/>
             <a:ext cx="1224000" cy="1224000"/>
           </a:xfrm>
           <a:prstGeom prst="rect">
@@ -4250,10 +5037,10 @@
       </p:sp>
       <p:sp>
         <p:nvSpPr>
-          <p:cNvPr id="91" name="Rectangle 90">
-            <a:extLst>
-              <a:ext uri="{FF2B5EF4-FFF2-40B4-BE49-F238E27FC236}">
-                <a16:creationId xmlns:a16="http://schemas.microsoft.com/office/drawing/2014/main" id="{1176E01C-3CDC-DB8D-AB3D-8BF5904D1941}"/>
+          <p:cNvPr id="16" name="Rectangle 15">
+            <a:extLst>
+              <a:ext uri="{FF2B5EF4-FFF2-40B4-BE49-F238E27FC236}">
+                <a16:creationId xmlns:a16="http://schemas.microsoft.com/office/drawing/2014/main" id="{0A32D9A7-0E48-0F2D-D066-3DCE013B28C5}"/>
               </a:ext>
             </a:extLst>
           </p:cNvPr>
@@ -4264,7 +5051,7 @@
         </p:nvSpPr>
         <p:spPr>
           <a:xfrm>
-            <a:off x="9570416" y="2681898"/>
+            <a:off x="9455156" y="2532060"/>
             <a:ext cx="1224000" cy="1224000"/>
           </a:xfrm>
           <a:prstGeom prst="rect">
@@ -4301,216 +5088,52 @@
       </p:sp>
       <p:sp>
         <p:nvSpPr>
-          <p:cNvPr id="92" name="TextBox 91">
-            <a:extLst>
-              <a:ext uri="{FF2B5EF4-FFF2-40B4-BE49-F238E27FC236}">
-                <a16:creationId xmlns:a16="http://schemas.microsoft.com/office/drawing/2014/main" id="{3E24AE1A-6FD8-435F-CF2F-E0D1552D29A1}"/>
-              </a:ext>
-            </a:extLst>
-          </p:cNvPr>
-          <p:cNvSpPr txBox="1"/>
-          <p:nvPr/>
-        </p:nvSpPr>
-        <p:spPr>
-          <a:xfrm>
-            <a:off x="6423782" y="713773"/>
-            <a:ext cx="891206" cy="646331"/>
-          </a:xfrm>
-          <a:prstGeom prst="rect">
-            <a:avLst/>
-          </a:prstGeom>
-          <a:noFill/>
-        </p:spPr>
-        <p:txBody>
-          <a:bodyPr wrap="none" rtlCol="0">
-            <a:spAutoFit/>
-          </a:bodyPr>
-          <a:lstStyle/>
-          <a:p>
-            <a:pPr algn="l"/>
-            <a:r>
-              <a:rPr lang="en-US" dirty="0">
-                <a:latin typeface="Helvetica Neue Light" panose="02000403000000020004" pitchFamily="2" charset="0"/>
-                <a:ea typeface="Helvetica Neue Light" panose="02000403000000020004" pitchFamily="2" charset="0"/>
-                <a:cs typeface="Helvetica Neue" panose="02000503000000020004" pitchFamily="2" charset="0"/>
-              </a:rPr>
-              <a:t>Tutorial</a:t>
-            </a:r>
-          </a:p>
-          <a:p>
-            <a:pPr algn="l"/>
-            <a:r>
-              <a:rPr lang="en-US" dirty="0">
-                <a:latin typeface="Helvetica Neue Light" panose="02000403000000020004" pitchFamily="2" charset="0"/>
-                <a:ea typeface="Helvetica Neue Light" panose="02000403000000020004" pitchFamily="2" charset="0"/>
-                <a:cs typeface="Helvetica Neue" panose="02000503000000020004" pitchFamily="2" charset="0"/>
-              </a:rPr>
-              <a:t>round</a:t>
-            </a:r>
-          </a:p>
-        </p:txBody>
-      </p:sp>
-      <p:sp>
-        <p:nvSpPr>
-          <p:cNvPr id="93" name="TextBox 92">
-            <a:extLst>
-              <a:ext uri="{FF2B5EF4-FFF2-40B4-BE49-F238E27FC236}">
-                <a16:creationId xmlns:a16="http://schemas.microsoft.com/office/drawing/2014/main" id="{B5BB5E33-EBC4-BE83-BA81-9BF77F7756F4}"/>
-              </a:ext>
-            </a:extLst>
-          </p:cNvPr>
-          <p:cNvSpPr txBox="1"/>
-          <p:nvPr/>
-        </p:nvSpPr>
-        <p:spPr>
-          <a:xfrm>
-            <a:off x="6423782" y="1772136"/>
-            <a:ext cx="1147464" cy="646331"/>
-          </a:xfrm>
-          <a:prstGeom prst="rect">
-            <a:avLst/>
-          </a:prstGeom>
-          <a:noFill/>
-        </p:spPr>
-        <p:txBody>
-          <a:bodyPr wrap="square" rtlCol="0">
-            <a:spAutoFit/>
-          </a:bodyPr>
-          <a:lstStyle/>
-          <a:p>
-            <a:pPr algn="l"/>
-            <a:r>
-              <a:rPr lang="en-US" dirty="0">
-                <a:latin typeface="Helvetica Neue Light" panose="02000403000000020004" pitchFamily="2" charset="0"/>
-                <a:ea typeface="Helvetica Neue Light" panose="02000403000000020004" pitchFamily="2" charset="0"/>
-                <a:cs typeface="Helvetica Neue" panose="02000503000000020004" pitchFamily="2" charset="0"/>
-              </a:rPr>
-              <a:t>8 rounds of search</a:t>
-            </a:r>
-          </a:p>
-        </p:txBody>
-      </p:sp>
-      <p:cxnSp>
-        <p:nvCxnSpPr>
-          <p:cNvPr id="94" name="Straight Arrow Connector 93">
-            <a:extLst>
-              <a:ext uri="{FF2B5EF4-FFF2-40B4-BE49-F238E27FC236}">
-                <a16:creationId xmlns:a16="http://schemas.microsoft.com/office/drawing/2014/main" id="{EE583D75-5A3F-4F00-170A-0D1CE9FC0573}"/>
-              </a:ext>
-            </a:extLst>
-          </p:cNvPr>
-          <p:cNvCxnSpPr>
-            <a:cxnSpLocks/>
-          </p:cNvCxnSpPr>
-          <p:nvPr/>
-        </p:nvCxnSpPr>
-        <p:spPr>
-          <a:xfrm>
-            <a:off x="9557902" y="628800"/>
-            <a:ext cx="2416777" cy="2777280"/>
-          </a:xfrm>
-          <a:prstGeom prst="straightConnector1">
-            <a:avLst/>
-          </a:prstGeom>
-          <a:ln w="34925">
-            <a:solidFill>
-              <a:schemeClr val="tx1"/>
-            </a:solidFill>
-            <a:tailEnd type="triangle" w="lg" len="lg"/>
-          </a:ln>
+          <p:cNvPr id="17" name="Rectangle 16">
+            <a:extLst>
+              <a:ext uri="{FF2B5EF4-FFF2-40B4-BE49-F238E27FC236}">
+                <a16:creationId xmlns:a16="http://schemas.microsoft.com/office/drawing/2014/main" id="{67862164-BD51-DCAA-B114-30766194BA57}"/>
+              </a:ext>
+            </a:extLst>
+          </p:cNvPr>
+          <p:cNvSpPr>
+            <a:spLocks noChangeAspect="1"/>
+          </p:cNvSpPr>
+          <p:nvPr/>
+        </p:nvSpPr>
+        <p:spPr>
+          <a:xfrm>
+            <a:off x="9709441" y="2784209"/>
+            <a:ext cx="1224000" cy="1224000"/>
+          </a:xfrm>
+          <a:prstGeom prst="rect">
+            <a:avLst/>
+          </a:prstGeom>
+          <a:solidFill>
+            <a:schemeClr val="bg1"/>
+          </a:solidFill>
         </p:spPr>
         <p:style>
           <a:lnRef idx="2">
-            <a:schemeClr val="accent1"/>
+            <a:schemeClr val="accent1">
+              <a:shade val="15000"/>
+            </a:schemeClr>
           </a:lnRef>
-          <a:fillRef idx="0">
+          <a:fillRef idx="1">
             <a:schemeClr val="accent1"/>
           </a:fillRef>
-          <a:effectRef idx="1">
+          <a:effectRef idx="0">
             <a:schemeClr val="accent1"/>
           </a:effectRef>
           <a:fontRef idx="minor">
-            <a:schemeClr val="tx1"/>
+            <a:schemeClr val="lt1"/>
           </a:fontRef>
         </p:style>
-      </p:cxnSp>
-      <p:sp>
-        <p:nvSpPr>
-          <p:cNvPr id="95" name="TextBox 94">
-            <a:extLst>
-              <a:ext uri="{FF2B5EF4-FFF2-40B4-BE49-F238E27FC236}">
-                <a16:creationId xmlns:a16="http://schemas.microsoft.com/office/drawing/2014/main" id="{B352BF44-E0FB-FFA5-6917-E9F3F12458A8}"/>
-              </a:ext>
-            </a:extLst>
-          </p:cNvPr>
-          <p:cNvSpPr txBox="1"/>
-          <p:nvPr/>
-        </p:nvSpPr>
-        <p:spPr>
-          <a:xfrm rot="2940000">
-            <a:off x="10253457" y="1580231"/>
-            <a:ext cx="1310029" cy="400110"/>
-          </a:xfrm>
-          <a:prstGeom prst="rect">
-            <a:avLst/>
-          </a:prstGeom>
-          <a:noFill/>
-        </p:spPr>
-        <p:txBody>
-          <a:bodyPr wrap="square" rtlCol="0">
-            <a:spAutoFit/>
-          </a:bodyPr>
+        <p:txBody>
+          <a:bodyPr rtlCol="0" anchor="ctr"/>
           <a:lstStyle/>
           <a:p>
             <a:pPr algn="ctr"/>
-            <a:r>
-              <a:rPr lang="en-US" sz="2000" dirty="0">
-                <a:latin typeface="Helvetica Neue Light" panose="02000403000000020004" pitchFamily="2" charset="0"/>
-                <a:ea typeface="Helvetica Neue Light" panose="02000403000000020004" pitchFamily="2" charset="0"/>
-                <a:cs typeface="Helvetica Neue" panose="02000503000000020004" pitchFamily="2" charset="0"/>
-              </a:rPr>
-              <a:t>Time</a:t>
-            </a:r>
-          </a:p>
-        </p:txBody>
-      </p:sp>
-      <p:sp>
-        <p:nvSpPr>
-          <p:cNvPr id="96" name="TextBox 95">
-            <a:extLst>
-              <a:ext uri="{FF2B5EF4-FFF2-40B4-BE49-F238E27FC236}">
-                <a16:creationId xmlns:a16="http://schemas.microsoft.com/office/drawing/2014/main" id="{4D8DB33C-C41A-C9AF-DCD5-0B38DE49F470}"/>
-              </a:ext>
-            </a:extLst>
-          </p:cNvPr>
-          <p:cNvSpPr txBox="1"/>
-          <p:nvPr/>
-        </p:nvSpPr>
-        <p:spPr>
-          <a:xfrm>
-            <a:off x="6423782" y="2600339"/>
-            <a:ext cx="1764776" cy="646331"/>
-          </a:xfrm>
-          <a:prstGeom prst="rect">
-            <a:avLst/>
-          </a:prstGeom>
-          <a:noFill/>
-        </p:spPr>
-        <p:txBody>
-          <a:bodyPr wrap="square" rtlCol="0">
-            <a:spAutoFit/>
-          </a:bodyPr>
-          <a:lstStyle/>
-          <a:p>
-            <a:pPr algn="l"/>
-            <a:r>
-              <a:rPr lang="en-US" dirty="0">
-                <a:latin typeface="Helvetica Neue Light" panose="02000403000000020004" pitchFamily="2" charset="0"/>
-                <a:ea typeface="Helvetica Neue Light" panose="02000403000000020004" pitchFamily="2" charset="0"/>
-                <a:cs typeface="Helvetica Neue" panose="02000503000000020004" pitchFamily="2" charset="0"/>
-              </a:rPr>
-              <a:t>25 clicks in each round</a:t>
-            </a:r>
+            <a:endParaRPr lang="en-US" dirty="0"/>
           </a:p>
         </p:txBody>
       </p:sp>
@@ -4600,6 +5223,1294 @@
             <p:nvPr/>
           </p:nvPicPr>
           <p:blipFill>
+            <a:blip r:embed="rId13"/>
+            <a:srcRect l="738"/>
+            <a:stretch>
+              <a:fillRect/>
+            </a:stretch>
+          </p:blipFill>
+          <p:spPr>
+            <a:xfrm>
+              <a:off x="15241862" y="25687196"/>
+              <a:ext cx="1188000" cy="1188000"/>
+            </a:xfrm>
+            <a:prstGeom prst="rect">
+              <a:avLst/>
+            </a:prstGeom>
+          </p:spPr>
+        </p:pic>
+      </p:grpSp>
+      <p:sp>
+        <p:nvSpPr>
+          <p:cNvPr id="18" name="TextBox 17">
+            <a:extLst>
+              <a:ext uri="{FF2B5EF4-FFF2-40B4-BE49-F238E27FC236}">
+                <a16:creationId xmlns:a16="http://schemas.microsoft.com/office/drawing/2014/main" id="{E2983378-1CB0-6284-CA59-CD0AE190374C}"/>
+              </a:ext>
+            </a:extLst>
+          </p:cNvPr>
+          <p:cNvSpPr txBox="1"/>
+          <p:nvPr/>
+        </p:nvSpPr>
+        <p:spPr>
+          <a:xfrm>
+            <a:off x="3603320" y="985861"/>
+            <a:ext cx="1014609" cy="407804"/>
+          </a:xfrm>
+          <a:prstGeom prst="rect">
+            <a:avLst/>
+          </a:prstGeom>
+          <a:solidFill>
+            <a:schemeClr val="bg1"/>
+          </a:solidFill>
+        </p:spPr>
+        <p:txBody>
+          <a:bodyPr wrap="square" lIns="36000" tIns="0" rIns="36000" bIns="0" rtlCol="0">
+            <a:spAutoFit/>
+          </a:bodyPr>
+          <a:lstStyle/>
+          <a:p>
+            <a:pPr>
+              <a:spcAft>
+                <a:spcPts val="100"/>
+              </a:spcAft>
+            </a:pPr>
+            <a:r>
+              <a:rPr lang="en-US" sz="600" b="1" dirty="0">
+                <a:solidFill>
+                  <a:srgbClr val="008001"/>
+                </a:solidFill>
+                <a:latin typeface="Arial" panose="020B0604020202020204" pitchFamily="34" charset="0"/>
+                <a:cs typeface="Arial" panose="020B0604020202020204" pitchFamily="34" charset="0"/>
+              </a:rPr>
+              <a:t>Points: 476</a:t>
+            </a:r>
+          </a:p>
+          <a:p>
+            <a:pPr>
+              <a:spcAft>
+                <a:spcPts val="100"/>
+              </a:spcAft>
+            </a:pPr>
+            <a:r>
+              <a:rPr lang="en-US" sz="600" dirty="0">
+                <a:latin typeface="Arial" panose="020B0604020202020204" pitchFamily="34" charset="0"/>
+                <a:cs typeface="Arial" panose="020B0604020202020204" pitchFamily="34" charset="0"/>
+              </a:rPr>
+              <a:t>Remaining rounds: </a:t>
+            </a:r>
+            <a:r>
+              <a:rPr lang="en-US" sz="600" b="1" dirty="0">
+                <a:latin typeface="Arial" panose="020B0604020202020204" pitchFamily="34" charset="0"/>
+                <a:cs typeface="Arial" panose="020B0604020202020204" pitchFamily="34" charset="0"/>
+              </a:rPr>
+              <a:t>8</a:t>
+            </a:r>
+          </a:p>
+          <a:p>
+            <a:pPr>
+              <a:spcAft>
+                <a:spcPts val="100"/>
+              </a:spcAft>
+            </a:pPr>
+            <a:r>
+              <a:rPr lang="en-US" sz="600" dirty="0">
+                <a:latin typeface="Arial" panose="020B0604020202020204" pitchFamily="34" charset="0"/>
+                <a:cs typeface="Arial" panose="020B0604020202020204" pitchFamily="34" charset="0"/>
+              </a:rPr>
+              <a:t>Remaining clicks:</a:t>
+            </a:r>
+            <a:r>
+              <a:rPr lang="en-US" sz="600" b="1" dirty="0">
+                <a:latin typeface="Arial" panose="020B0604020202020204" pitchFamily="34" charset="0"/>
+                <a:cs typeface="Arial" panose="020B0604020202020204" pitchFamily="34" charset="0"/>
+              </a:rPr>
+              <a:t> 10</a:t>
+            </a:r>
+          </a:p>
+          <a:p>
+            <a:pPr>
+              <a:spcAft>
+                <a:spcPts val="100"/>
+              </a:spcAft>
+            </a:pPr>
+            <a:r>
+              <a:rPr lang="en-US" sz="600" b="1" dirty="0">
+                <a:latin typeface="Arial" panose="020B0604020202020204" pitchFamily="34" charset="0"/>
+                <a:cs typeface="Arial" panose="020B0604020202020204" pitchFamily="34" charset="0"/>
+              </a:rPr>
+              <a:t>Stars collected:</a:t>
+            </a:r>
+            <a:endParaRPr lang="en-US" sz="100" b="1" dirty="0">
+              <a:latin typeface="Arial" panose="020B0604020202020204" pitchFamily="34" charset="0"/>
+              <a:cs typeface="Arial" panose="020B0604020202020204" pitchFamily="34" charset="0"/>
+            </a:endParaRPr>
+          </a:p>
+        </p:txBody>
+      </p:sp>
+    </p:spTree>
+    <p:extLst>
+      <p:ext uri="{BB962C8B-B14F-4D97-AF65-F5344CB8AC3E}">
+        <p14:creationId xmlns:p14="http://schemas.microsoft.com/office/powerpoint/2010/main" val="34156375"/>
+      </p:ext>
+    </p:extLst>
+  </p:cSld>
+  <p:clrMapOvr>
+    <a:masterClrMapping/>
+  </p:clrMapOvr>
+</p:sld>
+</file>
+
+<file path=ppt/slides/slide2.xml><?xml version="1.0" encoding="utf-8"?>
+<p:sld xmlns:a="http://schemas.openxmlformats.org/drawingml/2006/main" xmlns:r="http://schemas.openxmlformats.org/officeDocument/2006/relationships" xmlns:p="http://schemas.openxmlformats.org/presentationml/2006/main">
+  <p:cSld>
+    <p:spTree>
+      <p:nvGrpSpPr>
+        <p:cNvPr id="1" name=""/>
+        <p:cNvGrpSpPr/>
+        <p:nvPr/>
+      </p:nvGrpSpPr>
+      <p:grpSpPr>
+        <a:xfrm>
+          <a:off x="0" y="0"/>
+          <a:ext cx="0" cy="0"/>
+          <a:chOff x="0" y="0"/>
+          <a:chExt cx="0" cy="0"/>
+        </a:xfrm>
+      </p:grpSpPr>
+      <p:pic>
+        <p:nvPicPr>
+          <p:cNvPr id="13" name="Image" descr="Image">
+            <a:extLst>
+              <a:ext uri="{FF2B5EF4-FFF2-40B4-BE49-F238E27FC236}">
+                <a16:creationId xmlns:a16="http://schemas.microsoft.com/office/drawing/2014/main" id="{25A8D0D4-0BB2-8654-66F7-0757C94C65A9}"/>
+              </a:ext>
+            </a:extLst>
+          </p:cNvPr>
+          <p:cNvPicPr>
+            <a:picLocks noChangeAspect="1"/>
+          </p:cNvPicPr>
+          <p:nvPr/>
+        </p:nvPicPr>
+        <p:blipFill>
+          <a:blip r:embed="rId2"/>
+          <a:stretch>
+            <a:fillRect/>
+          </a:stretch>
+        </p:blipFill>
+        <p:spPr>
+          <a:xfrm>
+            <a:off x="1460211" y="951213"/>
+            <a:ext cx="3051365" cy="2109558"/>
+          </a:xfrm>
+          <a:prstGeom prst="rect">
+            <a:avLst/>
+          </a:prstGeom>
+          <a:ln w="12700" cap="flat">
+            <a:noFill/>
+            <a:miter lim="400000"/>
+          </a:ln>
+          <a:effectLst/>
+        </p:spPr>
+      </p:pic>
+      <p:sp>
+        <p:nvSpPr>
+          <p:cNvPr id="15" name="TextBox 14">
+            <a:extLst>
+              <a:ext uri="{FF2B5EF4-FFF2-40B4-BE49-F238E27FC236}">
+                <a16:creationId xmlns:a16="http://schemas.microsoft.com/office/drawing/2014/main" id="{7312DAE1-2B18-54AB-3FF3-CCF983A71FFE}"/>
+              </a:ext>
+            </a:extLst>
+          </p:cNvPr>
+          <p:cNvSpPr txBox="1"/>
+          <p:nvPr/>
+        </p:nvSpPr>
+        <p:spPr>
+          <a:xfrm>
+            <a:off x="3603320" y="985861"/>
+            <a:ext cx="1014609" cy="407804"/>
+          </a:xfrm>
+          <a:prstGeom prst="rect">
+            <a:avLst/>
+          </a:prstGeom>
+          <a:solidFill>
+            <a:schemeClr val="bg1"/>
+          </a:solidFill>
+        </p:spPr>
+        <p:txBody>
+          <a:bodyPr wrap="square" lIns="36000" tIns="0" rIns="36000" bIns="0" rtlCol="0">
+            <a:spAutoFit/>
+          </a:bodyPr>
+          <a:lstStyle/>
+          <a:p>
+            <a:pPr>
+              <a:spcAft>
+                <a:spcPts val="100"/>
+              </a:spcAft>
+            </a:pPr>
+            <a:r>
+              <a:rPr lang="en-US" sz="600" b="1" dirty="0">
+                <a:solidFill>
+                  <a:srgbClr val="008001"/>
+                </a:solidFill>
+                <a:latin typeface="Arial" panose="020B0604020202020204" pitchFamily="34" charset="0"/>
+                <a:cs typeface="Arial" panose="020B0604020202020204" pitchFamily="34" charset="0"/>
+              </a:rPr>
+              <a:t>Points: 476</a:t>
+            </a:r>
+          </a:p>
+          <a:p>
+            <a:pPr>
+              <a:spcAft>
+                <a:spcPts val="100"/>
+              </a:spcAft>
+            </a:pPr>
+            <a:r>
+              <a:rPr lang="en-US" sz="600" dirty="0">
+                <a:latin typeface="Arial" panose="020B0604020202020204" pitchFamily="34" charset="0"/>
+                <a:cs typeface="Arial" panose="020B0604020202020204" pitchFamily="34" charset="0"/>
+              </a:rPr>
+              <a:t>Remaining rounds: </a:t>
+            </a:r>
+            <a:r>
+              <a:rPr lang="en-US" sz="600" b="1" dirty="0">
+                <a:latin typeface="Arial" panose="020B0604020202020204" pitchFamily="34" charset="0"/>
+                <a:cs typeface="Arial" panose="020B0604020202020204" pitchFamily="34" charset="0"/>
+              </a:rPr>
+              <a:t>8</a:t>
+            </a:r>
+          </a:p>
+          <a:p>
+            <a:pPr>
+              <a:spcAft>
+                <a:spcPts val="100"/>
+              </a:spcAft>
+            </a:pPr>
+            <a:r>
+              <a:rPr lang="en-US" sz="600" dirty="0">
+                <a:latin typeface="Arial" panose="020B0604020202020204" pitchFamily="34" charset="0"/>
+                <a:cs typeface="Arial" panose="020B0604020202020204" pitchFamily="34" charset="0"/>
+              </a:rPr>
+              <a:t>Remaining clicks:</a:t>
+            </a:r>
+            <a:r>
+              <a:rPr lang="en-US" sz="600" b="1" dirty="0">
+                <a:latin typeface="Arial" panose="020B0604020202020204" pitchFamily="34" charset="0"/>
+                <a:cs typeface="Arial" panose="020B0604020202020204" pitchFamily="34" charset="0"/>
+              </a:rPr>
+              <a:t> 10</a:t>
+            </a:r>
+          </a:p>
+          <a:p>
+            <a:pPr>
+              <a:spcAft>
+                <a:spcPts val="100"/>
+              </a:spcAft>
+            </a:pPr>
+            <a:r>
+              <a:rPr lang="en-US" sz="600" b="1" dirty="0">
+                <a:latin typeface="Arial" panose="020B0604020202020204" pitchFamily="34" charset="0"/>
+                <a:cs typeface="Arial" panose="020B0604020202020204" pitchFamily="34" charset="0"/>
+              </a:rPr>
+              <a:t>Stars collected:</a:t>
+            </a:r>
+            <a:endParaRPr lang="en-US" sz="100" b="1" dirty="0">
+              <a:latin typeface="Arial" panose="020B0604020202020204" pitchFamily="34" charset="0"/>
+              <a:cs typeface="Arial" panose="020B0604020202020204" pitchFamily="34" charset="0"/>
+            </a:endParaRPr>
+          </a:p>
+        </p:txBody>
+      </p:sp>
+    </p:spTree>
+    <p:extLst>
+      <p:ext uri="{BB962C8B-B14F-4D97-AF65-F5344CB8AC3E}">
+        <p14:creationId xmlns:p14="http://schemas.microsoft.com/office/powerpoint/2010/main" val="598453788"/>
+      </p:ext>
+    </p:extLst>
+  </p:cSld>
+  <p:clrMapOvr>
+    <a:masterClrMapping/>
+  </p:clrMapOvr>
+</p:sld>
+</file>
+
+<file path=ppt/slides/slide3.xml><?xml version="1.0" encoding="utf-8"?>
+<p:sld xmlns:a="http://schemas.openxmlformats.org/drawingml/2006/main" xmlns:r="http://schemas.openxmlformats.org/officeDocument/2006/relationships" xmlns:p="http://schemas.openxmlformats.org/presentationml/2006/main">
+  <p:cSld>
+    <p:spTree>
+      <p:nvGrpSpPr>
+        <p:cNvPr id="1" name="">
+          <a:extLst>
+            <a:ext uri="{FF2B5EF4-FFF2-40B4-BE49-F238E27FC236}">
+              <a16:creationId xmlns:a16="http://schemas.microsoft.com/office/drawing/2014/main" id="{1A0966BD-303B-9D45-E950-E8F0B34AC3EB}"/>
+            </a:ext>
+          </a:extLst>
+        </p:cNvPr>
+        <p:cNvGrpSpPr/>
+        <p:nvPr/>
+      </p:nvGrpSpPr>
+      <p:grpSpPr>
+        <a:xfrm>
+          <a:off x="0" y="0"/>
+          <a:ext cx="0" cy="0"/>
+          <a:chOff x="0" y="0"/>
+          <a:chExt cx="0" cy="0"/>
+        </a:xfrm>
+      </p:grpSpPr>
+      <p:grpSp>
+        <p:nvGrpSpPr>
+          <p:cNvPr id="77" name="Group 76">
+            <a:extLst>
+              <a:ext uri="{FF2B5EF4-FFF2-40B4-BE49-F238E27FC236}">
+                <a16:creationId xmlns:a16="http://schemas.microsoft.com/office/drawing/2014/main" id="{A67A5284-A046-908D-489F-050C0C64257D}"/>
+              </a:ext>
+            </a:extLst>
+          </p:cNvPr>
+          <p:cNvGrpSpPr>
+            <a:grpSpLocks noChangeAspect="1"/>
+          </p:cNvGrpSpPr>
+          <p:nvPr/>
+        </p:nvGrpSpPr>
+        <p:grpSpPr>
+          <a:xfrm>
+            <a:off x="0" y="439773"/>
+            <a:ext cx="6058691" cy="3815861"/>
+            <a:chOff x="231563" y="2575404"/>
+            <a:chExt cx="4962849" cy="3125682"/>
+          </a:xfrm>
+        </p:grpSpPr>
+        <p:pic>
+          <p:nvPicPr>
+            <p:cNvPr id="78" name="Picture 77">
+              <a:extLst>
+                <a:ext uri="{FF2B5EF4-FFF2-40B4-BE49-F238E27FC236}">
+                  <a16:creationId xmlns:a16="http://schemas.microsoft.com/office/drawing/2014/main" id="{DE9A304F-C980-BC03-FDBB-9215271EADE9}"/>
+                </a:ext>
+              </a:extLst>
+            </p:cNvPr>
+            <p:cNvPicPr>
+              <a:picLocks noChangeAspect="1"/>
+            </p:cNvPicPr>
+            <p:nvPr/>
+          </p:nvPicPr>
+          <p:blipFill>
+            <a:blip r:embed="rId2"/>
+            <a:srcRect l="6664" t="21611" r="5353" b="22976"/>
+            <a:stretch>
+              <a:fillRect/>
+            </a:stretch>
+          </p:blipFill>
+          <p:spPr>
+            <a:xfrm>
+              <a:off x="231563" y="2575404"/>
+              <a:ext cx="4962849" cy="3125682"/>
+            </a:xfrm>
+            <a:prstGeom prst="rect">
+              <a:avLst/>
+            </a:prstGeom>
+          </p:spPr>
+        </p:pic>
+        <p:pic>
+          <p:nvPicPr>
+            <p:cNvPr id="79" name="Image" descr="Image">
+              <a:extLst>
+                <a:ext uri="{FF2B5EF4-FFF2-40B4-BE49-F238E27FC236}">
+                  <a16:creationId xmlns:a16="http://schemas.microsoft.com/office/drawing/2014/main" id="{2C3F5DD5-8B9C-2F15-D257-4B3D272B4350}"/>
+                </a:ext>
+              </a:extLst>
+            </p:cNvPr>
+            <p:cNvPicPr>
+              <a:picLocks noChangeAspect="1"/>
+            </p:cNvPicPr>
+            <p:nvPr/>
+          </p:nvPicPr>
+          <p:blipFill>
+            <a:blip r:embed="rId3"/>
+            <a:stretch>
+              <a:fillRect/>
+            </a:stretch>
+          </p:blipFill>
+          <p:spPr>
+            <a:xfrm>
+              <a:off x="1427664" y="2994339"/>
+              <a:ext cx="2499461" cy="1728000"/>
+            </a:xfrm>
+            <a:prstGeom prst="rect">
+              <a:avLst/>
+            </a:prstGeom>
+            <a:ln w="12700" cap="flat">
+              <a:noFill/>
+              <a:miter lim="400000"/>
+            </a:ln>
+            <a:effectLst/>
+          </p:spPr>
+        </p:pic>
+      </p:grpSp>
+      <p:sp>
+        <p:nvSpPr>
+          <p:cNvPr id="80" name="TextBox 79">
+            <a:extLst>
+              <a:ext uri="{FF2B5EF4-FFF2-40B4-BE49-F238E27FC236}">
+                <a16:creationId xmlns:a16="http://schemas.microsoft.com/office/drawing/2014/main" id="{58445B30-DE05-7C48-0E4E-F14FDAC36D2C}"/>
+              </a:ext>
+            </a:extLst>
+          </p:cNvPr>
+          <p:cNvSpPr txBox="1"/>
+          <p:nvPr/>
+        </p:nvSpPr>
+        <p:spPr>
+          <a:xfrm>
+            <a:off x="2508719" y="-8041"/>
+            <a:ext cx="857799" cy="492443"/>
+          </a:xfrm>
+          <a:prstGeom prst="rect">
+            <a:avLst/>
+          </a:prstGeom>
+          <a:noFill/>
+        </p:spPr>
+        <p:txBody>
+          <a:bodyPr wrap="none" rtlCol="0">
+            <a:spAutoFit/>
+          </a:bodyPr>
+          <a:lstStyle/>
+          <a:p>
+            <a:pPr algn="l"/>
+            <a:r>
+              <a:rPr lang="en-US" sz="2600" dirty="0">
+                <a:latin typeface="Helvetica Neue Light" panose="02000403000000020004" pitchFamily="2" charset="0"/>
+                <a:ea typeface="Helvetica Neue Light" panose="02000403000000020004" pitchFamily="2" charset="0"/>
+                <a:cs typeface="Helvetica Neue" panose="02000503000000020004" pitchFamily="2" charset="0"/>
+              </a:rPr>
+              <a:t>Task</a:t>
+            </a:r>
+          </a:p>
+        </p:txBody>
+      </p:sp>
+      <p:sp>
+        <p:nvSpPr>
+          <p:cNvPr id="81" name="TextBox 80">
+            <a:extLst>
+              <a:ext uri="{FF2B5EF4-FFF2-40B4-BE49-F238E27FC236}">
+                <a16:creationId xmlns:a16="http://schemas.microsoft.com/office/drawing/2014/main" id="{FDA91C4A-60CE-0EB8-538E-AA6BB8D30889}"/>
+              </a:ext>
+            </a:extLst>
+          </p:cNvPr>
+          <p:cNvSpPr txBox="1"/>
+          <p:nvPr/>
+        </p:nvSpPr>
+        <p:spPr>
+          <a:xfrm>
+            <a:off x="13182730" y="-8041"/>
+            <a:ext cx="2131096" cy="492443"/>
+          </a:xfrm>
+          <a:prstGeom prst="rect">
+            <a:avLst/>
+          </a:prstGeom>
+          <a:noFill/>
+        </p:spPr>
+        <p:txBody>
+          <a:bodyPr wrap="none" rtlCol="0">
+            <a:spAutoFit/>
+          </a:bodyPr>
+          <a:lstStyle/>
+          <a:p>
+            <a:pPr algn="l"/>
+            <a:r>
+              <a:rPr lang="en-US" sz="2600" dirty="0">
+                <a:latin typeface="Helvetica Neue Light" panose="02000403000000020004" pitchFamily="2" charset="0"/>
+                <a:ea typeface="Helvetica Neue Light" panose="02000403000000020004" pitchFamily="2" charset="0"/>
+                <a:cs typeface="Helvetica Neue" panose="02000503000000020004" pitchFamily="2" charset="0"/>
+              </a:rPr>
+              <a:t>Environments</a:t>
+            </a:r>
+          </a:p>
+        </p:txBody>
+      </p:sp>
+      <p:sp>
+        <p:nvSpPr>
+          <p:cNvPr id="82" name="TextBox 81">
+            <a:extLst>
+              <a:ext uri="{FF2B5EF4-FFF2-40B4-BE49-F238E27FC236}">
+                <a16:creationId xmlns:a16="http://schemas.microsoft.com/office/drawing/2014/main" id="{86F78DDD-40DA-F689-5D57-ABC8225D0F86}"/>
+              </a:ext>
+            </a:extLst>
+          </p:cNvPr>
+          <p:cNvSpPr txBox="1"/>
+          <p:nvPr/>
+        </p:nvSpPr>
+        <p:spPr>
+          <a:xfrm>
+            <a:off x="8018304" y="-8041"/>
+            <a:ext cx="1722716" cy="492443"/>
+          </a:xfrm>
+          <a:prstGeom prst="rect">
+            <a:avLst/>
+          </a:prstGeom>
+          <a:noFill/>
+        </p:spPr>
+        <p:txBody>
+          <a:bodyPr wrap="none" rtlCol="0">
+            <a:spAutoFit/>
+          </a:bodyPr>
+          <a:lstStyle/>
+          <a:p>
+            <a:pPr algn="l"/>
+            <a:r>
+              <a:rPr lang="en-US" sz="2600" dirty="0">
+                <a:latin typeface="Helvetica Neue Light" panose="02000403000000020004" pitchFamily="2" charset="0"/>
+                <a:ea typeface="Helvetica Neue Light" panose="02000403000000020004" pitchFamily="2" charset="0"/>
+                <a:cs typeface="Helvetica Neue" panose="02000503000000020004" pitchFamily="2" charset="0"/>
+              </a:rPr>
+              <a:t>Procedure</a:t>
+            </a:r>
+          </a:p>
+        </p:txBody>
+      </p:sp>
+      <p:sp>
+        <p:nvSpPr>
+          <p:cNvPr id="83" name="Rectangle 82">
+            <a:extLst>
+              <a:ext uri="{FF2B5EF4-FFF2-40B4-BE49-F238E27FC236}">
+                <a16:creationId xmlns:a16="http://schemas.microsoft.com/office/drawing/2014/main" id="{B6D86320-722E-7357-17B2-6F4A7AA7AF66}"/>
+              </a:ext>
+            </a:extLst>
+          </p:cNvPr>
+          <p:cNvSpPr>
+            <a:spLocks noChangeAspect="1"/>
+          </p:cNvSpPr>
+          <p:nvPr/>
+        </p:nvSpPr>
+        <p:spPr>
+          <a:xfrm>
+            <a:off x="7469743" y="628800"/>
+            <a:ext cx="1224000" cy="1224000"/>
+          </a:xfrm>
+          <a:prstGeom prst="rect">
+            <a:avLst/>
+          </a:prstGeom>
+          <a:solidFill>
+            <a:schemeClr val="bg1"/>
+          </a:solidFill>
+        </p:spPr>
+        <p:style>
+          <a:lnRef idx="2">
+            <a:schemeClr val="accent1">
+              <a:shade val="15000"/>
+            </a:schemeClr>
+          </a:lnRef>
+          <a:fillRef idx="1">
+            <a:schemeClr val="accent1"/>
+          </a:fillRef>
+          <a:effectRef idx="0">
+            <a:schemeClr val="accent1"/>
+          </a:effectRef>
+          <a:fontRef idx="minor">
+            <a:schemeClr val="lt1"/>
+          </a:fontRef>
+        </p:style>
+        <p:txBody>
+          <a:bodyPr rtlCol="0" anchor="ctr"/>
+          <a:lstStyle/>
+          <a:p>
+            <a:pPr algn="ctr"/>
+            <a:endParaRPr lang="en-US" dirty="0"/>
+          </a:p>
+        </p:txBody>
+      </p:sp>
+      <p:pic>
+        <p:nvPicPr>
+          <p:cNvPr id="84" name="Image" descr="Image">
+            <a:extLst>
+              <a:ext uri="{FF2B5EF4-FFF2-40B4-BE49-F238E27FC236}">
+                <a16:creationId xmlns:a16="http://schemas.microsoft.com/office/drawing/2014/main" id="{7E9BE874-E4FA-E792-44C0-83DF8B3A79F7}"/>
+              </a:ext>
+            </a:extLst>
+          </p:cNvPr>
+          <p:cNvPicPr>
+            <a:picLocks noChangeAspect="1"/>
+          </p:cNvPicPr>
+          <p:nvPr/>
+        </p:nvPicPr>
+        <p:blipFill>
+          <a:blip r:embed="rId3"/>
+          <a:srcRect l="1194" t="1330" r="32651" b="1508"/>
+          <a:stretch>
+            <a:fillRect/>
+          </a:stretch>
+        </p:blipFill>
+        <p:spPr>
+          <a:xfrm>
+            <a:off x="7490577" y="655443"/>
+            <a:ext cx="1188000" cy="1188000"/>
+          </a:xfrm>
+          <a:prstGeom prst="rect">
+            <a:avLst/>
+          </a:prstGeom>
+          <a:ln w="12700" cap="flat">
+            <a:noFill/>
+            <a:miter lim="400000"/>
+          </a:ln>
+          <a:effectLst/>
+        </p:spPr>
+      </p:pic>
+      <p:sp>
+        <p:nvSpPr>
+          <p:cNvPr id="85" name="Rectangle 84">
+            <a:extLst>
+              <a:ext uri="{FF2B5EF4-FFF2-40B4-BE49-F238E27FC236}">
+                <a16:creationId xmlns:a16="http://schemas.microsoft.com/office/drawing/2014/main" id="{6AAF86B2-9F73-4989-6F23-53EFA12FAF93}"/>
+              </a:ext>
+            </a:extLst>
+          </p:cNvPr>
+          <p:cNvSpPr>
+            <a:spLocks noChangeAspect="1"/>
+          </p:cNvSpPr>
+          <p:nvPr/>
+        </p:nvSpPr>
+        <p:spPr>
+          <a:xfrm>
+            <a:off x="7929446" y="1019166"/>
+            <a:ext cx="1224000" cy="1224000"/>
+          </a:xfrm>
+          <a:prstGeom prst="rect">
+            <a:avLst/>
+          </a:prstGeom>
+          <a:solidFill>
+            <a:schemeClr val="bg1"/>
+          </a:solidFill>
+        </p:spPr>
+        <p:style>
+          <a:lnRef idx="2">
+            <a:schemeClr val="accent1">
+              <a:shade val="15000"/>
+            </a:schemeClr>
+          </a:lnRef>
+          <a:fillRef idx="1">
+            <a:schemeClr val="accent1"/>
+          </a:fillRef>
+          <a:effectRef idx="0">
+            <a:schemeClr val="accent1"/>
+          </a:effectRef>
+          <a:fontRef idx="minor">
+            <a:schemeClr val="lt1"/>
+          </a:fontRef>
+        </p:style>
+        <p:txBody>
+          <a:bodyPr rtlCol="0" anchor="ctr"/>
+          <a:lstStyle/>
+          <a:p>
+            <a:pPr algn="ctr"/>
+            <a:endParaRPr lang="en-US" dirty="0"/>
+          </a:p>
+        </p:txBody>
+      </p:sp>
+      <p:sp>
+        <p:nvSpPr>
+          <p:cNvPr id="86" name="Rectangle 85">
+            <a:extLst>
+              <a:ext uri="{FF2B5EF4-FFF2-40B4-BE49-F238E27FC236}">
+                <a16:creationId xmlns:a16="http://schemas.microsoft.com/office/drawing/2014/main" id="{86257324-ECCA-C959-68D5-CD7A13CB2536}"/>
+              </a:ext>
+            </a:extLst>
+          </p:cNvPr>
+          <p:cNvSpPr>
+            <a:spLocks noChangeAspect="1"/>
+          </p:cNvSpPr>
+          <p:nvPr/>
+        </p:nvSpPr>
+        <p:spPr>
+          <a:xfrm>
+            <a:off x="8202941" y="1296288"/>
+            <a:ext cx="1224000" cy="1224000"/>
+          </a:xfrm>
+          <a:prstGeom prst="rect">
+            <a:avLst/>
+          </a:prstGeom>
+          <a:solidFill>
+            <a:schemeClr val="bg1"/>
+          </a:solidFill>
+        </p:spPr>
+        <p:style>
+          <a:lnRef idx="2">
+            <a:schemeClr val="accent1">
+              <a:shade val="15000"/>
+            </a:schemeClr>
+          </a:lnRef>
+          <a:fillRef idx="1">
+            <a:schemeClr val="accent1"/>
+          </a:fillRef>
+          <a:effectRef idx="0">
+            <a:schemeClr val="accent1"/>
+          </a:effectRef>
+          <a:fontRef idx="minor">
+            <a:schemeClr val="lt1"/>
+          </a:fontRef>
+        </p:style>
+        <p:txBody>
+          <a:bodyPr rtlCol="0" anchor="ctr"/>
+          <a:lstStyle/>
+          <a:p>
+            <a:pPr algn="ctr"/>
+            <a:endParaRPr lang="en-US" dirty="0"/>
+          </a:p>
+        </p:txBody>
+      </p:sp>
+      <p:sp>
+        <p:nvSpPr>
+          <p:cNvPr id="87" name="Rectangle 86">
+            <a:extLst>
+              <a:ext uri="{FF2B5EF4-FFF2-40B4-BE49-F238E27FC236}">
+                <a16:creationId xmlns:a16="http://schemas.microsoft.com/office/drawing/2014/main" id="{21185B21-EB6D-7071-ECCB-A3FC603A3674}"/>
+              </a:ext>
+            </a:extLst>
+          </p:cNvPr>
+          <p:cNvSpPr>
+            <a:spLocks noChangeAspect="1"/>
+          </p:cNvSpPr>
+          <p:nvPr/>
+        </p:nvSpPr>
+        <p:spPr>
+          <a:xfrm>
+            <a:off x="8476436" y="1573410"/>
+            <a:ext cx="1224000" cy="1224000"/>
+          </a:xfrm>
+          <a:prstGeom prst="rect">
+            <a:avLst/>
+          </a:prstGeom>
+          <a:solidFill>
+            <a:schemeClr val="bg1"/>
+          </a:solidFill>
+        </p:spPr>
+        <p:style>
+          <a:lnRef idx="2">
+            <a:schemeClr val="accent1">
+              <a:shade val="15000"/>
+            </a:schemeClr>
+          </a:lnRef>
+          <a:fillRef idx="1">
+            <a:schemeClr val="accent1"/>
+          </a:fillRef>
+          <a:effectRef idx="0">
+            <a:schemeClr val="accent1"/>
+          </a:effectRef>
+          <a:fontRef idx="minor">
+            <a:schemeClr val="lt1"/>
+          </a:fontRef>
+        </p:style>
+        <p:txBody>
+          <a:bodyPr rtlCol="0" anchor="ctr"/>
+          <a:lstStyle/>
+          <a:p>
+            <a:pPr algn="ctr"/>
+            <a:endParaRPr lang="en-US" dirty="0"/>
+          </a:p>
+        </p:txBody>
+      </p:sp>
+      <p:sp>
+        <p:nvSpPr>
+          <p:cNvPr id="88" name="Rectangle 87">
+            <a:extLst>
+              <a:ext uri="{FF2B5EF4-FFF2-40B4-BE49-F238E27FC236}">
+                <a16:creationId xmlns:a16="http://schemas.microsoft.com/office/drawing/2014/main" id="{E5538B35-54A3-EA78-19CF-E74617CD6FE0}"/>
+              </a:ext>
+            </a:extLst>
+          </p:cNvPr>
+          <p:cNvSpPr>
+            <a:spLocks noChangeAspect="1"/>
+          </p:cNvSpPr>
+          <p:nvPr/>
+        </p:nvSpPr>
+        <p:spPr>
+          <a:xfrm>
+            <a:off x="8749931" y="1850532"/>
+            <a:ext cx="1224000" cy="1224000"/>
+          </a:xfrm>
+          <a:prstGeom prst="rect">
+            <a:avLst/>
+          </a:prstGeom>
+          <a:solidFill>
+            <a:schemeClr val="bg1"/>
+          </a:solidFill>
+        </p:spPr>
+        <p:style>
+          <a:lnRef idx="2">
+            <a:schemeClr val="accent1">
+              <a:shade val="15000"/>
+            </a:schemeClr>
+          </a:lnRef>
+          <a:fillRef idx="1">
+            <a:schemeClr val="accent1"/>
+          </a:fillRef>
+          <a:effectRef idx="0">
+            <a:schemeClr val="accent1"/>
+          </a:effectRef>
+          <a:fontRef idx="minor">
+            <a:schemeClr val="lt1"/>
+          </a:fontRef>
+        </p:style>
+        <p:txBody>
+          <a:bodyPr rtlCol="0" anchor="ctr"/>
+          <a:lstStyle/>
+          <a:p>
+            <a:pPr algn="ctr"/>
+            <a:endParaRPr lang="en-US" dirty="0"/>
+          </a:p>
+        </p:txBody>
+      </p:sp>
+      <p:sp>
+        <p:nvSpPr>
+          <p:cNvPr id="89" name="Rectangle 88">
+            <a:extLst>
+              <a:ext uri="{FF2B5EF4-FFF2-40B4-BE49-F238E27FC236}">
+                <a16:creationId xmlns:a16="http://schemas.microsoft.com/office/drawing/2014/main" id="{4B59DF2A-17E3-D8FE-6F19-396DA70F9ACC}"/>
+              </a:ext>
+            </a:extLst>
+          </p:cNvPr>
+          <p:cNvSpPr>
+            <a:spLocks noChangeAspect="1"/>
+          </p:cNvSpPr>
+          <p:nvPr/>
+        </p:nvSpPr>
+        <p:spPr>
+          <a:xfrm>
+            <a:off x="9023426" y="2127654"/>
+            <a:ext cx="1224000" cy="1224000"/>
+          </a:xfrm>
+          <a:prstGeom prst="rect">
+            <a:avLst/>
+          </a:prstGeom>
+          <a:solidFill>
+            <a:schemeClr val="bg1"/>
+          </a:solidFill>
+        </p:spPr>
+        <p:style>
+          <a:lnRef idx="2">
+            <a:schemeClr val="accent1">
+              <a:shade val="15000"/>
+            </a:schemeClr>
+          </a:lnRef>
+          <a:fillRef idx="1">
+            <a:schemeClr val="accent1"/>
+          </a:fillRef>
+          <a:effectRef idx="0">
+            <a:schemeClr val="accent1"/>
+          </a:effectRef>
+          <a:fontRef idx="minor">
+            <a:schemeClr val="lt1"/>
+          </a:fontRef>
+        </p:style>
+        <p:txBody>
+          <a:bodyPr rtlCol="0" anchor="ctr"/>
+          <a:lstStyle/>
+          <a:p>
+            <a:pPr algn="ctr"/>
+            <a:endParaRPr lang="en-US" dirty="0"/>
+          </a:p>
+        </p:txBody>
+      </p:sp>
+      <p:sp>
+        <p:nvSpPr>
+          <p:cNvPr id="90" name="Rectangle 89">
+            <a:extLst>
+              <a:ext uri="{FF2B5EF4-FFF2-40B4-BE49-F238E27FC236}">
+                <a16:creationId xmlns:a16="http://schemas.microsoft.com/office/drawing/2014/main" id="{1AA326DB-484B-9336-7AB5-1F162F7E4C1C}"/>
+              </a:ext>
+            </a:extLst>
+          </p:cNvPr>
+          <p:cNvSpPr>
+            <a:spLocks noChangeAspect="1"/>
+          </p:cNvSpPr>
+          <p:nvPr/>
+        </p:nvSpPr>
+        <p:spPr>
+          <a:xfrm>
+            <a:off x="9296921" y="2404776"/>
+            <a:ext cx="1224000" cy="1224000"/>
+          </a:xfrm>
+          <a:prstGeom prst="rect">
+            <a:avLst/>
+          </a:prstGeom>
+          <a:solidFill>
+            <a:schemeClr val="bg1"/>
+          </a:solidFill>
+        </p:spPr>
+        <p:style>
+          <a:lnRef idx="2">
+            <a:schemeClr val="accent1">
+              <a:shade val="15000"/>
+            </a:schemeClr>
+          </a:lnRef>
+          <a:fillRef idx="1">
+            <a:schemeClr val="accent1"/>
+          </a:fillRef>
+          <a:effectRef idx="0">
+            <a:schemeClr val="accent1"/>
+          </a:effectRef>
+          <a:fontRef idx="minor">
+            <a:schemeClr val="lt1"/>
+          </a:fontRef>
+        </p:style>
+        <p:txBody>
+          <a:bodyPr rtlCol="0" anchor="ctr"/>
+          <a:lstStyle/>
+          <a:p>
+            <a:pPr algn="ctr"/>
+            <a:endParaRPr lang="en-US" dirty="0"/>
+          </a:p>
+        </p:txBody>
+      </p:sp>
+      <p:sp>
+        <p:nvSpPr>
+          <p:cNvPr id="91" name="Rectangle 90">
+            <a:extLst>
+              <a:ext uri="{FF2B5EF4-FFF2-40B4-BE49-F238E27FC236}">
+                <a16:creationId xmlns:a16="http://schemas.microsoft.com/office/drawing/2014/main" id="{9BD26823-E7B6-014A-1E74-8E58A1FCC879}"/>
+              </a:ext>
+            </a:extLst>
+          </p:cNvPr>
+          <p:cNvSpPr>
+            <a:spLocks noChangeAspect="1"/>
+          </p:cNvSpPr>
+          <p:nvPr/>
+        </p:nvSpPr>
+        <p:spPr>
+          <a:xfrm>
+            <a:off x="9570416" y="2681898"/>
+            <a:ext cx="1224000" cy="1224000"/>
+          </a:xfrm>
+          <a:prstGeom prst="rect">
+            <a:avLst/>
+          </a:prstGeom>
+          <a:solidFill>
+            <a:schemeClr val="bg1"/>
+          </a:solidFill>
+        </p:spPr>
+        <p:style>
+          <a:lnRef idx="2">
+            <a:schemeClr val="accent1">
+              <a:shade val="15000"/>
+            </a:schemeClr>
+          </a:lnRef>
+          <a:fillRef idx="1">
+            <a:schemeClr val="accent1"/>
+          </a:fillRef>
+          <a:effectRef idx="0">
+            <a:schemeClr val="accent1"/>
+          </a:effectRef>
+          <a:fontRef idx="minor">
+            <a:schemeClr val="lt1"/>
+          </a:fontRef>
+        </p:style>
+        <p:txBody>
+          <a:bodyPr rtlCol="0" anchor="ctr"/>
+          <a:lstStyle/>
+          <a:p>
+            <a:pPr algn="ctr"/>
+            <a:endParaRPr lang="en-US" dirty="0"/>
+          </a:p>
+        </p:txBody>
+      </p:sp>
+      <p:sp>
+        <p:nvSpPr>
+          <p:cNvPr id="92" name="TextBox 91">
+            <a:extLst>
+              <a:ext uri="{FF2B5EF4-FFF2-40B4-BE49-F238E27FC236}">
+                <a16:creationId xmlns:a16="http://schemas.microsoft.com/office/drawing/2014/main" id="{EABC0AC3-8310-A715-C778-4F0E03944C29}"/>
+              </a:ext>
+            </a:extLst>
+          </p:cNvPr>
+          <p:cNvSpPr txBox="1"/>
+          <p:nvPr/>
+        </p:nvSpPr>
+        <p:spPr>
+          <a:xfrm>
+            <a:off x="6423782" y="713773"/>
+            <a:ext cx="891206" cy="646331"/>
+          </a:xfrm>
+          <a:prstGeom prst="rect">
+            <a:avLst/>
+          </a:prstGeom>
+          <a:noFill/>
+        </p:spPr>
+        <p:txBody>
+          <a:bodyPr wrap="none" rtlCol="0">
+            <a:spAutoFit/>
+          </a:bodyPr>
+          <a:lstStyle/>
+          <a:p>
+            <a:pPr algn="l"/>
+            <a:r>
+              <a:rPr lang="en-US" dirty="0">
+                <a:latin typeface="Helvetica Neue Light" panose="02000403000000020004" pitchFamily="2" charset="0"/>
+                <a:ea typeface="Helvetica Neue Light" panose="02000403000000020004" pitchFamily="2" charset="0"/>
+                <a:cs typeface="Helvetica Neue" panose="02000503000000020004" pitchFamily="2" charset="0"/>
+              </a:rPr>
+              <a:t>Tutorial</a:t>
+            </a:r>
+          </a:p>
+          <a:p>
+            <a:pPr algn="l"/>
+            <a:r>
+              <a:rPr lang="en-US" dirty="0">
+                <a:latin typeface="Helvetica Neue Light" panose="02000403000000020004" pitchFamily="2" charset="0"/>
+                <a:ea typeface="Helvetica Neue Light" panose="02000403000000020004" pitchFamily="2" charset="0"/>
+                <a:cs typeface="Helvetica Neue" panose="02000503000000020004" pitchFamily="2" charset="0"/>
+              </a:rPr>
+              <a:t>round</a:t>
+            </a:r>
+          </a:p>
+        </p:txBody>
+      </p:sp>
+      <p:sp>
+        <p:nvSpPr>
+          <p:cNvPr id="93" name="TextBox 92">
+            <a:extLst>
+              <a:ext uri="{FF2B5EF4-FFF2-40B4-BE49-F238E27FC236}">
+                <a16:creationId xmlns:a16="http://schemas.microsoft.com/office/drawing/2014/main" id="{BF0C212D-B1CA-9C05-1E93-A8DC85C0EED7}"/>
+              </a:ext>
+            </a:extLst>
+          </p:cNvPr>
+          <p:cNvSpPr txBox="1"/>
+          <p:nvPr/>
+        </p:nvSpPr>
+        <p:spPr>
+          <a:xfrm>
+            <a:off x="6423782" y="1772136"/>
+            <a:ext cx="1147464" cy="646331"/>
+          </a:xfrm>
+          <a:prstGeom prst="rect">
+            <a:avLst/>
+          </a:prstGeom>
+          <a:noFill/>
+        </p:spPr>
+        <p:txBody>
+          <a:bodyPr wrap="square" rtlCol="0">
+            <a:spAutoFit/>
+          </a:bodyPr>
+          <a:lstStyle/>
+          <a:p>
+            <a:pPr algn="l"/>
+            <a:r>
+              <a:rPr lang="en-US" dirty="0">
+                <a:latin typeface="Helvetica Neue Light" panose="02000403000000020004" pitchFamily="2" charset="0"/>
+                <a:ea typeface="Helvetica Neue Light" panose="02000403000000020004" pitchFamily="2" charset="0"/>
+                <a:cs typeface="Helvetica Neue" panose="02000503000000020004" pitchFamily="2" charset="0"/>
+              </a:rPr>
+              <a:t>8 rounds of search</a:t>
+            </a:r>
+          </a:p>
+        </p:txBody>
+      </p:sp>
+      <p:cxnSp>
+        <p:nvCxnSpPr>
+          <p:cNvPr id="94" name="Straight Arrow Connector 93">
+            <a:extLst>
+              <a:ext uri="{FF2B5EF4-FFF2-40B4-BE49-F238E27FC236}">
+                <a16:creationId xmlns:a16="http://schemas.microsoft.com/office/drawing/2014/main" id="{D6599B80-426B-A0F3-7485-8C7DB01EDB89}"/>
+              </a:ext>
+            </a:extLst>
+          </p:cNvPr>
+          <p:cNvCxnSpPr>
+            <a:cxnSpLocks/>
+          </p:cNvCxnSpPr>
+          <p:nvPr/>
+        </p:nvCxnSpPr>
+        <p:spPr>
+          <a:xfrm>
+            <a:off x="9557902" y="628800"/>
+            <a:ext cx="2416777" cy="2777280"/>
+          </a:xfrm>
+          <a:prstGeom prst="straightConnector1">
+            <a:avLst/>
+          </a:prstGeom>
+          <a:ln w="34925">
+            <a:solidFill>
+              <a:schemeClr val="tx1"/>
+            </a:solidFill>
+            <a:tailEnd type="triangle" w="lg" len="lg"/>
+          </a:ln>
+        </p:spPr>
+        <p:style>
+          <a:lnRef idx="2">
+            <a:schemeClr val="accent1"/>
+          </a:lnRef>
+          <a:fillRef idx="0">
+            <a:schemeClr val="accent1"/>
+          </a:fillRef>
+          <a:effectRef idx="1">
+            <a:schemeClr val="accent1"/>
+          </a:effectRef>
+          <a:fontRef idx="minor">
+            <a:schemeClr val="tx1"/>
+          </a:fontRef>
+        </p:style>
+      </p:cxnSp>
+      <p:sp>
+        <p:nvSpPr>
+          <p:cNvPr id="95" name="TextBox 94">
+            <a:extLst>
+              <a:ext uri="{FF2B5EF4-FFF2-40B4-BE49-F238E27FC236}">
+                <a16:creationId xmlns:a16="http://schemas.microsoft.com/office/drawing/2014/main" id="{A29B566C-CFDD-1622-1795-67694B6ED4C3}"/>
+              </a:ext>
+            </a:extLst>
+          </p:cNvPr>
+          <p:cNvSpPr txBox="1"/>
+          <p:nvPr/>
+        </p:nvSpPr>
+        <p:spPr>
+          <a:xfrm rot="2940000">
+            <a:off x="10253457" y="1580231"/>
+            <a:ext cx="1310029" cy="400110"/>
+          </a:xfrm>
+          <a:prstGeom prst="rect">
+            <a:avLst/>
+          </a:prstGeom>
+          <a:noFill/>
+        </p:spPr>
+        <p:txBody>
+          <a:bodyPr wrap="square" rtlCol="0">
+            <a:spAutoFit/>
+          </a:bodyPr>
+          <a:lstStyle/>
+          <a:p>
+            <a:pPr algn="ctr"/>
+            <a:r>
+              <a:rPr lang="en-US" sz="2000" dirty="0">
+                <a:latin typeface="Helvetica Neue Light" panose="02000403000000020004" pitchFamily="2" charset="0"/>
+                <a:ea typeface="Helvetica Neue Light" panose="02000403000000020004" pitchFamily="2" charset="0"/>
+                <a:cs typeface="Helvetica Neue" panose="02000503000000020004" pitchFamily="2" charset="0"/>
+              </a:rPr>
+              <a:t>Time</a:t>
+            </a:r>
+          </a:p>
+        </p:txBody>
+      </p:sp>
+      <p:sp>
+        <p:nvSpPr>
+          <p:cNvPr id="96" name="TextBox 95">
+            <a:extLst>
+              <a:ext uri="{FF2B5EF4-FFF2-40B4-BE49-F238E27FC236}">
+                <a16:creationId xmlns:a16="http://schemas.microsoft.com/office/drawing/2014/main" id="{A513DA09-3348-1B07-80B5-904562F88DEA}"/>
+              </a:ext>
+            </a:extLst>
+          </p:cNvPr>
+          <p:cNvSpPr txBox="1"/>
+          <p:nvPr/>
+        </p:nvSpPr>
+        <p:spPr>
+          <a:xfrm>
+            <a:off x="6423782" y="2600339"/>
+            <a:ext cx="1764776" cy="646331"/>
+          </a:xfrm>
+          <a:prstGeom prst="rect">
+            <a:avLst/>
+          </a:prstGeom>
+          <a:noFill/>
+        </p:spPr>
+        <p:txBody>
+          <a:bodyPr wrap="square" rtlCol="0">
+            <a:spAutoFit/>
+          </a:bodyPr>
+          <a:lstStyle/>
+          <a:p>
+            <a:pPr algn="l"/>
+            <a:r>
+              <a:rPr lang="en-US" dirty="0">
+                <a:latin typeface="Helvetica Neue Light" panose="02000403000000020004" pitchFamily="2" charset="0"/>
+                <a:ea typeface="Helvetica Neue Light" panose="02000403000000020004" pitchFamily="2" charset="0"/>
+                <a:cs typeface="Helvetica Neue" panose="02000503000000020004" pitchFamily="2" charset="0"/>
+              </a:rPr>
+              <a:t>25 clicks in each round</a:t>
+            </a:r>
+          </a:p>
+        </p:txBody>
+      </p:sp>
+      <p:grpSp>
+        <p:nvGrpSpPr>
+          <p:cNvPr id="97" name="Group 96">
+            <a:extLst>
+              <a:ext uri="{FF2B5EF4-FFF2-40B4-BE49-F238E27FC236}">
+                <a16:creationId xmlns:a16="http://schemas.microsoft.com/office/drawing/2014/main" id="{1E46F21B-AC37-163A-519D-693EB811CDAB}"/>
+              </a:ext>
+            </a:extLst>
+          </p:cNvPr>
+          <p:cNvGrpSpPr/>
+          <p:nvPr/>
+        </p:nvGrpSpPr>
+        <p:grpSpPr>
+          <a:xfrm>
+            <a:off x="9941459" y="3031634"/>
+            <a:ext cx="1224000" cy="1224000"/>
+            <a:chOff x="15216601" y="25659727"/>
+            <a:chExt cx="1224000" cy="1224000"/>
+          </a:xfrm>
+        </p:grpSpPr>
+        <p:sp>
+          <p:nvSpPr>
+            <p:cNvPr id="98" name="Rectangle 97">
+              <a:extLst>
+                <a:ext uri="{FF2B5EF4-FFF2-40B4-BE49-F238E27FC236}">
+                  <a16:creationId xmlns:a16="http://schemas.microsoft.com/office/drawing/2014/main" id="{508EFB50-DBCD-6A46-D820-4E653EABEC94}"/>
+                </a:ext>
+              </a:extLst>
+            </p:cNvPr>
+            <p:cNvSpPr>
+              <a:spLocks noChangeAspect="1"/>
+            </p:cNvSpPr>
+            <p:nvPr/>
+          </p:nvSpPr>
+          <p:spPr>
+            <a:xfrm>
+              <a:off x="15216601" y="25659727"/>
+              <a:ext cx="1224000" cy="1224000"/>
+            </a:xfrm>
+            <a:prstGeom prst="rect">
+              <a:avLst/>
+            </a:prstGeom>
+            <a:solidFill>
+              <a:schemeClr val="bg1"/>
+            </a:solidFill>
+          </p:spPr>
+          <p:style>
+            <a:lnRef idx="2">
+              <a:schemeClr val="accent1">
+                <a:shade val="15000"/>
+              </a:schemeClr>
+            </a:lnRef>
+            <a:fillRef idx="1">
+              <a:schemeClr val="accent1"/>
+            </a:fillRef>
+            <a:effectRef idx="0">
+              <a:schemeClr val="accent1"/>
+            </a:effectRef>
+            <a:fontRef idx="minor">
+              <a:schemeClr val="lt1"/>
+            </a:fontRef>
+          </p:style>
+          <p:txBody>
+            <a:bodyPr rtlCol="0" anchor="ctr"/>
+            <a:lstStyle/>
+            <a:p>
+              <a:pPr algn="ctr"/>
+              <a:endParaRPr lang="en-US" dirty="0"/>
+            </a:p>
+          </p:txBody>
+        </p:sp>
+        <p:pic>
+          <p:nvPicPr>
+            <p:cNvPr id="99" name="Picture 98">
+              <a:extLst>
+                <a:ext uri="{FF2B5EF4-FFF2-40B4-BE49-F238E27FC236}">
+                  <a16:creationId xmlns:a16="http://schemas.microsoft.com/office/drawing/2014/main" id="{0D2B5421-32C4-01C5-7688-8A302D1F1A4B}"/>
+                </a:ext>
+              </a:extLst>
+            </p:cNvPr>
+            <p:cNvPicPr>
+              <a:picLocks noChangeAspect="1"/>
+            </p:cNvPicPr>
+            <p:nvPr/>
+          </p:nvPicPr>
+          <p:blipFill>
             <a:blip r:embed="rId4"/>
             <a:srcRect l="738"/>
             <a:stretch>
@@ -4622,7 +6533,7 @@
           <p:cNvPr id="100" name="TextBox 99">
             <a:extLst>
               <a:ext uri="{FF2B5EF4-FFF2-40B4-BE49-F238E27FC236}">
-                <a16:creationId xmlns:a16="http://schemas.microsoft.com/office/drawing/2014/main" id="{99FB87C8-70F5-A168-2F03-1FB715C6666F}"/>
+                <a16:creationId xmlns:a16="http://schemas.microsoft.com/office/drawing/2014/main" id="{F5A12F0B-620A-F36A-6662-CAD619AB924D}"/>
               </a:ext>
             </a:extLst>
           </p:cNvPr>
@@ -4662,7 +6573,7 @@
           <p:cNvPr id="29" name="Picture 28">
             <a:extLst>
               <a:ext uri="{FF2B5EF4-FFF2-40B4-BE49-F238E27FC236}">
-                <a16:creationId xmlns:a16="http://schemas.microsoft.com/office/drawing/2014/main" id="{52DFD066-56C8-F401-9824-E63A66FD8DE3}"/>
+                <a16:creationId xmlns:a16="http://schemas.microsoft.com/office/drawing/2014/main" id="{D04F9189-D8D9-7CA1-668C-FF08ADE80F08}"/>
               </a:ext>
             </a:extLst>
           </p:cNvPr>
@@ -4692,7 +6603,7 @@
           <p:cNvPr id="30" name="Picture 29">
             <a:extLst>
               <a:ext uri="{FF2B5EF4-FFF2-40B4-BE49-F238E27FC236}">
-                <a16:creationId xmlns:a16="http://schemas.microsoft.com/office/drawing/2014/main" id="{E05433B0-B7BA-7A98-207D-239BBB94A262}"/>
+                <a16:creationId xmlns:a16="http://schemas.microsoft.com/office/drawing/2014/main" id="{E50B1C58-D811-C2AD-659D-05B6E192F4DB}"/>
               </a:ext>
             </a:extLst>
           </p:cNvPr>
@@ -4722,7 +6633,7 @@
           <p:cNvPr id="31" name="Picture 30">
             <a:extLst>
               <a:ext uri="{FF2B5EF4-FFF2-40B4-BE49-F238E27FC236}">
-                <a16:creationId xmlns:a16="http://schemas.microsoft.com/office/drawing/2014/main" id="{9BCA3DFD-A3F1-CF71-7602-76C4E6EA2C3E}"/>
+                <a16:creationId xmlns:a16="http://schemas.microsoft.com/office/drawing/2014/main" id="{AE7E5C22-94B9-E91F-382C-69256ED23C8E}"/>
               </a:ext>
             </a:extLst>
           </p:cNvPr>
@@ -4752,7 +6663,7 @@
           <p:cNvPr id="32" name="Picture 31">
             <a:extLst>
               <a:ext uri="{FF2B5EF4-FFF2-40B4-BE49-F238E27FC236}">
-                <a16:creationId xmlns:a16="http://schemas.microsoft.com/office/drawing/2014/main" id="{83AFEAE7-44F2-8648-F279-9487F0178620}"/>
+                <a16:creationId xmlns:a16="http://schemas.microsoft.com/office/drawing/2014/main" id="{C45C7F36-EF82-ABB8-7480-21C1C9B0B2A5}"/>
               </a:ext>
             </a:extLst>
           </p:cNvPr>
@@ -4782,7 +6693,7 @@
           <p:cNvPr id="33" name="Picture 32">
             <a:extLst>
               <a:ext uri="{FF2B5EF4-FFF2-40B4-BE49-F238E27FC236}">
-                <a16:creationId xmlns:a16="http://schemas.microsoft.com/office/drawing/2014/main" id="{0546CB74-262E-BA4F-B904-F814BF6D7321}"/>
+                <a16:creationId xmlns:a16="http://schemas.microsoft.com/office/drawing/2014/main" id="{1E58CC9C-4A55-0725-9972-FDBB454D4B25}"/>
               </a:ext>
             </a:extLst>
           </p:cNvPr>
@@ -4812,7 +6723,7 @@
           <p:cNvPr id="34" name="Picture 33">
             <a:extLst>
               <a:ext uri="{FF2B5EF4-FFF2-40B4-BE49-F238E27FC236}">
-                <a16:creationId xmlns:a16="http://schemas.microsoft.com/office/drawing/2014/main" id="{386DA79D-F596-D613-92F7-3C0158E99893}"/>
+                <a16:creationId xmlns:a16="http://schemas.microsoft.com/office/drawing/2014/main" id="{24F0CB9B-24F9-BAF4-28DA-CEB26753FD2C}"/>
               </a:ext>
             </a:extLst>
           </p:cNvPr>
@@ -4842,7 +6753,7 @@
           <p:cNvPr id="35" name="Picture 34">
             <a:extLst>
               <a:ext uri="{FF2B5EF4-FFF2-40B4-BE49-F238E27FC236}">
-                <a16:creationId xmlns:a16="http://schemas.microsoft.com/office/drawing/2014/main" id="{2E10C79D-1D6D-4A73-621F-8BA18273367D}"/>
+                <a16:creationId xmlns:a16="http://schemas.microsoft.com/office/drawing/2014/main" id="{953C95ED-4DB4-9CC9-4AC7-E338FABCC475}"/>
               </a:ext>
             </a:extLst>
           </p:cNvPr>
@@ -4872,7 +6783,7 @@
           <p:cNvPr id="36" name="Picture 35">
             <a:extLst>
               <a:ext uri="{FF2B5EF4-FFF2-40B4-BE49-F238E27FC236}">
-                <a16:creationId xmlns:a16="http://schemas.microsoft.com/office/drawing/2014/main" id="{E0B13C66-5342-D09E-7AAC-82520DC8C39D}"/>
+                <a16:creationId xmlns:a16="http://schemas.microsoft.com/office/drawing/2014/main" id="{D8D2F1F4-4485-0DBA-EA5D-EED832960699}"/>
               </a:ext>
             </a:extLst>
           </p:cNvPr>
@@ -4902,7 +6813,7 @@
           <p:cNvPr id="37" name="Picture 36">
             <a:extLst>
               <a:ext uri="{FF2B5EF4-FFF2-40B4-BE49-F238E27FC236}">
-                <a16:creationId xmlns:a16="http://schemas.microsoft.com/office/drawing/2014/main" id="{AAB0F67F-0AF4-2945-014F-CD1A32645447}"/>
+                <a16:creationId xmlns:a16="http://schemas.microsoft.com/office/drawing/2014/main" id="{5BB1AE8F-4577-344D-DB18-137861879046}"/>
               </a:ext>
             </a:extLst>
           </p:cNvPr>
@@ -4932,7 +6843,7 @@
           <p:cNvPr id="38" name="TextBox 37">
             <a:extLst>
               <a:ext uri="{FF2B5EF4-FFF2-40B4-BE49-F238E27FC236}">
-                <a16:creationId xmlns:a16="http://schemas.microsoft.com/office/drawing/2014/main" id="{448CD114-3C19-C02E-BA6B-DD5CD0D288FC}"/>
+                <a16:creationId xmlns:a16="http://schemas.microsoft.com/office/drawing/2014/main" id="{2FBCCE90-A9BB-7401-4668-B3324C1D13F2}"/>
               </a:ext>
             </a:extLst>
           </p:cNvPr>
@@ -4970,7 +6881,7 @@
           <p:cNvPr id="39" name="TextBox 38">
             <a:extLst>
               <a:ext uri="{FF2B5EF4-FFF2-40B4-BE49-F238E27FC236}">
-                <a16:creationId xmlns:a16="http://schemas.microsoft.com/office/drawing/2014/main" id="{70AEBB63-8371-464C-88DF-09CD8F6461BB}"/>
+                <a16:creationId xmlns:a16="http://schemas.microsoft.com/office/drawing/2014/main" id="{F1223CE9-D81E-F1B1-CE8B-59A159190B76}"/>
               </a:ext>
             </a:extLst>
           </p:cNvPr>
@@ -5008,7 +6919,7 @@
           <p:cNvPr id="40" name="TextBox 39">
             <a:extLst>
               <a:ext uri="{FF2B5EF4-FFF2-40B4-BE49-F238E27FC236}">
-                <a16:creationId xmlns:a16="http://schemas.microsoft.com/office/drawing/2014/main" id="{A9ADF8AA-678C-83A0-EAC3-BD2B4D45577A}"/>
+                <a16:creationId xmlns:a16="http://schemas.microsoft.com/office/drawing/2014/main" id="{1474E3C1-E749-5111-2E0E-DBBF406BF03D}"/>
               </a:ext>
             </a:extLst>
           </p:cNvPr>
@@ -5046,7 +6957,7 @@
           <p:cNvPr id="41" name="TextBox 40">
             <a:extLst>
               <a:ext uri="{FF2B5EF4-FFF2-40B4-BE49-F238E27FC236}">
-                <a16:creationId xmlns:a16="http://schemas.microsoft.com/office/drawing/2014/main" id="{61D13226-896A-A190-5957-A0CBFA31C357}"/>
+                <a16:creationId xmlns:a16="http://schemas.microsoft.com/office/drawing/2014/main" id="{6629C765-2A12-94D1-ED4C-7417AD69D3B2}"/>
               </a:ext>
             </a:extLst>
           </p:cNvPr>
@@ -5084,7 +6995,7 @@
           <p:cNvPr id="42" name="TextBox 41">
             <a:extLst>
               <a:ext uri="{FF2B5EF4-FFF2-40B4-BE49-F238E27FC236}">
-                <a16:creationId xmlns:a16="http://schemas.microsoft.com/office/drawing/2014/main" id="{760CF696-3888-E86C-81FD-F695DFE89A32}"/>
+                <a16:creationId xmlns:a16="http://schemas.microsoft.com/office/drawing/2014/main" id="{F48859F4-8611-795E-7709-C1D24AA138CA}"/>
               </a:ext>
             </a:extLst>
           </p:cNvPr>
@@ -5122,7 +7033,7 @@
           <p:cNvPr id="43" name="TextBox 42">
             <a:extLst>
               <a:ext uri="{FF2B5EF4-FFF2-40B4-BE49-F238E27FC236}">
-                <a16:creationId xmlns:a16="http://schemas.microsoft.com/office/drawing/2014/main" id="{DDA2092D-2AD1-1ABE-62A0-837A0E74BDFA}"/>
+                <a16:creationId xmlns:a16="http://schemas.microsoft.com/office/drawing/2014/main" id="{A0DDCE82-1650-89F6-2B47-75845C09AA7B}"/>
               </a:ext>
             </a:extLst>
           </p:cNvPr>
@@ -5160,7 +7071,7 @@
           <p:cNvPr id="44" name="TextBox 43">
             <a:extLst>
               <a:ext uri="{FF2B5EF4-FFF2-40B4-BE49-F238E27FC236}">
-                <a16:creationId xmlns:a16="http://schemas.microsoft.com/office/drawing/2014/main" id="{F323E07B-5A06-F267-8220-0390F1D57091}"/>
+                <a16:creationId xmlns:a16="http://schemas.microsoft.com/office/drawing/2014/main" id="{2E5A51FD-C9DE-2547-472D-9EBF87BB4B15}"/>
               </a:ext>
             </a:extLst>
           </p:cNvPr>
@@ -5198,7 +7109,7 @@
           <p:cNvPr id="45" name="TextBox 44">
             <a:extLst>
               <a:ext uri="{FF2B5EF4-FFF2-40B4-BE49-F238E27FC236}">
-                <a16:creationId xmlns:a16="http://schemas.microsoft.com/office/drawing/2014/main" id="{98F2BC21-1865-99FF-0648-5627C4C27389}"/>
+                <a16:creationId xmlns:a16="http://schemas.microsoft.com/office/drawing/2014/main" id="{4054FDCD-F545-0EB2-21E2-318891CE2A72}"/>
               </a:ext>
             </a:extLst>
           </p:cNvPr>
@@ -5236,7 +7147,7 @@
           <p:cNvPr id="46" name="TextBox 45">
             <a:extLst>
               <a:ext uri="{FF2B5EF4-FFF2-40B4-BE49-F238E27FC236}">
-                <a16:creationId xmlns:a16="http://schemas.microsoft.com/office/drawing/2014/main" id="{9F58EAA9-DAFB-098A-5368-C11F71E605C2}"/>
+                <a16:creationId xmlns:a16="http://schemas.microsoft.com/office/drawing/2014/main" id="{2B29BCB3-E9D0-A1EF-055D-EE91328AA71F}"/>
               </a:ext>
             </a:extLst>
           </p:cNvPr>
@@ -5274,7 +7185,7 @@
           <p:cNvPr id="47" name="TextBox 46">
             <a:extLst>
               <a:ext uri="{FF2B5EF4-FFF2-40B4-BE49-F238E27FC236}">
-                <a16:creationId xmlns:a16="http://schemas.microsoft.com/office/drawing/2014/main" id="{7C3862DE-1F5F-3CB4-07A4-A2A0AC47CD6A}"/>
+                <a16:creationId xmlns:a16="http://schemas.microsoft.com/office/drawing/2014/main" id="{49F770AC-FFAF-1010-771C-FCBEE5F8EEBF}"/>
               </a:ext>
             </a:extLst>
           </p:cNvPr>
@@ -5312,7 +7223,7 @@
           <p:cNvPr id="48" name="TextBox 47">
             <a:extLst>
               <a:ext uri="{FF2B5EF4-FFF2-40B4-BE49-F238E27FC236}">
-                <a16:creationId xmlns:a16="http://schemas.microsoft.com/office/drawing/2014/main" id="{CF59F1C9-120F-B885-8620-D6B2621134D8}"/>
+                <a16:creationId xmlns:a16="http://schemas.microsoft.com/office/drawing/2014/main" id="{F0DADCAE-2D50-4209-4967-2E585AA2EDED}"/>
               </a:ext>
             </a:extLst>
           </p:cNvPr>
@@ -5350,7 +7261,7 @@
           <p:cNvPr id="49" name="TextBox 48">
             <a:extLst>
               <a:ext uri="{FF2B5EF4-FFF2-40B4-BE49-F238E27FC236}">
-                <a16:creationId xmlns:a16="http://schemas.microsoft.com/office/drawing/2014/main" id="{9B8966E5-28BF-258F-CA2E-93BA17BD83D8}"/>
+                <a16:creationId xmlns:a16="http://schemas.microsoft.com/office/drawing/2014/main" id="{AE5ACFD2-2268-1349-28FA-23888DA21A72}"/>
               </a:ext>
             </a:extLst>
           </p:cNvPr>
@@ -5388,7 +7299,7 @@
           <p:cNvPr id="50" name="TextBox 49">
             <a:extLst>
               <a:ext uri="{FF2B5EF4-FFF2-40B4-BE49-F238E27FC236}">
-                <a16:creationId xmlns:a16="http://schemas.microsoft.com/office/drawing/2014/main" id="{76AA6E67-C047-6B9E-034C-90BA401825AA}"/>
+                <a16:creationId xmlns:a16="http://schemas.microsoft.com/office/drawing/2014/main" id="{3AE2EEF6-F04C-45E2-05C7-1B5C8715E2E9}"/>
               </a:ext>
             </a:extLst>
           </p:cNvPr>
@@ -5426,7 +7337,7 @@
           <p:cNvPr id="51" name="TextBox 50">
             <a:extLst>
               <a:ext uri="{FF2B5EF4-FFF2-40B4-BE49-F238E27FC236}">
-                <a16:creationId xmlns:a16="http://schemas.microsoft.com/office/drawing/2014/main" id="{B14A9CC0-2D13-27CF-CD9C-437FE6EBD294}"/>
+                <a16:creationId xmlns:a16="http://schemas.microsoft.com/office/drawing/2014/main" id="{2E15ED12-E7AD-855C-6D91-671CE316A365}"/>
               </a:ext>
             </a:extLst>
           </p:cNvPr>
@@ -5462,7 +7373,7 @@
     </p:spTree>
     <p:extLst>
       <p:ext uri="{BB962C8B-B14F-4D97-AF65-F5344CB8AC3E}">
-        <p14:creationId xmlns:p14="http://schemas.microsoft.com/office/powerpoint/2010/main" val="34156375"/>
+        <p14:creationId xmlns:p14="http://schemas.microsoft.com/office/powerpoint/2010/main" val="3288632656"/>
       </p:ext>
     </p:extLst>
   </p:cSld>
@@ -5472,7 +7383,7 @@
 </p:sld>
 </file>
 
-<file path=ppt/slides/slide2.xml><?xml version="1.0" encoding="utf-8"?>
+<file path=ppt/slides/slide4.xml><?xml version="1.0" encoding="utf-8"?>
 <p:sld xmlns:a="http://schemas.openxmlformats.org/drawingml/2006/main" xmlns:r="http://schemas.openxmlformats.org/officeDocument/2006/relationships" xmlns:p="http://schemas.openxmlformats.org/presentationml/2006/main">
   <p:cSld>
     <p:spTree>
@@ -6640,6 +8551,41 @@
                 <a:cs typeface="Helvetica Neue" panose="02000503000000020004" pitchFamily="2" charset="0"/>
               </a:rPr>
               <a:t>”Bonus round” with reward predictions</a:t>
+            </a:r>
+          </a:p>
+        </p:txBody>
+      </p:sp>
+      <p:sp>
+        <p:nvSpPr>
+          <p:cNvPr id="3" name="TextBox 2">
+            <a:extLst>
+              <a:ext uri="{FF2B5EF4-FFF2-40B4-BE49-F238E27FC236}">
+                <a16:creationId xmlns:a16="http://schemas.microsoft.com/office/drawing/2014/main" id="{DFD685BF-4FD3-9357-7EEE-941C1AD4203B}"/>
+              </a:ext>
+            </a:extLst>
+          </p:cNvPr>
+          <p:cNvSpPr txBox="1"/>
+          <p:nvPr/>
+        </p:nvSpPr>
+        <p:spPr>
+          <a:xfrm>
+            <a:off x="4050792" y="1961126"/>
+            <a:ext cx="8101584" cy="369332"/>
+          </a:xfrm>
+          <a:prstGeom prst="rect">
+            <a:avLst/>
+          </a:prstGeom>
+          <a:noFill/>
+        </p:spPr>
+        <p:txBody>
+          <a:bodyPr wrap="square">
+            <a:spAutoFit/>
+          </a:bodyPr>
+          <a:lstStyle/>
+          <a:p>
+            <a:r>
+              <a:rPr lang="en-US" dirty="0"/>
+              <a:t>The right panel shows nine example environments.</a:t>
             </a:r>
           </a:p>
         </p:txBody>

</xml_diff>